<commit_message>
Replace information PDFs with interactive HTML lessons
</commit_message>
<xml_diff>
--- a/information-source-decks/02-quadrotor-aerodynamics.pptx
+++ b/information-source-decks/02-quadrotor-aerodynamics.pptx
@@ -2,20 +2,20 @@
 <file path=ppt/presentation.xml><?xml version="1.0" encoding="utf-8"?>
 <p:presentation xmlns:p="http://schemas.openxmlformats.org/presentationml/2006/main">
   <p:sldMasterIdLst>
-    <p:sldMasterId xmlns:r="http://schemas.openxmlformats.org/officeDocument/2006/relationships" id="2147483648" r:id="R0c961b7871e147e9"/>
+    <p:sldMasterId xmlns:r="http://schemas.openxmlformats.org/officeDocument/2006/relationships" id="2147483648" r:id="R3ccd2eed41fb42bd"/>
   </p:sldMasterIdLst>
   <p:notesMasterIdLst>
-    <p:notesMasterId xmlns:r="http://schemas.openxmlformats.org/officeDocument/2006/relationships" r:id="Rfd48c56551ee4e48"/>
+    <p:notesMasterId xmlns:r="http://schemas.openxmlformats.org/officeDocument/2006/relationships" r:id="Rbaf92935ad704639"/>
   </p:notesMasterIdLst>
   <p:sldIdLst>
-    <p:sldId xmlns:r="http://schemas.openxmlformats.org/officeDocument/2006/relationships" id="256" r:id="R41257b1243734548"/>
-    <p:sldId xmlns:r="http://schemas.openxmlformats.org/officeDocument/2006/relationships" id="257" r:id="R72f10f483cc244b0"/>
-    <p:sldId xmlns:r="http://schemas.openxmlformats.org/officeDocument/2006/relationships" id="258" r:id="Rc725012c1bac4deb"/>
-    <p:sldId xmlns:r="http://schemas.openxmlformats.org/officeDocument/2006/relationships" id="259" r:id="R230db3c215cd4535"/>
-    <p:sldId xmlns:r="http://schemas.openxmlformats.org/officeDocument/2006/relationships" id="260" r:id="R98d192487a08434e"/>
-    <p:sldId xmlns:r="http://schemas.openxmlformats.org/officeDocument/2006/relationships" id="261" r:id="R90f8bb6873364dc7"/>
-    <p:sldId xmlns:r="http://schemas.openxmlformats.org/officeDocument/2006/relationships" id="262" r:id="R899c6c792e83493e"/>
-    <p:sldId xmlns:r="http://schemas.openxmlformats.org/officeDocument/2006/relationships" id="263" r:id="Ra619f58388e54d12"/>
+    <p:sldId xmlns:r="http://schemas.openxmlformats.org/officeDocument/2006/relationships" id="256" r:id="R027ddb682fba42f2"/>
+    <p:sldId xmlns:r="http://schemas.openxmlformats.org/officeDocument/2006/relationships" id="257" r:id="R7766f0dcecba48b0"/>
+    <p:sldId xmlns:r="http://schemas.openxmlformats.org/officeDocument/2006/relationships" id="258" r:id="R200773014c904ea5"/>
+    <p:sldId xmlns:r="http://schemas.openxmlformats.org/officeDocument/2006/relationships" id="259" r:id="R271ac85d9db84523"/>
+    <p:sldId xmlns:r="http://schemas.openxmlformats.org/officeDocument/2006/relationships" id="260" r:id="R1f5081a53d07400e"/>
+    <p:sldId xmlns:r="http://schemas.openxmlformats.org/officeDocument/2006/relationships" id="261" r:id="R7dbf48c2af87463a"/>
+    <p:sldId xmlns:r="http://schemas.openxmlformats.org/officeDocument/2006/relationships" id="262" r:id="R5e7e1b00a3c64b62"/>
+    <p:sldId xmlns:r="http://schemas.openxmlformats.org/officeDocument/2006/relationships" id="263" r:id="R238608f4315747c4"/>
   </p:sldIdLst>
   <p:sldSz cx="12192000" cy="6858000"/>
   <p:notesSz cx="6858000" cy="9144000"/>
@@ -1182,7 +1182,7 @@
   </p:cSld>
   <p:clrMap bg1="lt1" tx1="dk1" bg2="lt2" tx2="dk2" accent1="accent1" accent2="accent2" accent3="accent3" accent4="accent4" accent5="accent5" accent6="accent6" hlink="hlink" folHlink="folHlink"/>
   <p:sldLayoutIdLst>
-    <p:sldLayoutId xmlns:r="http://schemas.openxmlformats.org/officeDocument/2006/relationships" id="2147483649" r:id="R5ad4f334cea04ec2"/>
+    <p:sldLayoutId xmlns:r="http://schemas.openxmlformats.org/officeDocument/2006/relationships" id="2147483649" r:id="R97ea299140d24edd"/>
   </p:sldLayoutIdLst>
   <p:txStyles>
     <p:titleStyle>
@@ -1737,7 +1737,7 @@
           <p:nvPr/>
         </p:nvPicPr>
         <p:blipFill>
-          <a:blip xmlns:r="http://schemas.openxmlformats.org/officeDocument/2006/relationships" xmlns:a="http://schemas.openxmlformats.org/drawingml/2006/main" r:embed="Rcc3fd36ed5394a3d"/>
+          <a:blip xmlns:r="http://schemas.openxmlformats.org/officeDocument/2006/relationships" xmlns:a="http://schemas.openxmlformats.org/drawingml/2006/main" r:embed="Ra6037c721fda4e0a"/>
           <a:srcRect xmlns:a="http://schemas.openxmlformats.org/drawingml/2006/main" l="0" t="10411" r="0" b="10411"/>
           <a:stretch xmlns:a="http://schemas.openxmlformats.org/drawingml/2006/main">
             <a:fillRect l="0" t="0" r="0" b="0"/>
@@ -1758,7 +1758,7 @@
           <p:cNvPr id="2" name="">
             <a:extLst xmlns:a="http://schemas.openxmlformats.org/drawingml/2006/main">
               <a:ext uri="{FF2B5EF4-FFF2-40B4-BE49-F238E27FC236}">
-                <a16:creationId xmlns:a16="http://schemas.microsoft.com/office/drawing/2014/main" id="{7C8EA0F7-ED7A-4CAA-8B60-F8420E3B8F2C}"/>
+                <a16:creationId xmlns:a16="http://schemas.microsoft.com/office/drawing/2014/main" id="{7D02008D-FD07-4B25-8E53-AEB04F6D16B3}"/>
               </a:ext>
             </a:extLst>
           </p:cNvPr>
@@ -1786,7 +1786,7 @@
           <p:cNvPr id="3" name="">
             <a:extLst xmlns:a="http://schemas.openxmlformats.org/drawingml/2006/main">
               <a:ext uri="{FF2B5EF4-FFF2-40B4-BE49-F238E27FC236}">
-                <a16:creationId xmlns:a16="http://schemas.microsoft.com/office/drawing/2014/main" id="{3B65ADB9-8370-4698-8E89-E5FA17F29DFA}"/>
+                <a16:creationId xmlns:a16="http://schemas.microsoft.com/office/drawing/2014/main" id="{373620FC-5D89-48E6-B8F2-1CA839D00A4A}"/>
               </a:ext>
             </a:extLst>
           </p:cNvPr>
@@ -1825,7 +1825,7 @@
           <p:nvPr/>
         </p:nvPicPr>
         <p:blipFill>
-          <a:blip xmlns:r="http://schemas.openxmlformats.org/officeDocument/2006/relationships" xmlns:a="http://schemas.openxmlformats.org/drawingml/2006/main" r:embed="Rc6c524c7f2a74ecb"/>
+          <a:blip xmlns:r="http://schemas.openxmlformats.org/officeDocument/2006/relationships" xmlns:a="http://schemas.openxmlformats.org/drawingml/2006/main" r:embed="R6d43829cfc0548bb"/>
           <a:stretch xmlns:a="http://schemas.openxmlformats.org/drawingml/2006/main"/>
         </p:blipFill>
         <p:spPr>
@@ -1843,7 +1843,7 @@
           <p:cNvPr id="5" name="">
             <a:extLst xmlns:a="http://schemas.openxmlformats.org/drawingml/2006/main">
               <a:ext uri="{FF2B5EF4-FFF2-40B4-BE49-F238E27FC236}">
-                <a16:creationId xmlns:a16="http://schemas.microsoft.com/office/drawing/2014/main" id="{4F0CA220-77D5-4B1E-AFD8-8EFEE66622EE}"/>
+                <a16:creationId xmlns:a16="http://schemas.microsoft.com/office/drawing/2014/main" id="{68D47B9D-629D-4A12-A3F6-5EB789F18FA6}"/>
               </a:ext>
             </a:extLst>
           </p:cNvPr>
@@ -1893,7 +1893,7 @@
           <p:cNvPr id="6" name="">
             <a:extLst xmlns:a="http://schemas.openxmlformats.org/drawingml/2006/main">
               <a:ext uri="{FF2B5EF4-FFF2-40B4-BE49-F238E27FC236}">
-                <a16:creationId xmlns:a16="http://schemas.microsoft.com/office/drawing/2014/main" id="{96545E76-01A4-42A3-8344-C5F1EC35FB26}"/>
+                <a16:creationId xmlns:a16="http://schemas.microsoft.com/office/drawing/2014/main" id="{7CCFCD66-2407-4B7E-BD6F-9EA5478E106C}"/>
               </a:ext>
             </a:extLst>
           </p:cNvPr>
@@ -1943,7 +1943,7 @@
           <p:cNvPr id="7" name="">
             <a:extLst xmlns:a="http://schemas.openxmlformats.org/drawingml/2006/main">
               <a:ext uri="{FF2B5EF4-FFF2-40B4-BE49-F238E27FC236}">
-                <a16:creationId xmlns:a16="http://schemas.microsoft.com/office/drawing/2014/main" id="{BAD43BD0-2129-4651-945A-71AE2F094DFC}"/>
+                <a16:creationId xmlns:a16="http://schemas.microsoft.com/office/drawing/2014/main" id="{0695E479-A690-4B7A-A26F-EB47244E10C2}"/>
               </a:ext>
             </a:extLst>
           </p:cNvPr>
@@ -1993,7 +1993,7 @@
           <p:cNvPr id="8" name="">
             <a:extLst xmlns:a="http://schemas.openxmlformats.org/drawingml/2006/main">
               <a:ext uri="{FF2B5EF4-FFF2-40B4-BE49-F238E27FC236}">
-                <a16:creationId xmlns:a16="http://schemas.microsoft.com/office/drawing/2014/main" id="{84CF7F13-D275-4933-BA45-57D56C376168}"/>
+                <a16:creationId xmlns:a16="http://schemas.microsoft.com/office/drawing/2014/main" id="{C71D2A1C-7D79-458E-BCFD-61EDA09C4087}"/>
               </a:ext>
             </a:extLst>
           </p:cNvPr>
@@ -2043,7 +2043,7 @@
           <p:cNvPr id="9" name="">
             <a:extLst xmlns:a="http://schemas.openxmlformats.org/drawingml/2006/main">
               <a:ext uri="{FF2B5EF4-FFF2-40B4-BE49-F238E27FC236}">
-                <a16:creationId xmlns:a16="http://schemas.microsoft.com/office/drawing/2014/main" id="{E2B93CBE-7D5A-45C8-B8D2-B3CBF50F358A}"/>
+                <a16:creationId xmlns:a16="http://schemas.microsoft.com/office/drawing/2014/main" id="{9FBBBB9E-0A03-4D14-A4E9-665350F22729}"/>
               </a:ext>
             </a:extLst>
           </p:cNvPr>
@@ -2099,7 +2099,7 @@
           <p:cNvPr id="10" name="">
             <a:extLst xmlns:a="http://schemas.openxmlformats.org/drawingml/2006/main">
               <a:ext uri="{FF2B5EF4-FFF2-40B4-BE49-F238E27FC236}">
-                <a16:creationId xmlns:a16="http://schemas.microsoft.com/office/drawing/2014/main" id="{82868E2B-F785-4F6E-8283-FC4846FEE74C}"/>
+                <a16:creationId xmlns:a16="http://schemas.microsoft.com/office/drawing/2014/main" id="{6BC2A537-DA57-4A5F-81DF-B4FB833EDEAB}"/>
               </a:ext>
             </a:extLst>
           </p:cNvPr>
@@ -2155,7 +2155,7 @@
           <p:cNvPr id="11" name="">
             <a:extLst xmlns:a="http://schemas.openxmlformats.org/drawingml/2006/main">
               <a:ext uri="{FF2B5EF4-FFF2-40B4-BE49-F238E27FC236}">
-                <a16:creationId xmlns:a16="http://schemas.microsoft.com/office/drawing/2014/main" id="{67336547-A9BC-43D1-858B-1425B75A20E8}"/>
+                <a16:creationId xmlns:a16="http://schemas.microsoft.com/office/drawing/2014/main" id="{5C6B633D-0F7E-43C3-A76C-71F95B767BE3}"/>
               </a:ext>
             </a:extLst>
           </p:cNvPr>
@@ -2211,7 +2211,7 @@
           <p:cNvPr id="12" name="">
             <a:extLst xmlns:a="http://schemas.openxmlformats.org/drawingml/2006/main">
               <a:ext uri="{FF2B5EF4-FFF2-40B4-BE49-F238E27FC236}">
-                <a16:creationId xmlns:a16="http://schemas.microsoft.com/office/drawing/2014/main" id="{051F8F0F-C16D-4E45-8BA8-2D5C08A874E6}"/>
+                <a16:creationId xmlns:a16="http://schemas.microsoft.com/office/drawing/2014/main" id="{1DA6445C-B1D8-42A5-AFA3-BAD27ADF5CDE}"/>
               </a:ext>
             </a:extLst>
           </p:cNvPr>
@@ -2244,7 +2244,7 @@
           <p:cNvPr id="13" name="">
             <a:extLst xmlns:a="http://schemas.openxmlformats.org/drawingml/2006/main">
               <a:ext uri="{FF2B5EF4-FFF2-40B4-BE49-F238E27FC236}">
-                <a16:creationId xmlns:a16="http://schemas.microsoft.com/office/drawing/2014/main" id="{9934B663-5421-43E3-B349-C95D6404F242}"/>
+                <a16:creationId xmlns:a16="http://schemas.microsoft.com/office/drawing/2014/main" id="{CCF6BB55-E630-4458-8761-CB556348C107}"/>
               </a:ext>
             </a:extLst>
           </p:cNvPr>
@@ -2292,7 +2292,7 @@
     </p:spTree>
     <p:extLst>
       <p:ext uri="{BB962C8B-B14F-4D97-AF65-F5344CB8AC3E}">
-        <p14:creationId xmlns:p14="http://schemas.microsoft.com/office/powerpoint/2010/main" val="1495644764"/>
+        <p14:creationId xmlns:p14="http://schemas.microsoft.com/office/powerpoint/2010/main" val="1286419036"/>
       </p:ext>
     </p:extLst>
   </p:cSld>
@@ -2323,7 +2323,7 @@
           <p:cNvPr id="48" name="">
             <a:extLst xmlns:a="http://schemas.openxmlformats.org/drawingml/2006/main">
               <a:ext uri="{FF2B5EF4-FFF2-40B4-BE49-F238E27FC236}">
-                <a16:creationId xmlns:a16="http://schemas.microsoft.com/office/drawing/2014/main" id="{B47B7E0D-CA55-474A-96B2-C172B128C523}"/>
+                <a16:creationId xmlns:a16="http://schemas.microsoft.com/office/drawing/2014/main" id="{F458DE27-6034-4813-AC9E-9F14C1A67034}"/>
               </a:ext>
             </a:extLst>
           </p:cNvPr>
@@ -2356,7 +2356,7 @@
           <p:cNvPr id="2" name="">
             <a:extLst xmlns:a="http://schemas.openxmlformats.org/drawingml/2006/main">
               <a:ext uri="{FF2B5EF4-FFF2-40B4-BE49-F238E27FC236}">
-                <a16:creationId xmlns:a16="http://schemas.microsoft.com/office/drawing/2014/main" id="{5D0AA342-C846-4E3C-B804-E956C4F49F18}"/>
+                <a16:creationId xmlns:a16="http://schemas.microsoft.com/office/drawing/2014/main" id="{534928DA-C598-4309-A4AF-5C5C370C0A74}"/>
               </a:ext>
             </a:extLst>
           </p:cNvPr>
@@ -2389,7 +2389,7 @@
           <p:cNvPr id="3" name="">
             <a:extLst xmlns:a="http://schemas.openxmlformats.org/drawingml/2006/main">
               <a:ext uri="{FF2B5EF4-FFF2-40B4-BE49-F238E27FC236}">
-                <a16:creationId xmlns:a16="http://schemas.microsoft.com/office/drawing/2014/main" id="{66CD2339-6E3B-41C6-84AF-4FE3B17FE16C}"/>
+                <a16:creationId xmlns:a16="http://schemas.microsoft.com/office/drawing/2014/main" id="{B7D2B1F9-1195-4F26-863E-6EC85E3940FD}"/>
               </a:ext>
             </a:extLst>
           </p:cNvPr>
@@ -2439,7 +2439,7 @@
           <p:cNvPr id="4" name="">
             <a:extLst xmlns:a="http://schemas.openxmlformats.org/drawingml/2006/main">
               <a:ext uri="{FF2B5EF4-FFF2-40B4-BE49-F238E27FC236}">
-                <a16:creationId xmlns:a16="http://schemas.microsoft.com/office/drawing/2014/main" id="{B05000DC-CDF7-4BC3-86CB-8574273AF2F7}"/>
+                <a16:creationId xmlns:a16="http://schemas.microsoft.com/office/drawing/2014/main" id="{ACBE7329-7DFB-4B20-89A0-92B300BD410C}"/>
               </a:ext>
             </a:extLst>
           </p:cNvPr>
@@ -2489,7 +2489,7 @@
           <p:cNvPr id="5" name="">
             <a:extLst xmlns:a="http://schemas.openxmlformats.org/drawingml/2006/main">
               <a:ext uri="{FF2B5EF4-FFF2-40B4-BE49-F238E27FC236}">
-                <a16:creationId xmlns:a16="http://schemas.microsoft.com/office/drawing/2014/main" id="{F4F5257A-DDBA-4EB5-ADCB-1F6CB80865A4}"/>
+                <a16:creationId xmlns:a16="http://schemas.microsoft.com/office/drawing/2014/main" id="{617C38D6-83C7-40C0-BBCE-DA68B523C088}"/>
               </a:ext>
             </a:extLst>
           </p:cNvPr>
@@ -2543,7 +2543,7 @@
           <p:nvPr/>
         </p:nvPicPr>
         <p:blipFill>
-          <a:blip xmlns:r="http://schemas.openxmlformats.org/officeDocument/2006/relationships" xmlns:a="http://schemas.openxmlformats.org/drawingml/2006/main" r:embed="Ra432147107114092"/>
+          <a:blip xmlns:r="http://schemas.openxmlformats.org/officeDocument/2006/relationships" xmlns:a="http://schemas.openxmlformats.org/drawingml/2006/main" r:embed="R9a3fb1d088e94bc2"/>
           <a:stretch xmlns:a="http://schemas.openxmlformats.org/drawingml/2006/main"/>
         </p:blipFill>
         <p:spPr>
@@ -2561,7 +2561,7 @@
           <p:cNvPr id="7" name="">
             <a:extLst xmlns:a="http://schemas.openxmlformats.org/drawingml/2006/main">
               <a:ext uri="{FF2B5EF4-FFF2-40B4-BE49-F238E27FC236}">
-                <a16:creationId xmlns:a16="http://schemas.microsoft.com/office/drawing/2014/main" id="{0CDF01CF-DF29-4923-B3BE-99C93DD2C9CC}"/>
+                <a16:creationId xmlns:a16="http://schemas.microsoft.com/office/drawing/2014/main" id="{5A53E351-B427-4F69-9C57-54E7DEA27A15}"/>
               </a:ext>
             </a:extLst>
           </p:cNvPr>
@@ -2594,7 +2594,7 @@
           <p:cNvPr id="8" name="">
             <a:extLst xmlns:a="http://schemas.openxmlformats.org/drawingml/2006/main">
               <a:ext uri="{FF2B5EF4-FFF2-40B4-BE49-F238E27FC236}">
-                <a16:creationId xmlns:a16="http://schemas.microsoft.com/office/drawing/2014/main" id="{D199A6E0-1573-4678-B0DF-4B1AF6F9D2C0}"/>
+                <a16:creationId xmlns:a16="http://schemas.microsoft.com/office/drawing/2014/main" id="{919AA2B6-929D-4401-902C-89D6B11C948C}"/>
               </a:ext>
             </a:extLst>
           </p:cNvPr>
@@ -2644,7 +2644,7 @@
           <p:cNvPr id="9" name="">
             <a:extLst xmlns:a="http://schemas.openxmlformats.org/drawingml/2006/main">
               <a:ext uri="{FF2B5EF4-FFF2-40B4-BE49-F238E27FC236}">
-                <a16:creationId xmlns:a16="http://schemas.microsoft.com/office/drawing/2014/main" id="{84818255-6749-4C66-A4B4-8FE473237078}"/>
+                <a16:creationId xmlns:a16="http://schemas.microsoft.com/office/drawing/2014/main" id="{A62890D7-398E-4670-BEA3-4D3A8D866EBC}"/>
               </a:ext>
             </a:extLst>
           </p:cNvPr>
@@ -2694,7 +2694,7 @@
           <p:cNvPr id="10" name="">
             <a:extLst xmlns:a="http://schemas.openxmlformats.org/drawingml/2006/main">
               <a:ext uri="{FF2B5EF4-FFF2-40B4-BE49-F238E27FC236}">
-                <a16:creationId xmlns:a16="http://schemas.microsoft.com/office/drawing/2014/main" id="{7D58C53B-6B44-4AD9-8351-BC1A46A948BE}"/>
+                <a16:creationId xmlns:a16="http://schemas.microsoft.com/office/drawing/2014/main" id="{FC906B1F-76C4-433A-85E6-219F0DB1E202}"/>
               </a:ext>
             </a:extLst>
           </p:cNvPr>
@@ -2729,7 +2729,7 @@
           <p:cNvPr id="11" name="">
             <a:extLst xmlns:a="http://schemas.openxmlformats.org/drawingml/2006/main">
               <a:ext uri="{FF2B5EF4-FFF2-40B4-BE49-F238E27FC236}">
-                <a16:creationId xmlns:a16="http://schemas.microsoft.com/office/drawing/2014/main" id="{B67FB271-C6D9-46CD-B190-36227A657144}"/>
+                <a16:creationId xmlns:a16="http://schemas.microsoft.com/office/drawing/2014/main" id="{BC00FC3E-DE01-4D96-AECF-B4C9E31188F3}"/>
               </a:ext>
             </a:extLst>
           </p:cNvPr>
@@ -2785,7 +2785,7 @@
           <p:cNvPr id="12" name="">
             <a:extLst xmlns:a="http://schemas.openxmlformats.org/drawingml/2006/main">
               <a:ext uri="{FF2B5EF4-FFF2-40B4-BE49-F238E27FC236}">
-                <a16:creationId xmlns:a16="http://schemas.microsoft.com/office/drawing/2014/main" id="{671E7053-0C98-4CAC-A2C8-ED7CB7783C6B}"/>
+                <a16:creationId xmlns:a16="http://schemas.microsoft.com/office/drawing/2014/main" id="{F6F4E587-1394-4A5E-B79F-D03C56C0049F}"/>
               </a:ext>
             </a:extLst>
           </p:cNvPr>
@@ -2812,7 +2812,7 @@
           <p:cNvPr id="13" name="">
             <a:extLst xmlns:a="http://schemas.openxmlformats.org/drawingml/2006/main">
               <a:ext uri="{FF2B5EF4-FFF2-40B4-BE49-F238E27FC236}">
-                <a16:creationId xmlns:a16="http://schemas.microsoft.com/office/drawing/2014/main" id="{629AB338-B580-495D-BB32-B47866779E58}"/>
+                <a16:creationId xmlns:a16="http://schemas.microsoft.com/office/drawing/2014/main" id="{947616B2-5749-49E6-966B-25A2E4141B02}"/>
               </a:ext>
             </a:extLst>
           </p:cNvPr>
@@ -2865,7 +2865,7 @@
           <p:cNvPr id="15" name="">
             <a:extLst xmlns:a="http://schemas.openxmlformats.org/drawingml/2006/main">
               <a:ext uri="{FF2B5EF4-FFF2-40B4-BE49-F238E27FC236}">
-                <a16:creationId xmlns:a16="http://schemas.microsoft.com/office/drawing/2014/main" id="{B3C0882F-495B-46B2-B7ED-FB854A227CBF}"/>
+                <a16:creationId xmlns:a16="http://schemas.microsoft.com/office/drawing/2014/main" id="{21E78BD1-4A81-479C-8AE3-E8F121A80C3D}"/>
               </a:ext>
             </a:extLst>
           </p:cNvPr>
@@ -2892,7 +2892,7 @@
           <p:cNvPr id="16" name="">
             <a:extLst xmlns:a="http://schemas.openxmlformats.org/drawingml/2006/main">
               <a:ext uri="{FF2B5EF4-FFF2-40B4-BE49-F238E27FC236}">
-                <a16:creationId xmlns:a16="http://schemas.microsoft.com/office/drawing/2014/main" id="{9F53C392-54F1-482C-B858-1F3634E0A039}"/>
+                <a16:creationId xmlns:a16="http://schemas.microsoft.com/office/drawing/2014/main" id="{6C5E79F3-45BC-447A-8812-81BDB507BAA5}"/>
               </a:ext>
             </a:extLst>
           </p:cNvPr>
@@ -2945,7 +2945,7 @@
           <p:cNvPr id="18" name="">
             <a:extLst xmlns:a="http://schemas.openxmlformats.org/drawingml/2006/main">
               <a:ext uri="{FF2B5EF4-FFF2-40B4-BE49-F238E27FC236}">
-                <a16:creationId xmlns:a16="http://schemas.microsoft.com/office/drawing/2014/main" id="{AEA19053-4DF6-467B-AE70-F77E17880193}"/>
+                <a16:creationId xmlns:a16="http://schemas.microsoft.com/office/drawing/2014/main" id="{BA38B318-58C6-44A2-A08F-3BB319E18AAA}"/>
               </a:ext>
             </a:extLst>
           </p:cNvPr>
@@ -2972,7 +2972,7 @@
           <p:cNvPr id="19" name="">
             <a:extLst xmlns:a="http://schemas.openxmlformats.org/drawingml/2006/main">
               <a:ext uri="{FF2B5EF4-FFF2-40B4-BE49-F238E27FC236}">
-                <a16:creationId xmlns:a16="http://schemas.microsoft.com/office/drawing/2014/main" id="{FA306E4D-0936-4B3E-8029-EC3F8A821695}"/>
+                <a16:creationId xmlns:a16="http://schemas.microsoft.com/office/drawing/2014/main" id="{79C4C5EB-9938-4C9C-8BC8-4848753D5CF5}"/>
               </a:ext>
             </a:extLst>
           </p:cNvPr>
@@ -3025,7 +3025,7 @@
           <p:cNvPr id="21" name="">
             <a:extLst xmlns:a="http://schemas.openxmlformats.org/drawingml/2006/main">
               <a:ext uri="{FF2B5EF4-FFF2-40B4-BE49-F238E27FC236}">
-                <a16:creationId xmlns:a16="http://schemas.microsoft.com/office/drawing/2014/main" id="{41C5A615-EBF4-4E11-B919-C0B3E51E40A0}"/>
+                <a16:creationId xmlns:a16="http://schemas.microsoft.com/office/drawing/2014/main" id="{16263454-5103-40A3-B314-0B31DC4C8898}"/>
               </a:ext>
             </a:extLst>
           </p:cNvPr>
@@ -3075,7 +3075,7 @@
           <p:cNvPr id="22" name="">
             <a:extLst xmlns:a="http://schemas.openxmlformats.org/drawingml/2006/main">
               <a:ext uri="{FF2B5EF4-FFF2-40B4-BE49-F238E27FC236}">
-                <a16:creationId xmlns:a16="http://schemas.microsoft.com/office/drawing/2014/main" id="{E5D94BA7-9EBC-49DD-9935-B532FE98777C}"/>
+                <a16:creationId xmlns:a16="http://schemas.microsoft.com/office/drawing/2014/main" id="{F14B5688-A4E0-4313-8D7F-6A3F7F535D8C}"/>
               </a:ext>
             </a:extLst>
           </p:cNvPr>
@@ -3125,7 +3125,7 @@
           <p:cNvPr id="23" name="">
             <a:extLst xmlns:a="http://schemas.openxmlformats.org/drawingml/2006/main">
               <a:ext uri="{FF2B5EF4-FFF2-40B4-BE49-F238E27FC236}">
-                <a16:creationId xmlns:a16="http://schemas.microsoft.com/office/drawing/2014/main" id="{39B0F3AA-5E1E-4E90-98FD-242E8CBD4CE8}"/>
+                <a16:creationId xmlns:a16="http://schemas.microsoft.com/office/drawing/2014/main" id="{F92C18FD-E095-44D9-99A0-264F1952A350}"/>
               </a:ext>
             </a:extLst>
           </p:cNvPr>
@@ -3175,7 +3175,7 @@
           <p:cNvPr id="24" name="">
             <a:extLst xmlns:a="http://schemas.openxmlformats.org/drawingml/2006/main">
               <a:ext uri="{FF2B5EF4-FFF2-40B4-BE49-F238E27FC236}">
-                <a16:creationId xmlns:a16="http://schemas.microsoft.com/office/drawing/2014/main" id="{4CD02BA6-67ED-4B4B-99C8-5713A92A11CE}"/>
+                <a16:creationId xmlns:a16="http://schemas.microsoft.com/office/drawing/2014/main" id="{583AD90C-ADA8-4A74-82EF-A8FE19A68F46}"/>
               </a:ext>
             </a:extLst>
           </p:cNvPr>
@@ -3242,7 +3242,7 @@
           <p:cNvPr id="25" name="">
             <a:extLst xmlns:a="http://schemas.openxmlformats.org/drawingml/2006/main">
               <a:ext uri="{FF2B5EF4-FFF2-40B4-BE49-F238E27FC236}">
-                <a16:creationId xmlns:a16="http://schemas.microsoft.com/office/drawing/2014/main" id="{9EBDC22B-1F43-448B-AC18-62BD76EF97D2}"/>
+                <a16:creationId xmlns:a16="http://schemas.microsoft.com/office/drawing/2014/main" id="{475E0452-8A59-4796-88C8-D866E13E9AA1}"/>
               </a:ext>
             </a:extLst>
           </p:cNvPr>
@@ -3277,7 +3277,7 @@
           <p:cNvPr id="26" name="">
             <a:extLst xmlns:a="http://schemas.openxmlformats.org/drawingml/2006/main">
               <a:ext uri="{FF2B5EF4-FFF2-40B4-BE49-F238E27FC236}">
-                <a16:creationId xmlns:a16="http://schemas.microsoft.com/office/drawing/2014/main" id="{F9C55E79-362C-4423-854D-04C7EA59A373}"/>
+                <a16:creationId xmlns:a16="http://schemas.microsoft.com/office/drawing/2014/main" id="{3691C009-5088-4B7F-8FCC-85747BD14235}"/>
               </a:ext>
             </a:extLst>
           </p:cNvPr>
@@ -3333,7 +3333,7 @@
           <p:cNvPr id="27" name="">
             <a:extLst xmlns:a="http://schemas.openxmlformats.org/drawingml/2006/main">
               <a:ext uri="{FF2B5EF4-FFF2-40B4-BE49-F238E27FC236}">
-                <a16:creationId xmlns:a16="http://schemas.microsoft.com/office/drawing/2014/main" id="{D305C05D-2429-4151-8687-D0243C45E43A}"/>
+                <a16:creationId xmlns:a16="http://schemas.microsoft.com/office/drawing/2014/main" id="{4AAC93DE-80C6-4938-97B8-545E7D6D94E0}"/>
               </a:ext>
             </a:extLst>
           </p:cNvPr>
@@ -3368,7 +3368,7 @@
           <p:cNvPr id="28" name="">
             <a:extLst xmlns:a="http://schemas.openxmlformats.org/drawingml/2006/main">
               <a:ext uri="{FF2B5EF4-FFF2-40B4-BE49-F238E27FC236}">
-                <a16:creationId xmlns:a16="http://schemas.microsoft.com/office/drawing/2014/main" id="{77C1201E-1D90-4C7C-9D59-78FC05DC3D01}"/>
+                <a16:creationId xmlns:a16="http://schemas.microsoft.com/office/drawing/2014/main" id="{CE15CD31-5E27-42AF-B1FD-8215B5E4B292}"/>
               </a:ext>
             </a:extLst>
           </p:cNvPr>
@@ -3395,7 +3395,7 @@
           <p:cNvPr id="29" name="">
             <a:extLst xmlns:a="http://schemas.openxmlformats.org/drawingml/2006/main">
               <a:ext uri="{FF2B5EF4-FFF2-40B4-BE49-F238E27FC236}">
-                <a16:creationId xmlns:a16="http://schemas.microsoft.com/office/drawing/2014/main" id="{DCA3E241-0FAB-497C-90BF-2FE47271981A}"/>
+                <a16:creationId xmlns:a16="http://schemas.microsoft.com/office/drawing/2014/main" id="{A52EAFC9-D27A-4772-9CA6-D7EF8F2C184D}"/>
               </a:ext>
             </a:extLst>
           </p:cNvPr>
@@ -3448,7 +3448,7 @@
           <p:cNvPr id="31" name="">
             <a:extLst xmlns:a="http://schemas.openxmlformats.org/drawingml/2006/main">
               <a:ext uri="{FF2B5EF4-FFF2-40B4-BE49-F238E27FC236}">
-                <a16:creationId xmlns:a16="http://schemas.microsoft.com/office/drawing/2014/main" id="{3EBA60DC-4474-49D9-AAE2-A41E4871F563}"/>
+                <a16:creationId xmlns:a16="http://schemas.microsoft.com/office/drawing/2014/main" id="{6EC5615A-811E-402E-B22C-DDF3476DB5F5}"/>
               </a:ext>
             </a:extLst>
           </p:cNvPr>
@@ -3475,7 +3475,7 @@
           <p:cNvPr id="32" name="">
             <a:extLst xmlns:a="http://schemas.openxmlformats.org/drawingml/2006/main">
               <a:ext uri="{FF2B5EF4-FFF2-40B4-BE49-F238E27FC236}">
-                <a16:creationId xmlns:a16="http://schemas.microsoft.com/office/drawing/2014/main" id="{B97CB5A7-13E7-4E9A-A071-D2280786F7B6}"/>
+                <a16:creationId xmlns:a16="http://schemas.microsoft.com/office/drawing/2014/main" id="{DA992EDF-77B7-4032-A2A1-6C180512738B}"/>
               </a:ext>
             </a:extLst>
           </p:cNvPr>
@@ -3528,7 +3528,7 @@
           <p:cNvPr id="34" name="">
             <a:extLst xmlns:a="http://schemas.openxmlformats.org/drawingml/2006/main">
               <a:ext uri="{FF2B5EF4-FFF2-40B4-BE49-F238E27FC236}">
-                <a16:creationId xmlns:a16="http://schemas.microsoft.com/office/drawing/2014/main" id="{266D321D-C89B-4E43-BF39-318848822796}"/>
+                <a16:creationId xmlns:a16="http://schemas.microsoft.com/office/drawing/2014/main" id="{DE0E4A2A-167E-4844-9A0F-AA090A071924}"/>
               </a:ext>
             </a:extLst>
           </p:cNvPr>
@@ -3561,7 +3561,7 @@
           <p:cNvPr id="35" name="">
             <a:extLst xmlns:a="http://schemas.openxmlformats.org/drawingml/2006/main">
               <a:ext uri="{FF2B5EF4-FFF2-40B4-BE49-F238E27FC236}">
-                <a16:creationId xmlns:a16="http://schemas.microsoft.com/office/drawing/2014/main" id="{4F5B97C4-0299-4E3E-B047-C64C8D517859}"/>
+                <a16:creationId xmlns:a16="http://schemas.microsoft.com/office/drawing/2014/main" id="{FE048A3F-724A-4052-A162-0D4ACC440193}"/>
               </a:ext>
             </a:extLst>
           </p:cNvPr>
@@ -3611,7 +3611,7 @@
           <p:cNvPr id="36" name="">
             <a:extLst xmlns:a="http://schemas.openxmlformats.org/drawingml/2006/main">
               <a:ext uri="{FF2B5EF4-FFF2-40B4-BE49-F238E27FC236}">
-                <a16:creationId xmlns:a16="http://schemas.microsoft.com/office/drawing/2014/main" id="{6DAC7B08-3567-480C-AA21-AE1E79A602CA}"/>
+                <a16:creationId xmlns:a16="http://schemas.microsoft.com/office/drawing/2014/main" id="{2D1B68C9-5C2A-436B-B7FB-D512B93433A6}"/>
               </a:ext>
             </a:extLst>
           </p:cNvPr>
@@ -3661,7 +3661,7 @@
           <p:cNvPr id="37" name="">
             <a:extLst xmlns:a="http://schemas.openxmlformats.org/drawingml/2006/main">
               <a:ext uri="{FF2B5EF4-FFF2-40B4-BE49-F238E27FC236}">
-                <a16:creationId xmlns:a16="http://schemas.microsoft.com/office/drawing/2014/main" id="{CFDB15AD-F5D8-4EAD-B7D6-30B92C97636E}"/>
+                <a16:creationId xmlns:a16="http://schemas.microsoft.com/office/drawing/2014/main" id="{5717B3A3-FEEB-4D15-AC49-0E96E7835681}"/>
               </a:ext>
             </a:extLst>
           </p:cNvPr>
@@ -3711,7 +3711,7 @@
           <p:cNvPr id="38" name="">
             <a:extLst xmlns:a="http://schemas.openxmlformats.org/drawingml/2006/main">
               <a:ext uri="{FF2B5EF4-FFF2-40B4-BE49-F238E27FC236}">
-                <a16:creationId xmlns:a16="http://schemas.microsoft.com/office/drawing/2014/main" id="{E99AFBB6-421C-48D8-A957-5BF3E36BB969}"/>
+                <a16:creationId xmlns:a16="http://schemas.microsoft.com/office/drawing/2014/main" id="{DA68E86B-D448-4DCE-A398-491800AB45CE}"/>
               </a:ext>
             </a:extLst>
           </p:cNvPr>
@@ -3761,7 +3761,7 @@
           <p:cNvPr id="39" name="">
             <a:extLst xmlns:a="http://schemas.openxmlformats.org/drawingml/2006/main">
               <a:ext uri="{FF2B5EF4-FFF2-40B4-BE49-F238E27FC236}">
-                <a16:creationId xmlns:a16="http://schemas.microsoft.com/office/drawing/2014/main" id="{A162B810-1E93-4CE8-8462-4E3739BE0735}"/>
+                <a16:creationId xmlns:a16="http://schemas.microsoft.com/office/drawing/2014/main" id="{189DBFE2-C672-4677-9928-445493C139BE}"/>
               </a:ext>
             </a:extLst>
           </p:cNvPr>
@@ -3811,7 +3811,7 @@
           <p:cNvPr id="40" name="">
             <a:extLst xmlns:a="http://schemas.openxmlformats.org/drawingml/2006/main">
               <a:ext uri="{FF2B5EF4-FFF2-40B4-BE49-F238E27FC236}">
-                <a16:creationId xmlns:a16="http://schemas.microsoft.com/office/drawing/2014/main" id="{EE28020E-132F-4FF1-9038-F08C14E6EA8E}"/>
+                <a16:creationId xmlns:a16="http://schemas.microsoft.com/office/drawing/2014/main" id="{6CB2467F-1817-4499-96FD-F9AE6AE3407A}"/>
               </a:ext>
             </a:extLst>
           </p:cNvPr>
@@ -3846,7 +3846,7 @@
           <p:cNvPr id="41" name="">
             <a:extLst xmlns:a="http://schemas.openxmlformats.org/drawingml/2006/main">
               <a:ext uri="{FF2B5EF4-FFF2-40B4-BE49-F238E27FC236}">
-                <a16:creationId xmlns:a16="http://schemas.microsoft.com/office/drawing/2014/main" id="{265BF5C8-00A8-4048-8A67-0ED94A3B62F2}"/>
+                <a16:creationId xmlns:a16="http://schemas.microsoft.com/office/drawing/2014/main" id="{4ABB27A6-8E48-48C4-9876-2CB782C060BE}"/>
               </a:ext>
             </a:extLst>
           </p:cNvPr>
@@ -3879,7 +3879,7 @@
           <p:cNvPr id="42" name="">
             <a:extLst xmlns:a="http://schemas.openxmlformats.org/drawingml/2006/main">
               <a:ext uri="{FF2B5EF4-FFF2-40B4-BE49-F238E27FC236}">
-                <a16:creationId xmlns:a16="http://schemas.microsoft.com/office/drawing/2014/main" id="{D1B34F50-4F60-4481-A7C9-03A7ADC893B6}"/>
+                <a16:creationId xmlns:a16="http://schemas.microsoft.com/office/drawing/2014/main" id="{9BA93F67-CB0E-4479-8990-A5C00CE3D6FA}"/>
               </a:ext>
             </a:extLst>
           </p:cNvPr>
@@ -3933,10 +3933,10 @@
           <p:nvPr/>
         </p:nvPicPr>
         <p:blipFill>
-          <a:blip xmlns:r="http://schemas.openxmlformats.org/officeDocument/2006/relationships" xmlns:a="http://schemas.openxmlformats.org/drawingml/2006/main" r:embed="Ra187c8bb07224450">
+          <a:blip xmlns:r="http://schemas.openxmlformats.org/officeDocument/2006/relationships" xmlns:a="http://schemas.openxmlformats.org/drawingml/2006/main" r:embed="R1da3c26c671f40a1">
             <a:extLst>
               <a:ext uri="{96DAC541-7B7A-43D3-8B79-37D633B846F1}">
-                <asvg:svgBlip xmlns:asvg="http://schemas.microsoft.com/office/drawing/2016/SVG/main" r:embed="R7de0521c06ef46c1"/>
+                <asvg:svgBlip xmlns:asvg="http://schemas.microsoft.com/office/drawing/2016/SVG/main" r:embed="Re3e4c7b3abb8413e"/>
               </a:ext>
             </a:extLst>
           </a:blip>
@@ -3957,7 +3957,7 @@
           <p:cNvPr id="44" name="">
             <a:extLst xmlns:a="http://schemas.openxmlformats.org/drawingml/2006/main">
               <a:ext uri="{FF2B5EF4-FFF2-40B4-BE49-F238E27FC236}">
-                <a16:creationId xmlns:a16="http://schemas.microsoft.com/office/drawing/2014/main" id="{635FC574-1AE7-4C3C-9B75-F83E3E4DE077}"/>
+                <a16:creationId xmlns:a16="http://schemas.microsoft.com/office/drawing/2014/main" id="{CF5797CE-4222-491D-961E-BCE3B15EED92}"/>
               </a:ext>
             </a:extLst>
           </p:cNvPr>
@@ -3992,7 +3992,7 @@
           <p:cNvPr id="45" name="">
             <a:extLst xmlns:a="http://schemas.openxmlformats.org/drawingml/2006/main">
               <a:ext uri="{FF2B5EF4-FFF2-40B4-BE49-F238E27FC236}">
-                <a16:creationId xmlns:a16="http://schemas.microsoft.com/office/drawing/2014/main" id="{01687647-1876-4998-A4CF-5BA8A8B8D9E7}"/>
+                <a16:creationId xmlns:a16="http://schemas.microsoft.com/office/drawing/2014/main" id="{FF00A93E-C849-425D-8888-7813ECC0C4E4}"/>
               </a:ext>
             </a:extLst>
           </p:cNvPr>
@@ -4025,7 +4025,7 @@
           <p:cNvPr id="46" name="">
             <a:extLst xmlns:a="http://schemas.openxmlformats.org/drawingml/2006/main">
               <a:ext uri="{FF2B5EF4-FFF2-40B4-BE49-F238E27FC236}">
-                <a16:creationId xmlns:a16="http://schemas.microsoft.com/office/drawing/2014/main" id="{FC29D321-B4C3-45B6-B984-D321C7143651}"/>
+                <a16:creationId xmlns:a16="http://schemas.microsoft.com/office/drawing/2014/main" id="{80C0144F-3806-4929-B93B-03AF1D020F29}"/>
               </a:ext>
             </a:extLst>
           </p:cNvPr>
@@ -4079,10 +4079,10 @@
           <p:nvPr/>
         </p:nvPicPr>
         <p:blipFill>
-          <a:blip xmlns:r="http://schemas.openxmlformats.org/officeDocument/2006/relationships" xmlns:a="http://schemas.openxmlformats.org/drawingml/2006/main" r:embed="Rfd28d1a86af44aca">
+          <a:blip xmlns:r="http://schemas.openxmlformats.org/officeDocument/2006/relationships" xmlns:a="http://schemas.openxmlformats.org/drawingml/2006/main" r:embed="Rb5c5d481d8694831">
             <a:extLst>
               <a:ext uri="{96DAC541-7B7A-43D3-8B79-37D633B846F1}">
-                <asvg:svgBlip xmlns:asvg="http://schemas.microsoft.com/office/drawing/2016/SVG/main" r:embed="R5201ef03ad574737"/>
+                <asvg:svgBlip xmlns:asvg="http://schemas.microsoft.com/office/drawing/2016/SVG/main" r:embed="R80b4bbb7c8ce4f18"/>
               </a:ext>
             </a:extLst>
           </a:blip>
@@ -4101,7 +4101,7 @@
     </p:spTree>
     <p:extLst>
       <p:ext uri="{BB962C8B-B14F-4D97-AF65-F5344CB8AC3E}">
-        <p14:creationId xmlns:p14="http://schemas.microsoft.com/office/powerpoint/2010/main" val="1979154757"/>
+        <p14:creationId xmlns:p14="http://schemas.microsoft.com/office/powerpoint/2010/main" val="1510172325"/>
       </p:ext>
     </p:extLst>
   </p:cSld>
@@ -4132,7 +4132,7 @@
           <p:cNvPr id="28" name="">
             <a:extLst xmlns:a="http://schemas.openxmlformats.org/drawingml/2006/main">
               <a:ext uri="{FF2B5EF4-FFF2-40B4-BE49-F238E27FC236}">
-                <a16:creationId xmlns:a16="http://schemas.microsoft.com/office/drawing/2014/main" id="{45C74FD7-24D2-443B-B69B-02FD8B264425}"/>
+                <a16:creationId xmlns:a16="http://schemas.microsoft.com/office/drawing/2014/main" id="{D513AE41-2C85-45B3-BAF6-A459C25D214F}"/>
               </a:ext>
             </a:extLst>
           </p:cNvPr>
@@ -4165,7 +4165,7 @@
           <p:cNvPr id="2" name="">
             <a:extLst xmlns:a="http://schemas.openxmlformats.org/drawingml/2006/main">
               <a:ext uri="{FF2B5EF4-FFF2-40B4-BE49-F238E27FC236}">
-                <a16:creationId xmlns:a16="http://schemas.microsoft.com/office/drawing/2014/main" id="{2DF7CE74-6038-4264-AB15-C3042CD307ED}"/>
+                <a16:creationId xmlns:a16="http://schemas.microsoft.com/office/drawing/2014/main" id="{0B396943-9A67-40BC-BAF3-BB7824881E92}"/>
               </a:ext>
             </a:extLst>
           </p:cNvPr>
@@ -4198,7 +4198,7 @@
           <p:cNvPr id="3" name="">
             <a:extLst xmlns:a="http://schemas.openxmlformats.org/drawingml/2006/main">
               <a:ext uri="{FF2B5EF4-FFF2-40B4-BE49-F238E27FC236}">
-                <a16:creationId xmlns:a16="http://schemas.microsoft.com/office/drawing/2014/main" id="{42DA7A06-F033-4D7D-A576-CC9BC7AC84EA}"/>
+                <a16:creationId xmlns:a16="http://schemas.microsoft.com/office/drawing/2014/main" id="{DE6CC9CB-502D-4E94-BAC7-7813477AAFD2}"/>
               </a:ext>
             </a:extLst>
           </p:cNvPr>
@@ -4248,7 +4248,7 @@
           <p:cNvPr id="4" name="">
             <a:extLst xmlns:a="http://schemas.openxmlformats.org/drawingml/2006/main">
               <a:ext uri="{FF2B5EF4-FFF2-40B4-BE49-F238E27FC236}">
-                <a16:creationId xmlns:a16="http://schemas.microsoft.com/office/drawing/2014/main" id="{AC5466B2-C726-4FED-882F-BBB9CBECC660}"/>
+                <a16:creationId xmlns:a16="http://schemas.microsoft.com/office/drawing/2014/main" id="{C43CC6CB-CF84-4860-BB8F-6F6849459F85}"/>
               </a:ext>
             </a:extLst>
           </p:cNvPr>
@@ -4298,7 +4298,7 @@
           <p:cNvPr id="5" name="">
             <a:extLst xmlns:a="http://schemas.openxmlformats.org/drawingml/2006/main">
               <a:ext uri="{FF2B5EF4-FFF2-40B4-BE49-F238E27FC236}">
-                <a16:creationId xmlns:a16="http://schemas.microsoft.com/office/drawing/2014/main" id="{22D13737-8D46-4689-A411-92261231E84F}"/>
+                <a16:creationId xmlns:a16="http://schemas.microsoft.com/office/drawing/2014/main" id="{01267DED-A541-45B3-9114-34F125A656C3}"/>
               </a:ext>
             </a:extLst>
           </p:cNvPr>
@@ -4352,7 +4352,7 @@
           <p:nvPr/>
         </p:nvPicPr>
         <p:blipFill>
-          <a:blip xmlns:r="http://schemas.openxmlformats.org/officeDocument/2006/relationships" xmlns:a="http://schemas.openxmlformats.org/drawingml/2006/main" r:embed="R1a6f357fa21647f0"/>
+          <a:blip xmlns:r="http://schemas.openxmlformats.org/officeDocument/2006/relationships" xmlns:a="http://schemas.openxmlformats.org/drawingml/2006/main" r:embed="R4ac6c9d6817b40ea"/>
           <a:stretch xmlns:a="http://schemas.openxmlformats.org/drawingml/2006/main"/>
         </p:blipFill>
         <p:spPr>
@@ -4370,7 +4370,7 @@
           <p:cNvPr id="7" name="">
             <a:extLst xmlns:a="http://schemas.openxmlformats.org/drawingml/2006/main">
               <a:ext uri="{FF2B5EF4-FFF2-40B4-BE49-F238E27FC236}">
-                <a16:creationId xmlns:a16="http://schemas.microsoft.com/office/drawing/2014/main" id="{A2FDE817-C2CA-4AF3-9839-4962131C9A7A}"/>
+                <a16:creationId xmlns:a16="http://schemas.microsoft.com/office/drawing/2014/main" id="{6C3F86AD-08C1-4A30-9D37-63139260B22A}"/>
               </a:ext>
             </a:extLst>
           </p:cNvPr>
@@ -4403,7 +4403,7 @@
           <p:cNvPr id="8" name="">
             <a:extLst xmlns:a="http://schemas.openxmlformats.org/drawingml/2006/main">
               <a:ext uri="{FF2B5EF4-FFF2-40B4-BE49-F238E27FC236}">
-                <a16:creationId xmlns:a16="http://schemas.microsoft.com/office/drawing/2014/main" id="{9C2984A3-AD42-4189-B405-4FFBE2426396}"/>
+                <a16:creationId xmlns:a16="http://schemas.microsoft.com/office/drawing/2014/main" id="{67D05380-08F3-4FEF-9E93-C95BFDB815D2}"/>
               </a:ext>
             </a:extLst>
           </p:cNvPr>
@@ -4453,7 +4453,7 @@
           <p:cNvPr id="9" name="">
             <a:extLst xmlns:a="http://schemas.openxmlformats.org/drawingml/2006/main">
               <a:ext uri="{FF2B5EF4-FFF2-40B4-BE49-F238E27FC236}">
-                <a16:creationId xmlns:a16="http://schemas.microsoft.com/office/drawing/2014/main" id="{B8ED7ECB-3008-4FC9-BDBB-44E91E285E9A}"/>
+                <a16:creationId xmlns:a16="http://schemas.microsoft.com/office/drawing/2014/main" id="{8D22CDB0-69F4-4C41-80C8-07AC0130DA53}"/>
               </a:ext>
             </a:extLst>
           </p:cNvPr>
@@ -4503,7 +4503,7 @@
           <p:cNvPr id="10" name="">
             <a:extLst xmlns:a="http://schemas.openxmlformats.org/drawingml/2006/main">
               <a:ext uri="{FF2B5EF4-FFF2-40B4-BE49-F238E27FC236}">
-                <a16:creationId xmlns:a16="http://schemas.microsoft.com/office/drawing/2014/main" id="{3A170144-85AD-43DD-AA17-6CC50557769A}"/>
+                <a16:creationId xmlns:a16="http://schemas.microsoft.com/office/drawing/2014/main" id="{ED55302D-E2AF-4195-AC43-5A76FCDA033A}"/>
               </a:ext>
             </a:extLst>
           </p:cNvPr>
@@ -4538,7 +4538,7 @@
           <p:cNvPr id="11" name="">
             <a:extLst xmlns:a="http://schemas.openxmlformats.org/drawingml/2006/main">
               <a:ext uri="{FF2B5EF4-FFF2-40B4-BE49-F238E27FC236}">
-                <a16:creationId xmlns:a16="http://schemas.microsoft.com/office/drawing/2014/main" id="{BE360A9E-A8FE-4ADE-906A-253D9DFAC786}"/>
+                <a16:creationId xmlns:a16="http://schemas.microsoft.com/office/drawing/2014/main" id="{DB2AD6DB-C969-49B8-84AB-24E84A66A1D5}"/>
               </a:ext>
             </a:extLst>
           </p:cNvPr>
@@ -4571,7 +4571,7 @@
           <p:cNvPr id="12" name="">
             <a:extLst xmlns:a="http://schemas.openxmlformats.org/drawingml/2006/main">
               <a:ext uri="{FF2B5EF4-FFF2-40B4-BE49-F238E27FC236}">
-                <a16:creationId xmlns:a16="http://schemas.microsoft.com/office/drawing/2014/main" id="{6385837B-C2C3-4868-AF47-BA276D92F795}"/>
+                <a16:creationId xmlns:a16="http://schemas.microsoft.com/office/drawing/2014/main" id="{BEE45705-0AA3-465B-B985-A2804431362F}"/>
               </a:ext>
             </a:extLst>
           </p:cNvPr>
@@ -4625,10 +4625,10 @@
           <p:nvPr/>
         </p:nvPicPr>
         <p:blipFill>
-          <a:blip xmlns:r="http://schemas.openxmlformats.org/officeDocument/2006/relationships" xmlns:a="http://schemas.openxmlformats.org/drawingml/2006/main" r:embed="R414635e0c8ba4dc1">
+          <a:blip xmlns:r="http://schemas.openxmlformats.org/officeDocument/2006/relationships" xmlns:a="http://schemas.openxmlformats.org/drawingml/2006/main" r:embed="R3f9b7a0701ae4773">
             <a:extLst>
               <a:ext uri="{96DAC541-7B7A-43D3-8B79-37D633B846F1}">
-                <asvg:svgBlip xmlns:asvg="http://schemas.microsoft.com/office/drawing/2016/SVG/main" r:embed="Re9ac86985c3f4dfb"/>
+                <asvg:svgBlip xmlns:asvg="http://schemas.microsoft.com/office/drawing/2016/SVG/main" r:embed="R035860294dfd421f"/>
               </a:ext>
             </a:extLst>
           </a:blip>
@@ -4649,7 +4649,7 @@
           <p:cNvPr id="14" name="">
             <a:extLst xmlns:a="http://schemas.openxmlformats.org/drawingml/2006/main">
               <a:ext uri="{FF2B5EF4-FFF2-40B4-BE49-F238E27FC236}">
-                <a16:creationId xmlns:a16="http://schemas.microsoft.com/office/drawing/2014/main" id="{7875A811-D544-417E-BEE7-A0407DD50258}"/>
+                <a16:creationId xmlns:a16="http://schemas.microsoft.com/office/drawing/2014/main" id="{0315409A-82D0-4710-A06D-12AC6E250389}"/>
               </a:ext>
             </a:extLst>
           </p:cNvPr>
@@ -4684,7 +4684,7 @@
           <p:cNvPr id="15" name="">
             <a:extLst xmlns:a="http://schemas.openxmlformats.org/drawingml/2006/main">
               <a:ext uri="{FF2B5EF4-FFF2-40B4-BE49-F238E27FC236}">
-                <a16:creationId xmlns:a16="http://schemas.microsoft.com/office/drawing/2014/main" id="{002843AF-A705-4E76-80B3-63373B553852}"/>
+                <a16:creationId xmlns:a16="http://schemas.microsoft.com/office/drawing/2014/main" id="{5E740433-54AE-4004-AF48-21CBC3E77649}"/>
               </a:ext>
             </a:extLst>
           </p:cNvPr>
@@ -4717,7 +4717,7 @@
           <p:cNvPr id="16" name="">
             <a:extLst xmlns:a="http://schemas.openxmlformats.org/drawingml/2006/main">
               <a:ext uri="{FF2B5EF4-FFF2-40B4-BE49-F238E27FC236}">
-                <a16:creationId xmlns:a16="http://schemas.microsoft.com/office/drawing/2014/main" id="{E1440810-6ED0-4A36-9B45-B7198FB9C131}"/>
+                <a16:creationId xmlns:a16="http://schemas.microsoft.com/office/drawing/2014/main" id="{68C93FC7-9040-421E-907D-D7AEA1658798}"/>
               </a:ext>
             </a:extLst>
           </p:cNvPr>
@@ -4771,10 +4771,10 @@
           <p:nvPr/>
         </p:nvPicPr>
         <p:blipFill>
-          <a:blip xmlns:r="http://schemas.openxmlformats.org/officeDocument/2006/relationships" xmlns:a="http://schemas.openxmlformats.org/drawingml/2006/main" r:embed="R8f535e473b35465a">
+          <a:blip xmlns:r="http://schemas.openxmlformats.org/officeDocument/2006/relationships" xmlns:a="http://schemas.openxmlformats.org/drawingml/2006/main" r:embed="R044a1264f68c40d5">
             <a:extLst>
               <a:ext uri="{96DAC541-7B7A-43D3-8B79-37D633B846F1}">
-                <asvg:svgBlip xmlns:asvg="http://schemas.microsoft.com/office/drawing/2016/SVG/main" r:embed="Rdb5494795b734f9d"/>
+                <asvg:svgBlip xmlns:asvg="http://schemas.microsoft.com/office/drawing/2016/SVG/main" r:embed="R2b3149b0aad74c63"/>
               </a:ext>
             </a:extLst>
           </a:blip>
@@ -4795,7 +4795,7 @@
           <p:cNvPr id="18" name="">
             <a:extLst xmlns:a="http://schemas.openxmlformats.org/drawingml/2006/main">
               <a:ext uri="{FF2B5EF4-FFF2-40B4-BE49-F238E27FC236}">
-                <a16:creationId xmlns:a16="http://schemas.microsoft.com/office/drawing/2014/main" id="{3737DDE1-87B9-4DED-9256-8E4E69C4009E}"/>
+                <a16:creationId xmlns:a16="http://schemas.microsoft.com/office/drawing/2014/main" id="{37B17F93-77C3-4C43-91B2-31794946345E}"/>
               </a:ext>
             </a:extLst>
           </p:cNvPr>
@@ -4830,7 +4830,7 @@
           <p:cNvPr id="19" name="">
             <a:extLst xmlns:a="http://schemas.openxmlformats.org/drawingml/2006/main">
               <a:ext uri="{FF2B5EF4-FFF2-40B4-BE49-F238E27FC236}">
-                <a16:creationId xmlns:a16="http://schemas.microsoft.com/office/drawing/2014/main" id="{75DAA107-C704-486B-871F-EFE8B309D83A}"/>
+                <a16:creationId xmlns:a16="http://schemas.microsoft.com/office/drawing/2014/main" id="{6709D7CA-6696-4A0E-8089-CA0C89ADFC40}"/>
               </a:ext>
             </a:extLst>
           </p:cNvPr>
@@ -4863,7 +4863,7 @@
           <p:cNvPr id="20" name="">
             <a:extLst xmlns:a="http://schemas.openxmlformats.org/drawingml/2006/main">
               <a:ext uri="{FF2B5EF4-FFF2-40B4-BE49-F238E27FC236}">
-                <a16:creationId xmlns:a16="http://schemas.microsoft.com/office/drawing/2014/main" id="{A397F8D5-9760-44BF-9CA6-C25E5E368D0D}"/>
+                <a16:creationId xmlns:a16="http://schemas.microsoft.com/office/drawing/2014/main" id="{E1A291C5-06FB-435C-B53D-6EA42A413597}"/>
               </a:ext>
             </a:extLst>
           </p:cNvPr>
@@ -4917,10 +4917,10 @@
           <p:nvPr/>
         </p:nvPicPr>
         <p:blipFill>
-          <a:blip xmlns:r="http://schemas.openxmlformats.org/officeDocument/2006/relationships" xmlns:a="http://schemas.openxmlformats.org/drawingml/2006/main" r:embed="R0e8343765ff348dc">
+          <a:blip xmlns:r="http://schemas.openxmlformats.org/officeDocument/2006/relationships" xmlns:a="http://schemas.openxmlformats.org/drawingml/2006/main" r:embed="R99d2a8d5636b4fd4">
             <a:extLst>
               <a:ext uri="{96DAC541-7B7A-43D3-8B79-37D633B846F1}">
-                <asvg:svgBlip xmlns:asvg="http://schemas.microsoft.com/office/drawing/2016/SVG/main" r:embed="Rd581648eab114fa8"/>
+                <asvg:svgBlip xmlns:asvg="http://schemas.microsoft.com/office/drawing/2016/SVG/main" r:embed="R34502a139d164d8c"/>
               </a:ext>
             </a:extLst>
           </a:blip>
@@ -4941,7 +4941,7 @@
           <p:cNvPr id="22" name="">
             <a:extLst xmlns:a="http://schemas.openxmlformats.org/drawingml/2006/main">
               <a:ext uri="{FF2B5EF4-FFF2-40B4-BE49-F238E27FC236}">
-                <a16:creationId xmlns:a16="http://schemas.microsoft.com/office/drawing/2014/main" id="{1C8A987E-AD38-4CF5-AA1D-362296B1C7A3}"/>
+                <a16:creationId xmlns:a16="http://schemas.microsoft.com/office/drawing/2014/main" id="{FDFE0508-0DC9-4760-9BC2-29910FC038D3}"/>
               </a:ext>
             </a:extLst>
           </p:cNvPr>
@@ -4976,7 +4976,7 @@
           <p:cNvPr id="23" name="">
             <a:extLst xmlns:a="http://schemas.openxmlformats.org/drawingml/2006/main">
               <a:ext uri="{FF2B5EF4-FFF2-40B4-BE49-F238E27FC236}">
-                <a16:creationId xmlns:a16="http://schemas.microsoft.com/office/drawing/2014/main" id="{77203076-7DFE-421C-835E-37CF558B1B3B}"/>
+                <a16:creationId xmlns:a16="http://schemas.microsoft.com/office/drawing/2014/main" id="{E5FEE7FE-9BB6-4352-BF18-FB36C9B55844}"/>
               </a:ext>
             </a:extLst>
           </p:cNvPr>
@@ -5009,7 +5009,7 @@
           <p:cNvPr id="24" name="">
             <a:extLst xmlns:a="http://schemas.openxmlformats.org/drawingml/2006/main">
               <a:ext uri="{FF2B5EF4-FFF2-40B4-BE49-F238E27FC236}">
-                <a16:creationId xmlns:a16="http://schemas.microsoft.com/office/drawing/2014/main" id="{CA661DB2-6531-4D98-B3DE-27127940E2D9}"/>
+                <a16:creationId xmlns:a16="http://schemas.microsoft.com/office/drawing/2014/main" id="{259E5FF8-502C-4406-B05A-F78CD8A47CC3}"/>
               </a:ext>
             </a:extLst>
           </p:cNvPr>
@@ -5059,7 +5059,7 @@
           <p:cNvPr id="25" name="">
             <a:extLst xmlns:a="http://schemas.openxmlformats.org/drawingml/2006/main">
               <a:ext uri="{FF2B5EF4-FFF2-40B4-BE49-F238E27FC236}">
-                <a16:creationId xmlns:a16="http://schemas.microsoft.com/office/drawing/2014/main" id="{DE8BC20D-2B67-4782-8364-2129B7E4A764}"/>
+                <a16:creationId xmlns:a16="http://schemas.microsoft.com/office/drawing/2014/main" id="{A75C7CB2-F16F-4CD0-8534-D59AA9CBC960}"/>
               </a:ext>
             </a:extLst>
           </p:cNvPr>
@@ -5143,7 +5143,7 @@
           <p:cNvPr id="26" name="">
             <a:extLst xmlns:a="http://schemas.openxmlformats.org/drawingml/2006/main">
               <a:ext uri="{FF2B5EF4-FFF2-40B4-BE49-F238E27FC236}">
-                <a16:creationId xmlns:a16="http://schemas.microsoft.com/office/drawing/2014/main" id="{8642A4E6-643D-458B-8109-2776CEBC8918}"/>
+                <a16:creationId xmlns:a16="http://schemas.microsoft.com/office/drawing/2014/main" id="{ADA6CB1E-4F8E-4934-9D45-31D8A843DB52}"/>
               </a:ext>
             </a:extLst>
           </p:cNvPr>
@@ -5178,7 +5178,7 @@
           <p:cNvPr id="27" name="">
             <a:extLst xmlns:a="http://schemas.openxmlformats.org/drawingml/2006/main">
               <a:ext uri="{FF2B5EF4-FFF2-40B4-BE49-F238E27FC236}">
-                <a16:creationId xmlns:a16="http://schemas.microsoft.com/office/drawing/2014/main" id="{217E9C89-A4EB-47D2-9442-B3C3ADF6783A}"/>
+                <a16:creationId xmlns:a16="http://schemas.microsoft.com/office/drawing/2014/main" id="{EF123848-EA10-4E95-908A-FA0FC72CC296}"/>
               </a:ext>
             </a:extLst>
           </p:cNvPr>
@@ -5226,7 +5226,7 @@
     </p:spTree>
     <p:extLst>
       <p:ext uri="{BB962C8B-B14F-4D97-AF65-F5344CB8AC3E}">
-        <p14:creationId xmlns:p14="http://schemas.microsoft.com/office/powerpoint/2010/main" val="1494913002"/>
+        <p14:creationId xmlns:p14="http://schemas.microsoft.com/office/powerpoint/2010/main" val="2141977041"/>
       </p:ext>
     </p:extLst>
   </p:cSld>
@@ -5257,7 +5257,7 @@
           <p:cNvPr id="39" name="">
             <a:extLst xmlns:a="http://schemas.openxmlformats.org/drawingml/2006/main">
               <a:ext uri="{FF2B5EF4-FFF2-40B4-BE49-F238E27FC236}">
-                <a16:creationId xmlns:a16="http://schemas.microsoft.com/office/drawing/2014/main" id="{350D0F6A-831A-448A-BEE5-F4D0446C5247}"/>
+                <a16:creationId xmlns:a16="http://schemas.microsoft.com/office/drawing/2014/main" id="{F4825309-ABDC-4CC2-88C8-266732F29FE4}"/>
               </a:ext>
             </a:extLst>
           </p:cNvPr>
@@ -5290,7 +5290,7 @@
           <p:cNvPr id="2" name="">
             <a:extLst xmlns:a="http://schemas.openxmlformats.org/drawingml/2006/main">
               <a:ext uri="{FF2B5EF4-FFF2-40B4-BE49-F238E27FC236}">
-                <a16:creationId xmlns:a16="http://schemas.microsoft.com/office/drawing/2014/main" id="{93564FA9-0EAE-49D7-8FF9-D40200009E93}"/>
+                <a16:creationId xmlns:a16="http://schemas.microsoft.com/office/drawing/2014/main" id="{72B55D4D-2836-492E-B64B-3ED63076DD1F}"/>
               </a:ext>
             </a:extLst>
           </p:cNvPr>
@@ -5323,7 +5323,7 @@
           <p:cNvPr id="3" name="">
             <a:extLst xmlns:a="http://schemas.openxmlformats.org/drawingml/2006/main">
               <a:ext uri="{FF2B5EF4-FFF2-40B4-BE49-F238E27FC236}">
-                <a16:creationId xmlns:a16="http://schemas.microsoft.com/office/drawing/2014/main" id="{DD5DAEA4-65E7-4B54-842E-2B8531387661}"/>
+                <a16:creationId xmlns:a16="http://schemas.microsoft.com/office/drawing/2014/main" id="{3A70B1AB-3611-477D-9D15-7B1294CA5184}"/>
               </a:ext>
             </a:extLst>
           </p:cNvPr>
@@ -5373,7 +5373,7 @@
           <p:cNvPr id="4" name="">
             <a:extLst xmlns:a="http://schemas.openxmlformats.org/drawingml/2006/main">
               <a:ext uri="{FF2B5EF4-FFF2-40B4-BE49-F238E27FC236}">
-                <a16:creationId xmlns:a16="http://schemas.microsoft.com/office/drawing/2014/main" id="{6E8260A8-50D7-4CB0-B5BF-1C28ACB478F7}"/>
+                <a16:creationId xmlns:a16="http://schemas.microsoft.com/office/drawing/2014/main" id="{E90F5B8E-F3B4-4E82-9D77-D02BB03F3BB8}"/>
               </a:ext>
             </a:extLst>
           </p:cNvPr>
@@ -5423,7 +5423,7 @@
           <p:cNvPr id="5" name="">
             <a:extLst xmlns:a="http://schemas.openxmlformats.org/drawingml/2006/main">
               <a:ext uri="{FF2B5EF4-FFF2-40B4-BE49-F238E27FC236}">
-                <a16:creationId xmlns:a16="http://schemas.microsoft.com/office/drawing/2014/main" id="{D038BC2F-3B1B-4DE7-B5FF-237605537DF2}"/>
+                <a16:creationId xmlns:a16="http://schemas.microsoft.com/office/drawing/2014/main" id="{6FA25582-7E7C-444E-9959-15A4A81E6B8E}"/>
               </a:ext>
             </a:extLst>
           </p:cNvPr>
@@ -5477,7 +5477,7 @@
           <p:nvPr/>
         </p:nvPicPr>
         <p:blipFill>
-          <a:blip xmlns:r="http://schemas.openxmlformats.org/officeDocument/2006/relationships" xmlns:a="http://schemas.openxmlformats.org/drawingml/2006/main" r:embed="Re6f4352b778d4532"/>
+          <a:blip xmlns:r="http://schemas.openxmlformats.org/officeDocument/2006/relationships" xmlns:a="http://schemas.openxmlformats.org/drawingml/2006/main" r:embed="R560e3a97be5e4fd2"/>
           <a:stretch xmlns:a="http://schemas.openxmlformats.org/drawingml/2006/main"/>
         </p:blipFill>
         <p:spPr>
@@ -5495,7 +5495,7 @@
           <p:cNvPr id="7" name="">
             <a:extLst xmlns:a="http://schemas.openxmlformats.org/drawingml/2006/main">
               <a:ext uri="{FF2B5EF4-FFF2-40B4-BE49-F238E27FC236}">
-                <a16:creationId xmlns:a16="http://schemas.microsoft.com/office/drawing/2014/main" id="{3A5FE29B-FCEF-44F2-AE55-14AF3D3024AE}"/>
+                <a16:creationId xmlns:a16="http://schemas.microsoft.com/office/drawing/2014/main" id="{C0634423-457F-47D2-8844-51D9BEB29B4A}"/>
               </a:ext>
             </a:extLst>
           </p:cNvPr>
@@ -5528,7 +5528,7 @@
           <p:cNvPr id="8" name="">
             <a:extLst xmlns:a="http://schemas.openxmlformats.org/drawingml/2006/main">
               <a:ext uri="{FF2B5EF4-FFF2-40B4-BE49-F238E27FC236}">
-                <a16:creationId xmlns:a16="http://schemas.microsoft.com/office/drawing/2014/main" id="{6F9A8F05-856B-42F7-996F-C978DB313AFB}"/>
+                <a16:creationId xmlns:a16="http://schemas.microsoft.com/office/drawing/2014/main" id="{00FAE5AC-E674-4C1F-B153-7790133F3141}"/>
               </a:ext>
             </a:extLst>
           </p:cNvPr>
@@ -5578,7 +5578,7 @@
           <p:cNvPr id="9" name="">
             <a:extLst xmlns:a="http://schemas.openxmlformats.org/drawingml/2006/main">
               <a:ext uri="{FF2B5EF4-FFF2-40B4-BE49-F238E27FC236}">
-                <a16:creationId xmlns:a16="http://schemas.microsoft.com/office/drawing/2014/main" id="{7E86360D-48AE-4F78-BF15-1C2C53470DA9}"/>
+                <a16:creationId xmlns:a16="http://schemas.microsoft.com/office/drawing/2014/main" id="{FCF07A78-FEDF-43C0-8AAD-334B25DC3604}"/>
               </a:ext>
             </a:extLst>
           </p:cNvPr>
@@ -5628,7 +5628,7 @@
           <p:cNvPr id="10" name="">
             <a:extLst xmlns:a="http://schemas.openxmlformats.org/drawingml/2006/main">
               <a:ext uri="{FF2B5EF4-FFF2-40B4-BE49-F238E27FC236}">
-                <a16:creationId xmlns:a16="http://schemas.microsoft.com/office/drawing/2014/main" id="{FB3B2767-68BD-451E-AAF6-8464968CF2F8}"/>
+                <a16:creationId xmlns:a16="http://schemas.microsoft.com/office/drawing/2014/main" id="{7E8B256A-0745-43B8-87D0-7ECEBB967263}"/>
               </a:ext>
             </a:extLst>
           </p:cNvPr>
@@ -5663,7 +5663,7 @@
           <p:cNvPr id="11" name="">
             <a:extLst xmlns:a="http://schemas.openxmlformats.org/drawingml/2006/main">
               <a:ext uri="{FF2B5EF4-FFF2-40B4-BE49-F238E27FC236}">
-                <a16:creationId xmlns:a16="http://schemas.microsoft.com/office/drawing/2014/main" id="{EE837DA7-5D70-4BFF-99B6-CFAB321AFE05}"/>
+                <a16:creationId xmlns:a16="http://schemas.microsoft.com/office/drawing/2014/main" id="{D09F4636-EA9C-413D-89BA-B3C96E2D0478}"/>
               </a:ext>
             </a:extLst>
           </p:cNvPr>
@@ -5719,18 +5719,18 @@
           <p:cNvPr id="12" name="">
             <a:extLst xmlns:a="http://schemas.openxmlformats.org/drawingml/2006/main">
               <a:ext uri="{FF2B5EF4-FFF2-40B4-BE49-F238E27FC236}">
-                <a16:creationId xmlns:a16="http://schemas.microsoft.com/office/drawing/2014/main" id="{481EA9B7-ED36-408E-AB7E-E5F6448F052E}"/>
-              </a:ext>
-            </a:extLst>
-          </p:cNvPr>
-          <p:cNvSpPr>
-            <a:spLocks xmlns:a="http://schemas.openxmlformats.org/drawingml/2006/main" noGrp="1"/>
-          </p:cNvSpPr>
-          <p:nvPr/>
-        </p:nvSpPr>
-        <p:spPr>
-          <a:xfrm xmlns:a="http://schemas.openxmlformats.org/drawingml/2006/main">
-            <a:off x="1695450" y="3914775"/>
+                <a16:creationId xmlns:a16="http://schemas.microsoft.com/office/drawing/2014/main" id="{5EA9D630-F730-4217-8593-25F91FDA8C07}"/>
+              </a:ext>
+            </a:extLst>
+          </p:cNvPr>
+          <p:cNvSpPr>
+            <a:spLocks xmlns:a="http://schemas.openxmlformats.org/drawingml/2006/main" noGrp="1"/>
+          </p:cNvSpPr>
+          <p:nvPr/>
+        </p:nvSpPr>
+        <p:spPr>
+          <a:xfrm xmlns:a="http://schemas.openxmlformats.org/drawingml/2006/main">
+            <a:off x="1695450" y="3286125"/>
             <a:ext cx="19050" cy="19050"/>
           </a:xfrm>
           <a:prstGeom xmlns:a="http://schemas.openxmlformats.org/drawingml/2006/main" prst="rect">
@@ -5746,18 +5746,18 @@
           <p:cNvPr id="13" name="">
             <a:extLst xmlns:a="http://schemas.openxmlformats.org/drawingml/2006/main">
               <a:ext uri="{FF2B5EF4-FFF2-40B4-BE49-F238E27FC236}">
-                <a16:creationId xmlns:a16="http://schemas.microsoft.com/office/drawing/2014/main" id="{CC6A39E7-206F-4A88-A233-BD0C21D457AE}"/>
-              </a:ext>
-            </a:extLst>
-          </p:cNvPr>
-          <p:cNvSpPr>
-            <a:spLocks xmlns:a="http://schemas.openxmlformats.org/drawingml/2006/main" noGrp="1"/>
-          </p:cNvSpPr>
-          <p:nvPr/>
-        </p:nvSpPr>
-        <p:spPr>
-          <a:xfrm xmlns:a="http://schemas.openxmlformats.org/drawingml/2006/main">
-            <a:off x="4838700" y="3286125"/>
+                <a16:creationId xmlns:a16="http://schemas.microsoft.com/office/drawing/2014/main" id="{763D5D0E-EE36-4D3E-A296-6457792AE111}"/>
+              </a:ext>
+            </a:extLst>
+          </p:cNvPr>
+          <p:cNvSpPr>
+            <a:spLocks xmlns:a="http://schemas.openxmlformats.org/drawingml/2006/main" noGrp="1"/>
+          </p:cNvSpPr>
+          <p:nvPr/>
+        </p:nvSpPr>
+        <p:spPr>
+          <a:xfrm xmlns:a="http://schemas.openxmlformats.org/drawingml/2006/main">
+            <a:off x="4838700" y="3914775"/>
             <a:ext cx="19050" cy="19050"/>
           </a:xfrm>
           <a:prstGeom xmlns:a="http://schemas.openxmlformats.org/drawingml/2006/main" prst="rect">
@@ -5778,7 +5778,7 @@
           <p:nvPr/>
         </p:nvCxnSpPr>
         <p:spPr>
-          <a:xfrm xmlns:a="http://schemas.openxmlformats.org/drawingml/2006/main" flipV="1">
+          <a:xfrm xmlns:a="http://schemas.openxmlformats.org/drawingml/2006/main">
             <a:off x="1714500" y="3295650"/>
             <a:ext cx="3124200" cy="628650"/>
           </a:xfrm>
@@ -5798,18 +5798,18 @@
           <p:cNvPr id="15" name="">
             <a:extLst xmlns:a="http://schemas.openxmlformats.org/drawingml/2006/main">
               <a:ext uri="{FF2B5EF4-FFF2-40B4-BE49-F238E27FC236}">
-                <a16:creationId xmlns:a16="http://schemas.microsoft.com/office/drawing/2014/main" id="{4FBDD8CE-A0FA-4E03-BFB2-7346C4031E81}"/>
-              </a:ext>
-            </a:extLst>
-          </p:cNvPr>
-          <p:cNvSpPr>
-            <a:spLocks xmlns:a="http://schemas.openxmlformats.org/drawingml/2006/main" noGrp="1"/>
-          </p:cNvSpPr>
-          <p:nvPr/>
-        </p:nvSpPr>
-        <p:spPr>
-          <a:xfrm xmlns:a="http://schemas.openxmlformats.org/drawingml/2006/main">
-            <a:off x="1485900" y="3705225"/>
+                <a16:creationId xmlns:a16="http://schemas.microsoft.com/office/drawing/2014/main" id="{6F0C692A-9664-45EF-88A2-3E2859840FFC}"/>
+              </a:ext>
+            </a:extLst>
+          </p:cNvPr>
+          <p:cNvSpPr>
+            <a:spLocks xmlns:a="http://schemas.openxmlformats.org/drawingml/2006/main" noGrp="1"/>
+          </p:cNvSpPr>
+          <p:nvPr/>
+        </p:nvSpPr>
+        <p:spPr>
+          <a:xfrm xmlns:a="http://schemas.openxmlformats.org/drawingml/2006/main">
+            <a:off x="1485900" y="3076575"/>
             <a:ext cx="419100" cy="419100"/>
           </a:xfrm>
           <a:prstGeom xmlns:a="http://schemas.openxmlformats.org/drawingml/2006/main" prst="ellipse">
@@ -5831,18 +5831,18 @@
           <p:cNvPr id="16" name="">
             <a:extLst xmlns:a="http://schemas.openxmlformats.org/drawingml/2006/main">
               <a:ext uri="{FF2B5EF4-FFF2-40B4-BE49-F238E27FC236}">
-                <a16:creationId xmlns:a16="http://schemas.microsoft.com/office/drawing/2014/main" id="{3909BBAB-7B28-4CEB-ACEB-56AF6D3FC392}"/>
-              </a:ext>
-            </a:extLst>
-          </p:cNvPr>
-          <p:cNvSpPr>
-            <a:spLocks xmlns:a="http://schemas.openxmlformats.org/drawingml/2006/main" noGrp="1"/>
-          </p:cNvSpPr>
-          <p:nvPr/>
-        </p:nvSpPr>
-        <p:spPr>
-          <a:xfrm xmlns:a="http://schemas.openxmlformats.org/drawingml/2006/main">
-            <a:off x="4629150" y="3076575"/>
+                <a16:creationId xmlns:a16="http://schemas.microsoft.com/office/drawing/2014/main" id="{8776F7A3-95BD-4077-A1B7-FFFB1149CAB1}"/>
+              </a:ext>
+            </a:extLst>
+          </p:cNvPr>
+          <p:cNvSpPr>
+            <a:spLocks xmlns:a="http://schemas.openxmlformats.org/drawingml/2006/main" noGrp="1"/>
+          </p:cNvSpPr>
+          <p:nvPr/>
+        </p:nvSpPr>
+        <p:spPr>
+          <a:xfrm xmlns:a="http://schemas.openxmlformats.org/drawingml/2006/main">
+            <a:off x="4629150" y="3705225"/>
             <a:ext cx="419100" cy="419100"/>
           </a:xfrm>
           <a:prstGeom xmlns:a="http://schemas.openxmlformats.org/drawingml/2006/main" prst="ellipse">
@@ -5864,7 +5864,7 @@
           <p:cNvPr id="17" name="">
             <a:extLst xmlns:a="http://schemas.openxmlformats.org/drawingml/2006/main">
               <a:ext uri="{FF2B5EF4-FFF2-40B4-BE49-F238E27FC236}">
-                <a16:creationId xmlns:a16="http://schemas.microsoft.com/office/drawing/2014/main" id="{432CF990-60EB-488A-8F47-6BA0CF8E9B8D}"/>
+                <a16:creationId xmlns:a16="http://schemas.microsoft.com/office/drawing/2014/main" id="{8357AC22-5710-4CB0-AEDA-2A669FF04FE9}"/>
               </a:ext>
             </a:extLst>
           </p:cNvPr>
@@ -5891,7 +5891,7 @@
           <p:cNvPr id="18" name="">
             <a:extLst xmlns:a="http://schemas.openxmlformats.org/drawingml/2006/main">
               <a:ext uri="{FF2B5EF4-FFF2-40B4-BE49-F238E27FC236}">
-                <a16:creationId xmlns:a16="http://schemas.microsoft.com/office/drawing/2014/main" id="{62BA2A30-2A3A-46A5-8B11-A35181C09732}"/>
+                <a16:creationId xmlns:a16="http://schemas.microsoft.com/office/drawing/2014/main" id="{C97A50DD-986C-4C56-9770-1FFACFA31CC1}"/>
               </a:ext>
             </a:extLst>
           </p:cNvPr>
@@ -5944,7 +5944,7 @@
           <p:cNvPr id="20" name="">
             <a:extLst xmlns:a="http://schemas.openxmlformats.org/drawingml/2006/main">
               <a:ext uri="{FF2B5EF4-FFF2-40B4-BE49-F238E27FC236}">
-                <a16:creationId xmlns:a16="http://schemas.microsoft.com/office/drawing/2014/main" id="{E024263C-18EF-4A18-95D4-A6C3CC83EE5F}"/>
+                <a16:creationId xmlns:a16="http://schemas.microsoft.com/office/drawing/2014/main" id="{54576B53-F814-41CD-A389-AADEDE11F640}"/>
               </a:ext>
             </a:extLst>
           </p:cNvPr>
@@ -5971,7 +5971,7 @@
           <p:cNvPr id="21" name="">
             <a:extLst xmlns:a="http://schemas.openxmlformats.org/drawingml/2006/main">
               <a:ext uri="{FF2B5EF4-FFF2-40B4-BE49-F238E27FC236}">
-                <a16:creationId xmlns:a16="http://schemas.microsoft.com/office/drawing/2014/main" id="{3F27FBBF-58DF-4129-94D4-E3CCA7F1D7E7}"/>
+                <a16:creationId xmlns:a16="http://schemas.microsoft.com/office/drawing/2014/main" id="{5951940B-730E-487C-A0C8-85D8D5384080}"/>
               </a:ext>
             </a:extLst>
           </p:cNvPr>
@@ -6024,7 +6024,7 @@
           <p:cNvPr id="23" name="">
             <a:extLst xmlns:a="http://schemas.openxmlformats.org/drawingml/2006/main">
               <a:ext uri="{FF2B5EF4-FFF2-40B4-BE49-F238E27FC236}">
-                <a16:creationId xmlns:a16="http://schemas.microsoft.com/office/drawing/2014/main" id="{78A1F6B8-6708-4F83-BD49-8A1903886B64}"/>
+                <a16:creationId xmlns:a16="http://schemas.microsoft.com/office/drawing/2014/main" id="{FADC2910-6D8B-4838-AD00-8B7D59A78EBC}"/>
               </a:ext>
             </a:extLst>
           </p:cNvPr>
@@ -6051,7 +6051,7 @@
           <p:cNvPr id="24" name="">
             <a:extLst xmlns:a="http://schemas.openxmlformats.org/drawingml/2006/main">
               <a:ext uri="{FF2B5EF4-FFF2-40B4-BE49-F238E27FC236}">
-                <a16:creationId xmlns:a16="http://schemas.microsoft.com/office/drawing/2014/main" id="{081700B5-AFD8-4221-A5E3-40B8F916228C}"/>
+                <a16:creationId xmlns:a16="http://schemas.microsoft.com/office/drawing/2014/main" id="{BE9D1D86-CB01-4D07-A35A-98A6EC8CDED8}"/>
               </a:ext>
             </a:extLst>
           </p:cNvPr>
@@ -6104,7 +6104,7 @@
           <p:cNvPr id="26" name="">
             <a:extLst xmlns:a="http://schemas.openxmlformats.org/drawingml/2006/main">
               <a:ext uri="{FF2B5EF4-FFF2-40B4-BE49-F238E27FC236}">
-                <a16:creationId xmlns:a16="http://schemas.microsoft.com/office/drawing/2014/main" id="{A1C4A30F-C7BF-4853-91AC-90E6C6BC1AC5}"/>
+                <a16:creationId xmlns:a16="http://schemas.microsoft.com/office/drawing/2014/main" id="{68E211FE-D12D-4A9A-9D3B-B66902BA3BFB}"/>
               </a:ext>
             </a:extLst>
           </p:cNvPr>
@@ -6154,7 +6154,7 @@
           <p:cNvPr id="27" name="">
             <a:extLst xmlns:a="http://schemas.openxmlformats.org/drawingml/2006/main">
               <a:ext uri="{FF2B5EF4-FFF2-40B4-BE49-F238E27FC236}">
-                <a16:creationId xmlns:a16="http://schemas.microsoft.com/office/drawing/2014/main" id="{3B0C405C-25CD-471D-9541-A3D639AB819B}"/>
+                <a16:creationId xmlns:a16="http://schemas.microsoft.com/office/drawing/2014/main" id="{6A40758D-B475-47FA-AB7F-27E14B64FF5D}"/>
               </a:ext>
             </a:extLst>
           </p:cNvPr>
@@ -6204,19 +6204,19 @@
           <p:cNvPr id="28" name="">
             <a:extLst xmlns:a="http://schemas.openxmlformats.org/drawingml/2006/main">
               <a:ext uri="{FF2B5EF4-FFF2-40B4-BE49-F238E27FC236}">
-                <a16:creationId xmlns:a16="http://schemas.microsoft.com/office/drawing/2014/main" id="{4DC76984-DBC8-43E9-B199-1D60CE263674}"/>
-              </a:ext>
-            </a:extLst>
-          </p:cNvPr>
-          <p:cNvSpPr>
-            <a:spLocks xmlns:a="http://schemas.openxmlformats.org/drawingml/2006/main" noGrp="1"/>
-          </p:cNvSpPr>
-          <p:nvPr/>
-        </p:nvSpPr>
-        <p:spPr>
-          <a:xfrm xmlns:a="http://schemas.openxmlformats.org/drawingml/2006/main">
-            <a:off x="4552950" y="3714750"/>
-            <a:ext cx="1333500" cy="247650"/>
+                <a16:creationId xmlns:a16="http://schemas.microsoft.com/office/drawing/2014/main" id="{9123124D-13B7-4657-9361-C692A9EB1A03}"/>
+              </a:ext>
+            </a:extLst>
+          </p:cNvPr>
+          <p:cNvSpPr>
+            <a:spLocks xmlns:a="http://schemas.openxmlformats.org/drawingml/2006/main" noGrp="1"/>
+          </p:cNvSpPr>
+          <p:nvPr/>
+        </p:nvSpPr>
+        <p:spPr>
+          <a:xfrm xmlns:a="http://schemas.openxmlformats.org/drawingml/2006/main">
+            <a:off x="4286250" y="3295650"/>
+            <a:ext cx="1428750" cy="247650"/>
           </a:xfrm>
           <a:prstGeom xmlns:a="http://schemas.openxmlformats.org/drawingml/2006/main" prst="rect">
             <a:avLst/>
@@ -6254,7 +6254,7 @@
           <p:cNvPr id="29" name="">
             <a:extLst xmlns:a="http://schemas.openxmlformats.org/drawingml/2006/main">
               <a:ext uri="{FF2B5EF4-FFF2-40B4-BE49-F238E27FC236}">
-                <a16:creationId xmlns:a16="http://schemas.microsoft.com/office/drawing/2014/main" id="{861A57A8-172D-4A85-AA4B-EF6BF522A467}"/>
+                <a16:creationId xmlns:a16="http://schemas.microsoft.com/office/drawing/2014/main" id="{DAC748EA-261E-4D34-8405-75346B89B677}"/>
               </a:ext>
             </a:extLst>
           </p:cNvPr>
@@ -6304,7 +6304,7 @@
           <p:cNvPr id="30" name="">
             <a:extLst xmlns:a="http://schemas.openxmlformats.org/drawingml/2006/main">
               <a:ext uri="{FF2B5EF4-FFF2-40B4-BE49-F238E27FC236}">
-                <a16:creationId xmlns:a16="http://schemas.microsoft.com/office/drawing/2014/main" id="{55A78476-6A6E-4677-81DB-1B716D5FBBCF}"/>
+                <a16:creationId xmlns:a16="http://schemas.microsoft.com/office/drawing/2014/main" id="{3B93313A-07BD-4BDB-AC0B-0C7035B71574}"/>
               </a:ext>
             </a:extLst>
           </p:cNvPr>
@@ -6339,7 +6339,7 @@
           <p:cNvPr id="31" name="">
             <a:extLst xmlns:a="http://schemas.openxmlformats.org/drawingml/2006/main">
               <a:ext uri="{FF2B5EF4-FFF2-40B4-BE49-F238E27FC236}">
-                <a16:creationId xmlns:a16="http://schemas.microsoft.com/office/drawing/2014/main" id="{6A8EC1FC-B788-46C2-94BF-AC2295FAE2FD}"/>
+                <a16:creationId xmlns:a16="http://schemas.microsoft.com/office/drawing/2014/main" id="{FC9243DE-027E-4885-8D74-228E2112B48B}"/>
               </a:ext>
             </a:extLst>
           </p:cNvPr>
@@ -6372,7 +6372,7 @@
           <p:cNvPr id="32" name="">
             <a:extLst xmlns:a="http://schemas.openxmlformats.org/drawingml/2006/main">
               <a:ext uri="{FF2B5EF4-FFF2-40B4-BE49-F238E27FC236}">
-                <a16:creationId xmlns:a16="http://schemas.microsoft.com/office/drawing/2014/main" id="{70830534-CBCC-4641-80E0-A04D2ECD1EA6}"/>
+                <a16:creationId xmlns:a16="http://schemas.microsoft.com/office/drawing/2014/main" id="{96239A7B-BA49-44DF-9EB9-1D0DD8C739E8}"/>
               </a:ext>
             </a:extLst>
           </p:cNvPr>
@@ -6426,10 +6426,10 @@
           <p:nvPr/>
         </p:nvPicPr>
         <p:blipFill>
-          <a:blip xmlns:r="http://schemas.openxmlformats.org/officeDocument/2006/relationships" xmlns:a="http://schemas.openxmlformats.org/drawingml/2006/main" r:embed="R512867073c024a5b">
+          <a:blip xmlns:r="http://schemas.openxmlformats.org/officeDocument/2006/relationships" xmlns:a="http://schemas.openxmlformats.org/drawingml/2006/main" r:embed="R4f329a25d9a540ab">
             <a:extLst>
               <a:ext uri="{96DAC541-7B7A-43D3-8B79-37D633B846F1}">
-                <asvg:svgBlip xmlns:asvg="http://schemas.microsoft.com/office/drawing/2016/SVG/main" r:embed="Rd0d188bffcc64600"/>
+                <asvg:svgBlip xmlns:asvg="http://schemas.microsoft.com/office/drawing/2016/SVG/main" r:embed="R741889ba1f114dba"/>
               </a:ext>
             </a:extLst>
           </a:blip>
@@ -6450,7 +6450,7 @@
           <p:cNvPr id="34" name="">
             <a:extLst xmlns:a="http://schemas.openxmlformats.org/drawingml/2006/main">
               <a:ext uri="{FF2B5EF4-FFF2-40B4-BE49-F238E27FC236}">
-                <a16:creationId xmlns:a16="http://schemas.microsoft.com/office/drawing/2014/main" id="{CE4570DF-7A4B-4512-9001-191BBFD4C8CF}"/>
+                <a16:creationId xmlns:a16="http://schemas.microsoft.com/office/drawing/2014/main" id="{6CBF7209-9171-452D-B5ED-30C381291CF3}"/>
               </a:ext>
             </a:extLst>
           </p:cNvPr>
@@ -6485,7 +6485,7 @@
           <p:cNvPr id="35" name="">
             <a:extLst xmlns:a="http://schemas.openxmlformats.org/drawingml/2006/main">
               <a:ext uri="{FF2B5EF4-FFF2-40B4-BE49-F238E27FC236}">
-                <a16:creationId xmlns:a16="http://schemas.microsoft.com/office/drawing/2014/main" id="{4BC21387-4BE6-45D7-B8FF-0271379E42A4}"/>
+                <a16:creationId xmlns:a16="http://schemas.microsoft.com/office/drawing/2014/main" id="{DEFFDE77-26BD-41DE-A0AD-7524FBFC681E}"/>
               </a:ext>
             </a:extLst>
           </p:cNvPr>
@@ -6518,7 +6518,7 @@
           <p:cNvPr id="36" name="">
             <a:extLst xmlns:a="http://schemas.openxmlformats.org/drawingml/2006/main">
               <a:ext uri="{FF2B5EF4-FFF2-40B4-BE49-F238E27FC236}">
-                <a16:creationId xmlns:a16="http://schemas.microsoft.com/office/drawing/2014/main" id="{F44050BA-C46D-4908-ADB0-D5B030BBA170}"/>
+                <a16:creationId xmlns:a16="http://schemas.microsoft.com/office/drawing/2014/main" id="{588B116F-3A37-4936-BAE6-C112FF661223}"/>
               </a:ext>
             </a:extLst>
           </p:cNvPr>
@@ -6572,10 +6572,10 @@
           <p:nvPr/>
         </p:nvPicPr>
         <p:blipFill>
-          <a:blip xmlns:r="http://schemas.openxmlformats.org/officeDocument/2006/relationships" xmlns:a="http://schemas.openxmlformats.org/drawingml/2006/main" r:embed="R44aacf48943f4d12">
+          <a:blip xmlns:r="http://schemas.openxmlformats.org/officeDocument/2006/relationships" xmlns:a="http://schemas.openxmlformats.org/drawingml/2006/main" r:embed="Rfbb3613883464e64">
             <a:extLst>
               <a:ext uri="{96DAC541-7B7A-43D3-8B79-37D633B846F1}">
-                <asvg:svgBlip xmlns:asvg="http://schemas.microsoft.com/office/drawing/2016/SVG/main" r:embed="Rad4cdecdcbbb4dbb"/>
+                <asvg:svgBlip xmlns:asvg="http://schemas.microsoft.com/office/drawing/2016/SVG/main" r:embed="R6f198a39061342ba"/>
               </a:ext>
             </a:extLst>
           </a:blip>
@@ -6596,7 +6596,7 @@
           <p:cNvPr id="38" name="">
             <a:extLst xmlns:a="http://schemas.openxmlformats.org/drawingml/2006/main">
               <a:ext uri="{FF2B5EF4-FFF2-40B4-BE49-F238E27FC236}">
-                <a16:creationId xmlns:a16="http://schemas.microsoft.com/office/drawing/2014/main" id="{9B31CAB3-E86C-4031-8BE5-1D420D5E9994}"/>
+                <a16:creationId xmlns:a16="http://schemas.microsoft.com/office/drawing/2014/main" id="{E9E4EA6B-EE47-4FCF-A3E6-4CB26D2DC67D}"/>
               </a:ext>
             </a:extLst>
           </p:cNvPr>
@@ -6644,7 +6644,7 @@
     </p:spTree>
     <p:extLst>
       <p:ext uri="{BB962C8B-B14F-4D97-AF65-F5344CB8AC3E}">
-        <p14:creationId xmlns:p14="http://schemas.microsoft.com/office/powerpoint/2010/main" val="744910848"/>
+        <p14:creationId xmlns:p14="http://schemas.microsoft.com/office/powerpoint/2010/main" val="1122775246"/>
       </p:ext>
     </p:extLst>
   </p:cSld>
@@ -6675,7 +6675,7 @@
           <p:cNvPr id="102" name="">
             <a:extLst xmlns:a="http://schemas.openxmlformats.org/drawingml/2006/main">
               <a:ext uri="{FF2B5EF4-FFF2-40B4-BE49-F238E27FC236}">
-                <a16:creationId xmlns:a16="http://schemas.microsoft.com/office/drawing/2014/main" id="{6FBF296E-241E-473C-A004-C92CE4F90756}"/>
+                <a16:creationId xmlns:a16="http://schemas.microsoft.com/office/drawing/2014/main" id="{10A65DB3-5CED-479B-AC38-563061A8F122}"/>
               </a:ext>
             </a:extLst>
           </p:cNvPr>
@@ -6708,7 +6708,7 @@
           <p:cNvPr id="2" name="">
             <a:extLst xmlns:a="http://schemas.openxmlformats.org/drawingml/2006/main">
               <a:ext uri="{FF2B5EF4-FFF2-40B4-BE49-F238E27FC236}">
-                <a16:creationId xmlns:a16="http://schemas.microsoft.com/office/drawing/2014/main" id="{DC5F4788-CC1A-471E-9F1D-D4639F7A520E}"/>
+                <a16:creationId xmlns:a16="http://schemas.microsoft.com/office/drawing/2014/main" id="{CD981564-1A12-4AB5-922A-8CF9351D289F}"/>
               </a:ext>
             </a:extLst>
           </p:cNvPr>
@@ -6741,7 +6741,7 @@
           <p:cNvPr id="3" name="">
             <a:extLst xmlns:a="http://schemas.openxmlformats.org/drawingml/2006/main">
               <a:ext uri="{FF2B5EF4-FFF2-40B4-BE49-F238E27FC236}">
-                <a16:creationId xmlns:a16="http://schemas.microsoft.com/office/drawing/2014/main" id="{555C21D2-D89D-4F69-8890-2CFA6EDC33EA}"/>
+                <a16:creationId xmlns:a16="http://schemas.microsoft.com/office/drawing/2014/main" id="{51C1DBBB-444A-4C51-80B3-D4C3A5D45C66}"/>
               </a:ext>
             </a:extLst>
           </p:cNvPr>
@@ -6791,7 +6791,7 @@
           <p:cNvPr id="4" name="">
             <a:extLst xmlns:a="http://schemas.openxmlformats.org/drawingml/2006/main">
               <a:ext uri="{FF2B5EF4-FFF2-40B4-BE49-F238E27FC236}">
-                <a16:creationId xmlns:a16="http://schemas.microsoft.com/office/drawing/2014/main" id="{BF8315BA-27FE-49A9-9879-D84EEC1900AF}"/>
+                <a16:creationId xmlns:a16="http://schemas.microsoft.com/office/drawing/2014/main" id="{8E2EFD1C-B677-4DD0-BCBA-00B3629B698A}"/>
               </a:ext>
             </a:extLst>
           </p:cNvPr>
@@ -6841,7 +6841,7 @@
           <p:cNvPr id="5" name="">
             <a:extLst xmlns:a="http://schemas.openxmlformats.org/drawingml/2006/main">
               <a:ext uri="{FF2B5EF4-FFF2-40B4-BE49-F238E27FC236}">
-                <a16:creationId xmlns:a16="http://schemas.microsoft.com/office/drawing/2014/main" id="{09E56BB4-0012-4F9E-84B4-7340BC3ABB6B}"/>
+                <a16:creationId xmlns:a16="http://schemas.microsoft.com/office/drawing/2014/main" id="{BB200E25-EE66-4324-BC21-762FCEA9DDCD}"/>
               </a:ext>
             </a:extLst>
           </p:cNvPr>
@@ -6895,7 +6895,7 @@
           <p:nvPr/>
         </p:nvPicPr>
         <p:blipFill>
-          <a:blip xmlns:r="http://schemas.openxmlformats.org/officeDocument/2006/relationships" xmlns:a="http://schemas.openxmlformats.org/drawingml/2006/main" r:embed="R27cf22f860b94f87"/>
+          <a:blip xmlns:r="http://schemas.openxmlformats.org/officeDocument/2006/relationships" xmlns:a="http://schemas.openxmlformats.org/drawingml/2006/main" r:embed="Rd9c73703edcf4b28"/>
           <a:stretch xmlns:a="http://schemas.openxmlformats.org/drawingml/2006/main"/>
         </p:blipFill>
         <p:spPr>
@@ -6913,7 +6913,7 @@
           <p:cNvPr id="7" name="">
             <a:extLst xmlns:a="http://schemas.openxmlformats.org/drawingml/2006/main">
               <a:ext uri="{FF2B5EF4-FFF2-40B4-BE49-F238E27FC236}">
-                <a16:creationId xmlns:a16="http://schemas.microsoft.com/office/drawing/2014/main" id="{EB574441-3637-4BFD-BF36-D030B6632141}"/>
+                <a16:creationId xmlns:a16="http://schemas.microsoft.com/office/drawing/2014/main" id="{5E2BD8CA-7DA5-4680-9E30-B7D0F0F536A8}"/>
               </a:ext>
             </a:extLst>
           </p:cNvPr>
@@ -6946,7 +6946,7 @@
           <p:cNvPr id="8" name="">
             <a:extLst xmlns:a="http://schemas.openxmlformats.org/drawingml/2006/main">
               <a:ext uri="{FF2B5EF4-FFF2-40B4-BE49-F238E27FC236}">
-                <a16:creationId xmlns:a16="http://schemas.microsoft.com/office/drawing/2014/main" id="{2BD7E8F3-1BCA-4939-A877-BF5B77AC7C8B}"/>
+                <a16:creationId xmlns:a16="http://schemas.microsoft.com/office/drawing/2014/main" id="{82D41AFA-9E89-421B-95F2-94BA680F9E0A}"/>
               </a:ext>
             </a:extLst>
           </p:cNvPr>
@@ -6996,7 +6996,7 @@
           <p:cNvPr id="9" name="">
             <a:extLst xmlns:a="http://schemas.openxmlformats.org/drawingml/2006/main">
               <a:ext uri="{FF2B5EF4-FFF2-40B4-BE49-F238E27FC236}">
-                <a16:creationId xmlns:a16="http://schemas.microsoft.com/office/drawing/2014/main" id="{F15EFFDA-E12D-4F6B-8983-E0F2F2E0EC30}"/>
+                <a16:creationId xmlns:a16="http://schemas.microsoft.com/office/drawing/2014/main" id="{CC8947F7-F9D1-428F-85C1-6240F2C8909F}"/>
               </a:ext>
             </a:extLst>
           </p:cNvPr>
@@ -7046,7 +7046,7 @@
           <p:cNvPr id="10" name="">
             <a:extLst xmlns:a="http://schemas.openxmlformats.org/drawingml/2006/main">
               <a:ext uri="{FF2B5EF4-FFF2-40B4-BE49-F238E27FC236}">
-                <a16:creationId xmlns:a16="http://schemas.microsoft.com/office/drawing/2014/main" id="{BD4DBC7D-3741-4481-97A2-967DB9F6C612}"/>
+                <a16:creationId xmlns:a16="http://schemas.microsoft.com/office/drawing/2014/main" id="{118DF388-6187-4BD0-8506-59A8F116B88E}"/>
               </a:ext>
             </a:extLst>
           </p:cNvPr>
@@ -7081,7 +7081,7 @@
           <p:cNvPr id="11" name="">
             <a:extLst xmlns:a="http://schemas.openxmlformats.org/drawingml/2006/main">
               <a:ext uri="{FF2B5EF4-FFF2-40B4-BE49-F238E27FC236}">
-                <a16:creationId xmlns:a16="http://schemas.microsoft.com/office/drawing/2014/main" id="{292DAF63-0A33-4EEC-8EB7-ECA8E82C8729}"/>
+                <a16:creationId xmlns:a16="http://schemas.microsoft.com/office/drawing/2014/main" id="{DF58EA3D-9F4B-435F-B85B-CA48801208FB}"/>
               </a:ext>
             </a:extLst>
           </p:cNvPr>
@@ -7137,7 +7137,7 @@
           <p:cNvPr id="12" name="">
             <a:extLst xmlns:a="http://schemas.openxmlformats.org/drawingml/2006/main">
               <a:ext uri="{FF2B5EF4-FFF2-40B4-BE49-F238E27FC236}">
-                <a16:creationId xmlns:a16="http://schemas.microsoft.com/office/drawing/2014/main" id="{8234CA21-5D1A-49F7-B18C-E3186A6778D5}"/>
+                <a16:creationId xmlns:a16="http://schemas.microsoft.com/office/drawing/2014/main" id="{BD5BF889-B87D-4030-9CC6-223239F65E0A}"/>
               </a:ext>
             </a:extLst>
           </p:cNvPr>
@@ -7164,7 +7164,7 @@
           <p:cNvPr id="13" name="">
             <a:extLst xmlns:a="http://schemas.openxmlformats.org/drawingml/2006/main">
               <a:ext uri="{FF2B5EF4-FFF2-40B4-BE49-F238E27FC236}">
-                <a16:creationId xmlns:a16="http://schemas.microsoft.com/office/drawing/2014/main" id="{DABDAFAC-7259-4679-9EB4-70C8F2903808}"/>
+                <a16:creationId xmlns:a16="http://schemas.microsoft.com/office/drawing/2014/main" id="{6AE5DB63-C039-49BD-9843-E79A95EE5FAA}"/>
               </a:ext>
             </a:extLst>
           </p:cNvPr>
@@ -7216,7 +7216,7 @@
           <p:cNvPr id="15" name="">
             <a:extLst xmlns:a="http://schemas.openxmlformats.org/drawingml/2006/main">
               <a:ext uri="{FF2B5EF4-FFF2-40B4-BE49-F238E27FC236}">
-                <a16:creationId xmlns:a16="http://schemas.microsoft.com/office/drawing/2014/main" id="{C3260B5A-9614-4120-9D6E-3CF7A57EEA33}"/>
+                <a16:creationId xmlns:a16="http://schemas.microsoft.com/office/drawing/2014/main" id="{D62B0C50-23D5-4240-9001-BD268E00E9D9}"/>
               </a:ext>
             </a:extLst>
           </p:cNvPr>
@@ -7249,7 +7249,7 @@
           <p:cNvPr id="16" name="">
             <a:extLst xmlns:a="http://schemas.openxmlformats.org/drawingml/2006/main">
               <a:ext uri="{FF2B5EF4-FFF2-40B4-BE49-F238E27FC236}">
-                <a16:creationId xmlns:a16="http://schemas.microsoft.com/office/drawing/2014/main" id="{597771E1-7EF2-42D8-82B4-34645E4A3E34}"/>
+                <a16:creationId xmlns:a16="http://schemas.microsoft.com/office/drawing/2014/main" id="{10F9E640-2723-4F02-B50D-7C83B0A157CE}"/>
               </a:ext>
             </a:extLst>
           </p:cNvPr>
@@ -7299,7 +7299,7 @@
           <p:cNvPr id="17" name="">
             <a:extLst xmlns:a="http://schemas.openxmlformats.org/drawingml/2006/main">
               <a:ext uri="{FF2B5EF4-FFF2-40B4-BE49-F238E27FC236}">
-                <a16:creationId xmlns:a16="http://schemas.microsoft.com/office/drawing/2014/main" id="{015E5E87-7DF0-461E-B478-192DFCE07334}"/>
+                <a16:creationId xmlns:a16="http://schemas.microsoft.com/office/drawing/2014/main" id="{F158401F-4C3B-4AC8-AF02-8EBCF5702C54}"/>
               </a:ext>
             </a:extLst>
           </p:cNvPr>
@@ -7349,7 +7349,7 @@
           <p:cNvPr id="18" name="">
             <a:extLst xmlns:a="http://schemas.openxmlformats.org/drawingml/2006/main">
               <a:ext uri="{FF2B5EF4-FFF2-40B4-BE49-F238E27FC236}">
-                <a16:creationId xmlns:a16="http://schemas.microsoft.com/office/drawing/2014/main" id="{3D3C65B5-52AA-4413-A76E-748C32BB3E8E}"/>
+                <a16:creationId xmlns:a16="http://schemas.microsoft.com/office/drawing/2014/main" id="{4A87880A-86D8-4994-B37D-234CDAD3752A}"/>
               </a:ext>
             </a:extLst>
           </p:cNvPr>
@@ -7376,7 +7376,7 @@
           <p:cNvPr id="19" name="">
             <a:extLst xmlns:a="http://schemas.openxmlformats.org/drawingml/2006/main">
               <a:ext uri="{FF2B5EF4-FFF2-40B4-BE49-F238E27FC236}">
-                <a16:creationId xmlns:a16="http://schemas.microsoft.com/office/drawing/2014/main" id="{AA20A7B9-38A1-482B-8F25-B0D7DFBF51FF}"/>
+                <a16:creationId xmlns:a16="http://schemas.microsoft.com/office/drawing/2014/main" id="{2C5FF6A3-E375-4330-9876-2A7F1B76FAE1}"/>
               </a:ext>
             </a:extLst>
           </p:cNvPr>
@@ -7428,7 +7428,7 @@
           <p:cNvPr id="21" name="">
             <a:extLst xmlns:a="http://schemas.openxmlformats.org/drawingml/2006/main">
               <a:ext uri="{FF2B5EF4-FFF2-40B4-BE49-F238E27FC236}">
-                <a16:creationId xmlns:a16="http://schemas.microsoft.com/office/drawing/2014/main" id="{25C998EB-01DA-42ED-9911-C00790E98560}"/>
+                <a16:creationId xmlns:a16="http://schemas.microsoft.com/office/drawing/2014/main" id="{286C8278-3919-422D-962B-79EBE97F455C}"/>
               </a:ext>
             </a:extLst>
           </p:cNvPr>
@@ -7461,7 +7461,7 @@
           <p:cNvPr id="22" name="">
             <a:extLst xmlns:a="http://schemas.openxmlformats.org/drawingml/2006/main">
               <a:ext uri="{FF2B5EF4-FFF2-40B4-BE49-F238E27FC236}">
-                <a16:creationId xmlns:a16="http://schemas.microsoft.com/office/drawing/2014/main" id="{4A004DF3-F8AC-4A43-85D2-FDAC5490AA0D}"/>
+                <a16:creationId xmlns:a16="http://schemas.microsoft.com/office/drawing/2014/main" id="{3FB113B6-8CDA-4281-AF83-EFC606250BCE}"/>
               </a:ext>
             </a:extLst>
           </p:cNvPr>
@@ -7511,7 +7511,7 @@
           <p:cNvPr id="23" name="">
             <a:extLst xmlns:a="http://schemas.openxmlformats.org/drawingml/2006/main">
               <a:ext uri="{FF2B5EF4-FFF2-40B4-BE49-F238E27FC236}">
-                <a16:creationId xmlns:a16="http://schemas.microsoft.com/office/drawing/2014/main" id="{1882A003-6262-4074-8DC2-B7621B85A232}"/>
+                <a16:creationId xmlns:a16="http://schemas.microsoft.com/office/drawing/2014/main" id="{3CCDB703-A4A7-4DF9-8B1B-9653F30211E0}"/>
               </a:ext>
             </a:extLst>
           </p:cNvPr>
@@ -7561,7 +7561,7 @@
           <p:cNvPr id="24" name="">
             <a:extLst xmlns:a="http://schemas.openxmlformats.org/drawingml/2006/main">
               <a:ext uri="{FF2B5EF4-FFF2-40B4-BE49-F238E27FC236}">
-                <a16:creationId xmlns:a16="http://schemas.microsoft.com/office/drawing/2014/main" id="{F90417F6-76C7-4BF6-A0EE-2B6D705E4E11}"/>
+                <a16:creationId xmlns:a16="http://schemas.microsoft.com/office/drawing/2014/main" id="{B25E268D-B8B7-4D1C-806F-D34A17A0D40B}"/>
               </a:ext>
             </a:extLst>
           </p:cNvPr>
@@ -7588,7 +7588,7 @@
           <p:cNvPr id="25" name="">
             <a:extLst xmlns:a="http://schemas.openxmlformats.org/drawingml/2006/main">
               <a:ext uri="{FF2B5EF4-FFF2-40B4-BE49-F238E27FC236}">
-                <a16:creationId xmlns:a16="http://schemas.microsoft.com/office/drawing/2014/main" id="{43B83F52-E360-46D1-AC57-343F5E42DA5C}"/>
+                <a16:creationId xmlns:a16="http://schemas.microsoft.com/office/drawing/2014/main" id="{D13A4009-3A54-46D3-9639-1C0C62B1BC6A}"/>
               </a:ext>
             </a:extLst>
           </p:cNvPr>
@@ -7640,7 +7640,7 @@
           <p:cNvPr id="27" name="">
             <a:extLst xmlns:a="http://schemas.openxmlformats.org/drawingml/2006/main">
               <a:ext uri="{FF2B5EF4-FFF2-40B4-BE49-F238E27FC236}">
-                <a16:creationId xmlns:a16="http://schemas.microsoft.com/office/drawing/2014/main" id="{FB60B038-8282-4C44-AA40-60E9AD70FFA1}"/>
+                <a16:creationId xmlns:a16="http://schemas.microsoft.com/office/drawing/2014/main" id="{D3A41B0B-F487-484C-9CE8-5C1ACD990B45}"/>
               </a:ext>
             </a:extLst>
           </p:cNvPr>
@@ -7673,7 +7673,7 @@
           <p:cNvPr id="28" name="">
             <a:extLst xmlns:a="http://schemas.openxmlformats.org/drawingml/2006/main">
               <a:ext uri="{FF2B5EF4-FFF2-40B4-BE49-F238E27FC236}">
-                <a16:creationId xmlns:a16="http://schemas.microsoft.com/office/drawing/2014/main" id="{98927433-7F97-4B65-AB7D-7586C969C097}"/>
+                <a16:creationId xmlns:a16="http://schemas.microsoft.com/office/drawing/2014/main" id="{0E9D37F2-E080-42D7-ABD4-741EC4662D04}"/>
               </a:ext>
             </a:extLst>
           </p:cNvPr>
@@ -7723,7 +7723,7 @@
           <p:cNvPr id="29" name="">
             <a:extLst xmlns:a="http://schemas.openxmlformats.org/drawingml/2006/main">
               <a:ext uri="{FF2B5EF4-FFF2-40B4-BE49-F238E27FC236}">
-                <a16:creationId xmlns:a16="http://schemas.microsoft.com/office/drawing/2014/main" id="{05333228-ECBB-4311-A85B-DA1C62D1C044}"/>
+                <a16:creationId xmlns:a16="http://schemas.microsoft.com/office/drawing/2014/main" id="{9706DBAE-6B8D-40DE-8702-7E72D2D29B52}"/>
               </a:ext>
             </a:extLst>
           </p:cNvPr>
@@ -7773,7 +7773,7 @@
           <p:cNvPr id="30" name="">
             <a:extLst xmlns:a="http://schemas.openxmlformats.org/drawingml/2006/main">
               <a:ext uri="{FF2B5EF4-FFF2-40B4-BE49-F238E27FC236}">
-                <a16:creationId xmlns:a16="http://schemas.microsoft.com/office/drawing/2014/main" id="{460C7B8D-01B1-4F4E-8B16-464651DA6510}"/>
+                <a16:creationId xmlns:a16="http://schemas.microsoft.com/office/drawing/2014/main" id="{97658BD4-89C3-4BF8-84FA-D87BE1E9A2F4}"/>
               </a:ext>
             </a:extLst>
           </p:cNvPr>
@@ -7800,7 +7800,7 @@
           <p:cNvPr id="31" name="">
             <a:extLst xmlns:a="http://schemas.openxmlformats.org/drawingml/2006/main">
               <a:ext uri="{FF2B5EF4-FFF2-40B4-BE49-F238E27FC236}">
-                <a16:creationId xmlns:a16="http://schemas.microsoft.com/office/drawing/2014/main" id="{9A3BD420-CF7B-44E1-939B-4C7C77C068C4}"/>
+                <a16:creationId xmlns:a16="http://schemas.microsoft.com/office/drawing/2014/main" id="{256CB9FD-DD1D-43E6-A4E5-076D6CFE24D3}"/>
               </a:ext>
             </a:extLst>
           </p:cNvPr>
@@ -7852,7 +7852,7 @@
           <p:cNvPr id="33" name="">
             <a:extLst xmlns:a="http://schemas.openxmlformats.org/drawingml/2006/main">
               <a:ext uri="{FF2B5EF4-FFF2-40B4-BE49-F238E27FC236}">
-                <a16:creationId xmlns:a16="http://schemas.microsoft.com/office/drawing/2014/main" id="{EEBEEF97-90D7-4D8B-BFF9-ABE97C950899}"/>
+                <a16:creationId xmlns:a16="http://schemas.microsoft.com/office/drawing/2014/main" id="{084D5AE3-7E7F-4878-85AB-668407BD92B2}"/>
               </a:ext>
             </a:extLst>
           </p:cNvPr>
@@ -7885,7 +7885,7 @@
           <p:cNvPr id="34" name="">
             <a:extLst xmlns:a="http://schemas.openxmlformats.org/drawingml/2006/main">
               <a:ext uri="{FF2B5EF4-FFF2-40B4-BE49-F238E27FC236}">
-                <a16:creationId xmlns:a16="http://schemas.microsoft.com/office/drawing/2014/main" id="{79457DBC-DA41-4B4E-BFA7-B1F4FDD851CD}"/>
+                <a16:creationId xmlns:a16="http://schemas.microsoft.com/office/drawing/2014/main" id="{2CDA5240-175D-4885-93B7-52CE6D9A1C51}"/>
               </a:ext>
             </a:extLst>
           </p:cNvPr>
@@ -7935,7 +7935,7 @@
           <p:cNvPr id="35" name="">
             <a:extLst xmlns:a="http://schemas.openxmlformats.org/drawingml/2006/main">
               <a:ext uri="{FF2B5EF4-FFF2-40B4-BE49-F238E27FC236}">
-                <a16:creationId xmlns:a16="http://schemas.microsoft.com/office/drawing/2014/main" id="{CDAC01E4-72A1-4BEA-913E-2FE13608253E}"/>
+                <a16:creationId xmlns:a16="http://schemas.microsoft.com/office/drawing/2014/main" id="{94F6DFB8-07F2-48D1-AE4E-AC435ABEBF52}"/>
               </a:ext>
             </a:extLst>
           </p:cNvPr>
@@ -7985,7 +7985,7 @@
           <p:cNvPr id="36" name="">
             <a:extLst xmlns:a="http://schemas.openxmlformats.org/drawingml/2006/main">
               <a:ext uri="{FF2B5EF4-FFF2-40B4-BE49-F238E27FC236}">
-                <a16:creationId xmlns:a16="http://schemas.microsoft.com/office/drawing/2014/main" id="{B5B86272-CA67-4EE5-A2E4-A262FE01971F}"/>
+                <a16:creationId xmlns:a16="http://schemas.microsoft.com/office/drawing/2014/main" id="{180A4665-3967-448A-843B-1A8C22C64C93}"/>
               </a:ext>
             </a:extLst>
           </p:cNvPr>
@@ -8020,7 +8020,7 @@
           <p:cNvPr id="37" name="">
             <a:extLst xmlns:a="http://schemas.openxmlformats.org/drawingml/2006/main">
               <a:ext uri="{FF2B5EF4-FFF2-40B4-BE49-F238E27FC236}">
-                <a16:creationId xmlns:a16="http://schemas.microsoft.com/office/drawing/2014/main" id="{289C2F9C-FE1D-4907-B0A1-BAC3FEA5E3C7}"/>
+                <a16:creationId xmlns:a16="http://schemas.microsoft.com/office/drawing/2014/main" id="{FCD98622-B7DC-47BF-8A02-E93AD84BECE6}"/>
               </a:ext>
             </a:extLst>
           </p:cNvPr>
@@ -8047,7 +8047,7 @@
           <p:cNvPr id="38" name="">
             <a:extLst xmlns:a="http://schemas.openxmlformats.org/drawingml/2006/main">
               <a:ext uri="{FF2B5EF4-FFF2-40B4-BE49-F238E27FC236}">
-                <a16:creationId xmlns:a16="http://schemas.microsoft.com/office/drawing/2014/main" id="{1B5C5B47-CCEC-46CB-8319-E71D8889767A}"/>
+                <a16:creationId xmlns:a16="http://schemas.microsoft.com/office/drawing/2014/main" id="{AE5C8851-FF12-4604-8659-B363E04B0EE0}"/>
               </a:ext>
             </a:extLst>
           </p:cNvPr>
@@ -8100,7 +8100,7 @@
           <p:cNvPr id="40" name="">
             <a:extLst xmlns:a="http://schemas.openxmlformats.org/drawingml/2006/main">
               <a:ext uri="{FF2B5EF4-FFF2-40B4-BE49-F238E27FC236}">
-                <a16:creationId xmlns:a16="http://schemas.microsoft.com/office/drawing/2014/main" id="{844BE342-FF1D-45B2-A007-A172D77C0EC3}"/>
+                <a16:creationId xmlns:a16="http://schemas.microsoft.com/office/drawing/2014/main" id="{A9C1C359-C9C1-4CFB-94B8-ADC5095D917E}"/>
               </a:ext>
             </a:extLst>
           </p:cNvPr>
@@ -8127,7 +8127,7 @@
           <p:cNvPr id="41" name="">
             <a:extLst xmlns:a="http://schemas.openxmlformats.org/drawingml/2006/main">
               <a:ext uri="{FF2B5EF4-FFF2-40B4-BE49-F238E27FC236}">
-                <a16:creationId xmlns:a16="http://schemas.microsoft.com/office/drawing/2014/main" id="{D1CEE845-98B2-472D-AEE1-C497BB902EB9}"/>
+                <a16:creationId xmlns:a16="http://schemas.microsoft.com/office/drawing/2014/main" id="{78CD9251-F4F7-40B7-ACD0-E2D73B47153A}"/>
               </a:ext>
             </a:extLst>
           </p:cNvPr>
@@ -8180,7 +8180,7 @@
           <p:cNvPr id="43" name="">
             <a:extLst xmlns:a="http://schemas.openxmlformats.org/drawingml/2006/main">
               <a:ext uri="{FF2B5EF4-FFF2-40B4-BE49-F238E27FC236}">
-                <a16:creationId xmlns:a16="http://schemas.microsoft.com/office/drawing/2014/main" id="{7BC09DED-EECC-49F9-A76B-363761D6AE7B}"/>
+                <a16:creationId xmlns:a16="http://schemas.microsoft.com/office/drawing/2014/main" id="{C180AD14-B422-4E64-8877-786C33FF9759}"/>
               </a:ext>
             </a:extLst>
           </p:cNvPr>
@@ -8236,7 +8236,7 @@
           <p:cNvPr id="44" name="">
             <a:extLst xmlns:a="http://schemas.openxmlformats.org/drawingml/2006/main">
               <a:ext uri="{FF2B5EF4-FFF2-40B4-BE49-F238E27FC236}">
-                <a16:creationId xmlns:a16="http://schemas.microsoft.com/office/drawing/2014/main" id="{194AC477-F030-45A8-8450-34793274B210}"/>
+                <a16:creationId xmlns:a16="http://schemas.microsoft.com/office/drawing/2014/main" id="{29D0D3CD-D576-42C8-BD97-C617EB2910A2}"/>
               </a:ext>
             </a:extLst>
           </p:cNvPr>
@@ -8286,7 +8286,7 @@
           <p:cNvPr id="45" name="">
             <a:extLst xmlns:a="http://schemas.openxmlformats.org/drawingml/2006/main">
               <a:ext uri="{FF2B5EF4-FFF2-40B4-BE49-F238E27FC236}">
-                <a16:creationId xmlns:a16="http://schemas.microsoft.com/office/drawing/2014/main" id="{5B074372-23C3-4446-B3D8-825DDBD89CAC}"/>
+                <a16:creationId xmlns:a16="http://schemas.microsoft.com/office/drawing/2014/main" id="{91873EB5-4ADB-4CB7-AEFF-E95B79D3DF61}"/>
               </a:ext>
             </a:extLst>
           </p:cNvPr>
@@ -8321,7 +8321,7 @@
           <p:cNvPr id="46" name="">
             <a:extLst xmlns:a="http://schemas.openxmlformats.org/drawingml/2006/main">
               <a:ext uri="{FF2B5EF4-FFF2-40B4-BE49-F238E27FC236}">
-                <a16:creationId xmlns:a16="http://schemas.microsoft.com/office/drawing/2014/main" id="{183634A4-F376-42FD-A705-3D19DC355365}"/>
+                <a16:creationId xmlns:a16="http://schemas.microsoft.com/office/drawing/2014/main" id="{0D987B7A-550F-42A6-9391-5D58E4FA3C1F}"/>
               </a:ext>
             </a:extLst>
           </p:cNvPr>
@@ -8371,7 +8371,7 @@
           <p:cNvPr id="47" name="">
             <a:extLst xmlns:a="http://schemas.openxmlformats.org/drawingml/2006/main">
               <a:ext uri="{FF2B5EF4-FFF2-40B4-BE49-F238E27FC236}">
-                <a16:creationId xmlns:a16="http://schemas.microsoft.com/office/drawing/2014/main" id="{F205AAE8-44E7-459F-9609-2B3E11917ED7}"/>
+                <a16:creationId xmlns:a16="http://schemas.microsoft.com/office/drawing/2014/main" id="{5EBCFD2F-7818-4EF2-8CE2-95C4A7939770}"/>
               </a:ext>
             </a:extLst>
           </p:cNvPr>
@@ -8404,7 +8404,7 @@
           <p:cNvPr id="48" name="">
             <a:extLst xmlns:a="http://schemas.openxmlformats.org/drawingml/2006/main">
               <a:ext uri="{FF2B5EF4-FFF2-40B4-BE49-F238E27FC236}">
-                <a16:creationId xmlns:a16="http://schemas.microsoft.com/office/drawing/2014/main" id="{699247D0-34FA-4C43-8F3B-2B3ED2B26765}"/>
+                <a16:creationId xmlns:a16="http://schemas.microsoft.com/office/drawing/2014/main" id="{C50D6391-93A0-46F0-A48A-B3B97DA1F736}"/>
               </a:ext>
             </a:extLst>
           </p:cNvPr>
@@ -8442,7 +8442,7 @@
           <p:cNvPr id="49" name="">
             <a:extLst xmlns:a="http://schemas.openxmlformats.org/drawingml/2006/main">
               <a:ext uri="{FF2B5EF4-FFF2-40B4-BE49-F238E27FC236}">
-                <a16:creationId xmlns:a16="http://schemas.microsoft.com/office/drawing/2014/main" id="{046B8212-95B1-420B-A09E-413910372856}"/>
+                <a16:creationId xmlns:a16="http://schemas.microsoft.com/office/drawing/2014/main" id="{7294D778-0A1E-4CD2-AF48-DCD669B1ECFA}"/>
               </a:ext>
             </a:extLst>
           </p:cNvPr>
@@ -8475,7 +8475,7 @@
           <p:cNvPr id="50" name="">
             <a:extLst xmlns:a="http://schemas.openxmlformats.org/drawingml/2006/main">
               <a:ext uri="{FF2B5EF4-FFF2-40B4-BE49-F238E27FC236}">
-                <a16:creationId xmlns:a16="http://schemas.microsoft.com/office/drawing/2014/main" id="{90509DED-9DC7-4F45-8583-94E77743A9CE}"/>
+                <a16:creationId xmlns:a16="http://schemas.microsoft.com/office/drawing/2014/main" id="{EA69F62B-3185-49B8-B571-BD2FC2A4FBFB}"/>
               </a:ext>
             </a:extLst>
           </p:cNvPr>
@@ -8525,7 +8525,7 @@
           <p:cNvPr id="51" name="">
             <a:extLst xmlns:a="http://schemas.openxmlformats.org/drawingml/2006/main">
               <a:ext uri="{FF2B5EF4-FFF2-40B4-BE49-F238E27FC236}">
-                <a16:creationId xmlns:a16="http://schemas.microsoft.com/office/drawing/2014/main" id="{DFB7DB11-47C3-4954-B5E9-22F3FAA512BF}"/>
+                <a16:creationId xmlns:a16="http://schemas.microsoft.com/office/drawing/2014/main" id="{A234E627-932A-46AF-ACEC-1FEFDDF16D55}"/>
               </a:ext>
             </a:extLst>
           </p:cNvPr>
@@ -8558,7 +8558,7 @@
           <p:cNvPr id="52" name="">
             <a:extLst xmlns:a="http://schemas.openxmlformats.org/drawingml/2006/main">
               <a:ext uri="{FF2B5EF4-FFF2-40B4-BE49-F238E27FC236}">
-                <a16:creationId xmlns:a16="http://schemas.microsoft.com/office/drawing/2014/main" id="{F5F6841D-C5FE-432B-BF00-7F19BB595B84}"/>
+                <a16:creationId xmlns:a16="http://schemas.microsoft.com/office/drawing/2014/main" id="{409F120C-4D4F-4B89-B3A7-44D31D4D794D}"/>
               </a:ext>
             </a:extLst>
           </p:cNvPr>
@@ -8608,7 +8608,7 @@
           <p:cNvPr id="53" name="">
             <a:extLst xmlns:a="http://schemas.openxmlformats.org/drawingml/2006/main">
               <a:ext uri="{FF2B5EF4-FFF2-40B4-BE49-F238E27FC236}">
-                <a16:creationId xmlns:a16="http://schemas.microsoft.com/office/drawing/2014/main" id="{EA2F3D59-5AFB-42C9-804B-CB19D5EC5DE0}"/>
+                <a16:creationId xmlns:a16="http://schemas.microsoft.com/office/drawing/2014/main" id="{E4F7D8AE-CC9A-42C7-BFA0-B966F59CF479}"/>
               </a:ext>
             </a:extLst>
           </p:cNvPr>
@@ -8641,7 +8641,7 @@
           <p:cNvPr id="54" name="">
             <a:extLst xmlns:a="http://schemas.openxmlformats.org/drawingml/2006/main">
               <a:ext uri="{FF2B5EF4-FFF2-40B4-BE49-F238E27FC236}">
-                <a16:creationId xmlns:a16="http://schemas.microsoft.com/office/drawing/2014/main" id="{BC1170F8-EDE8-480C-8ACB-07866394BF12}"/>
+                <a16:creationId xmlns:a16="http://schemas.microsoft.com/office/drawing/2014/main" id="{D2A91A38-8467-43A7-A60A-89D9421B6AF5}"/>
               </a:ext>
             </a:extLst>
           </p:cNvPr>
@@ -8691,7 +8691,7 @@
           <p:cNvPr id="55" name="">
             <a:extLst xmlns:a="http://schemas.openxmlformats.org/drawingml/2006/main">
               <a:ext uri="{FF2B5EF4-FFF2-40B4-BE49-F238E27FC236}">
-                <a16:creationId xmlns:a16="http://schemas.microsoft.com/office/drawing/2014/main" id="{B7A31F51-9246-4A35-AD23-9C381390DA6D}"/>
+                <a16:creationId xmlns:a16="http://schemas.microsoft.com/office/drawing/2014/main" id="{474B6F9A-E70D-4F3B-8D53-F4F33D40D3B9}"/>
               </a:ext>
             </a:extLst>
           </p:cNvPr>
@@ -8724,7 +8724,7 @@
           <p:cNvPr id="56" name="">
             <a:extLst xmlns:a="http://schemas.openxmlformats.org/drawingml/2006/main">
               <a:ext uri="{FF2B5EF4-FFF2-40B4-BE49-F238E27FC236}">
-                <a16:creationId xmlns:a16="http://schemas.microsoft.com/office/drawing/2014/main" id="{C4711D4C-9A3F-459A-B253-C114C1633A33}"/>
+                <a16:creationId xmlns:a16="http://schemas.microsoft.com/office/drawing/2014/main" id="{1B16348E-05F9-4FAC-BB2D-AF801117B217}"/>
               </a:ext>
             </a:extLst>
           </p:cNvPr>
@@ -8774,7 +8774,7 @@
           <p:cNvPr id="57" name="">
             <a:extLst xmlns:a="http://schemas.openxmlformats.org/drawingml/2006/main">
               <a:ext uri="{FF2B5EF4-FFF2-40B4-BE49-F238E27FC236}">
-                <a16:creationId xmlns:a16="http://schemas.microsoft.com/office/drawing/2014/main" id="{9417F1B3-3800-4F2D-A3C1-7C8CFA1973D6}"/>
+                <a16:creationId xmlns:a16="http://schemas.microsoft.com/office/drawing/2014/main" id="{C0C41F76-2BF2-4D29-9222-3113315FC008}"/>
               </a:ext>
             </a:extLst>
           </p:cNvPr>
@@ -8807,7 +8807,7 @@
           <p:cNvPr id="58" name="">
             <a:extLst xmlns:a="http://schemas.openxmlformats.org/drawingml/2006/main">
               <a:ext uri="{FF2B5EF4-FFF2-40B4-BE49-F238E27FC236}">
-                <a16:creationId xmlns:a16="http://schemas.microsoft.com/office/drawing/2014/main" id="{933A5B5D-1410-45BA-9078-FAE03735DDAB}"/>
+                <a16:creationId xmlns:a16="http://schemas.microsoft.com/office/drawing/2014/main" id="{03276886-2F5D-4AE6-B0E5-B387B891BDB2}"/>
               </a:ext>
             </a:extLst>
           </p:cNvPr>
@@ -8857,7 +8857,7 @@
           <p:cNvPr id="59" name="">
             <a:extLst xmlns:a="http://schemas.openxmlformats.org/drawingml/2006/main">
               <a:ext uri="{FF2B5EF4-FFF2-40B4-BE49-F238E27FC236}">
-                <a16:creationId xmlns:a16="http://schemas.microsoft.com/office/drawing/2014/main" id="{1BF81192-5A2B-4480-BAE4-A9989285A02E}"/>
+                <a16:creationId xmlns:a16="http://schemas.microsoft.com/office/drawing/2014/main" id="{8F584B45-546C-467D-9245-44BBCEE3CF53}"/>
               </a:ext>
             </a:extLst>
           </p:cNvPr>
@@ -8890,7 +8890,7 @@
           <p:cNvPr id="60" name="">
             <a:extLst xmlns:a="http://schemas.openxmlformats.org/drawingml/2006/main">
               <a:ext uri="{FF2B5EF4-FFF2-40B4-BE49-F238E27FC236}">
-                <a16:creationId xmlns:a16="http://schemas.microsoft.com/office/drawing/2014/main" id="{B56DCB6F-82AC-4AF1-8D72-C9C78DE6E2B5}"/>
+                <a16:creationId xmlns:a16="http://schemas.microsoft.com/office/drawing/2014/main" id="{EF4514D3-F828-46AD-A66A-12221E6980CC}"/>
               </a:ext>
             </a:extLst>
           </p:cNvPr>
@@ -8940,7 +8940,7 @@
           <p:cNvPr id="61" name="">
             <a:extLst xmlns:a="http://schemas.openxmlformats.org/drawingml/2006/main">
               <a:ext uri="{FF2B5EF4-FFF2-40B4-BE49-F238E27FC236}">
-                <a16:creationId xmlns:a16="http://schemas.microsoft.com/office/drawing/2014/main" id="{BC7133D6-2DA5-4290-86B3-517E724CD2AA}"/>
+                <a16:creationId xmlns:a16="http://schemas.microsoft.com/office/drawing/2014/main" id="{7E25AF31-B609-4135-A71E-BD4EE3D3F616}"/>
               </a:ext>
             </a:extLst>
           </p:cNvPr>
@@ -8973,7 +8973,7 @@
           <p:cNvPr id="62" name="">
             <a:extLst xmlns:a="http://schemas.openxmlformats.org/drawingml/2006/main">
               <a:ext uri="{FF2B5EF4-FFF2-40B4-BE49-F238E27FC236}">
-                <a16:creationId xmlns:a16="http://schemas.microsoft.com/office/drawing/2014/main" id="{0856D0C1-8875-41CA-920A-1F20C6916629}"/>
+                <a16:creationId xmlns:a16="http://schemas.microsoft.com/office/drawing/2014/main" id="{E723EC74-8E65-4F17-97D3-90E749C7351E}"/>
               </a:ext>
             </a:extLst>
           </p:cNvPr>
@@ -9023,7 +9023,7 @@
           <p:cNvPr id="63" name="">
             <a:extLst xmlns:a="http://schemas.openxmlformats.org/drawingml/2006/main">
               <a:ext uri="{FF2B5EF4-FFF2-40B4-BE49-F238E27FC236}">
-                <a16:creationId xmlns:a16="http://schemas.microsoft.com/office/drawing/2014/main" id="{83FA3D4F-1E54-487F-842F-A2F96B1571A2}"/>
+                <a16:creationId xmlns:a16="http://schemas.microsoft.com/office/drawing/2014/main" id="{AC31D186-A783-41DA-AF3D-279C4397A2AC}"/>
               </a:ext>
             </a:extLst>
           </p:cNvPr>
@@ -9056,7 +9056,7 @@
           <p:cNvPr id="64" name="">
             <a:extLst xmlns:a="http://schemas.openxmlformats.org/drawingml/2006/main">
               <a:ext uri="{FF2B5EF4-FFF2-40B4-BE49-F238E27FC236}">
-                <a16:creationId xmlns:a16="http://schemas.microsoft.com/office/drawing/2014/main" id="{9AFFD90A-4C06-44CE-9EBB-B495A36DADF5}"/>
+                <a16:creationId xmlns:a16="http://schemas.microsoft.com/office/drawing/2014/main" id="{E939C0E1-9498-42D6-9B8D-D4990902BECF}"/>
               </a:ext>
             </a:extLst>
           </p:cNvPr>
@@ -9106,7 +9106,7 @@
           <p:cNvPr id="65" name="">
             <a:extLst xmlns:a="http://schemas.openxmlformats.org/drawingml/2006/main">
               <a:ext uri="{FF2B5EF4-FFF2-40B4-BE49-F238E27FC236}">
-                <a16:creationId xmlns:a16="http://schemas.microsoft.com/office/drawing/2014/main" id="{88D2D712-5D68-43EF-95CF-5FD1952179E2}"/>
+                <a16:creationId xmlns:a16="http://schemas.microsoft.com/office/drawing/2014/main" id="{7F682023-9241-4F8D-B863-1A46D3F53264}"/>
               </a:ext>
             </a:extLst>
           </p:cNvPr>
@@ -9139,7 +9139,7 @@
           <p:cNvPr id="66" name="">
             <a:extLst xmlns:a="http://schemas.openxmlformats.org/drawingml/2006/main">
               <a:ext uri="{FF2B5EF4-FFF2-40B4-BE49-F238E27FC236}">
-                <a16:creationId xmlns:a16="http://schemas.microsoft.com/office/drawing/2014/main" id="{C4153833-A0C3-44AC-9850-0C23D4C03FEF}"/>
+                <a16:creationId xmlns:a16="http://schemas.microsoft.com/office/drawing/2014/main" id="{759A9C45-2FF8-4762-95E7-02B045B89EE7}"/>
               </a:ext>
             </a:extLst>
           </p:cNvPr>
@@ -9189,7 +9189,7 @@
           <p:cNvPr id="67" name="">
             <a:extLst xmlns:a="http://schemas.openxmlformats.org/drawingml/2006/main">
               <a:ext uri="{FF2B5EF4-FFF2-40B4-BE49-F238E27FC236}">
-                <a16:creationId xmlns:a16="http://schemas.microsoft.com/office/drawing/2014/main" id="{0335BE26-FF32-4259-9FFE-049A3E4EC92D}"/>
+                <a16:creationId xmlns:a16="http://schemas.microsoft.com/office/drawing/2014/main" id="{06B3C882-056C-466A-9A86-52F7F130180A}"/>
               </a:ext>
             </a:extLst>
           </p:cNvPr>
@@ -9222,7 +9222,7 @@
           <p:cNvPr id="68" name="">
             <a:extLst xmlns:a="http://schemas.openxmlformats.org/drawingml/2006/main">
               <a:ext uri="{FF2B5EF4-FFF2-40B4-BE49-F238E27FC236}">
-                <a16:creationId xmlns:a16="http://schemas.microsoft.com/office/drawing/2014/main" id="{3C78B839-36D7-413A-BC8B-B70580C8D2CF}"/>
+                <a16:creationId xmlns:a16="http://schemas.microsoft.com/office/drawing/2014/main" id="{39BD9116-E302-4CC0-97E7-CE50276D8905}"/>
               </a:ext>
             </a:extLst>
           </p:cNvPr>
@@ -9272,7 +9272,7 @@
           <p:cNvPr id="69" name="">
             <a:extLst xmlns:a="http://schemas.openxmlformats.org/drawingml/2006/main">
               <a:ext uri="{FF2B5EF4-FFF2-40B4-BE49-F238E27FC236}">
-                <a16:creationId xmlns:a16="http://schemas.microsoft.com/office/drawing/2014/main" id="{831B3162-32A2-4AB2-B5F6-F0D1470120CC}"/>
+                <a16:creationId xmlns:a16="http://schemas.microsoft.com/office/drawing/2014/main" id="{A1BF8A7C-02F8-442A-881E-BE106448DC98}"/>
               </a:ext>
             </a:extLst>
           </p:cNvPr>
@@ -9305,7 +9305,7 @@
           <p:cNvPr id="70" name="">
             <a:extLst xmlns:a="http://schemas.openxmlformats.org/drawingml/2006/main">
               <a:ext uri="{FF2B5EF4-FFF2-40B4-BE49-F238E27FC236}">
-                <a16:creationId xmlns:a16="http://schemas.microsoft.com/office/drawing/2014/main" id="{3F4F21CF-5BAA-429B-8ADD-D3F9E39847BB}"/>
+                <a16:creationId xmlns:a16="http://schemas.microsoft.com/office/drawing/2014/main" id="{C45A3C75-E9BB-46BF-98A9-2E0CE462D8DE}"/>
               </a:ext>
             </a:extLst>
           </p:cNvPr>
@@ -9355,7 +9355,7 @@
           <p:cNvPr id="71" name="">
             <a:extLst xmlns:a="http://schemas.openxmlformats.org/drawingml/2006/main">
               <a:ext uri="{FF2B5EF4-FFF2-40B4-BE49-F238E27FC236}">
-                <a16:creationId xmlns:a16="http://schemas.microsoft.com/office/drawing/2014/main" id="{11714C91-805A-4817-A094-6EB7CEC4595A}"/>
+                <a16:creationId xmlns:a16="http://schemas.microsoft.com/office/drawing/2014/main" id="{A8078043-0C11-4139-8C7A-E97B37EE8B9A}"/>
               </a:ext>
             </a:extLst>
           </p:cNvPr>
@@ -9388,7 +9388,7 @@
           <p:cNvPr id="72" name="">
             <a:extLst xmlns:a="http://schemas.openxmlformats.org/drawingml/2006/main">
               <a:ext uri="{FF2B5EF4-FFF2-40B4-BE49-F238E27FC236}">
-                <a16:creationId xmlns:a16="http://schemas.microsoft.com/office/drawing/2014/main" id="{A7F61F6E-BBB1-461B-9419-8A4AC952796F}"/>
+                <a16:creationId xmlns:a16="http://schemas.microsoft.com/office/drawing/2014/main" id="{01216240-BACE-481B-B679-16857938B492}"/>
               </a:ext>
             </a:extLst>
           </p:cNvPr>
@@ -9438,7 +9438,7 @@
           <p:cNvPr id="73" name="">
             <a:extLst xmlns:a="http://schemas.openxmlformats.org/drawingml/2006/main">
               <a:ext uri="{FF2B5EF4-FFF2-40B4-BE49-F238E27FC236}">
-                <a16:creationId xmlns:a16="http://schemas.microsoft.com/office/drawing/2014/main" id="{6B49B590-D8C6-4716-A6B1-40947467D2D8}"/>
+                <a16:creationId xmlns:a16="http://schemas.microsoft.com/office/drawing/2014/main" id="{E23F390C-83B9-4933-8A1E-7905426DE079}"/>
               </a:ext>
             </a:extLst>
           </p:cNvPr>
@@ -9471,7 +9471,7 @@
           <p:cNvPr id="74" name="">
             <a:extLst xmlns:a="http://schemas.openxmlformats.org/drawingml/2006/main">
               <a:ext uri="{FF2B5EF4-FFF2-40B4-BE49-F238E27FC236}">
-                <a16:creationId xmlns:a16="http://schemas.microsoft.com/office/drawing/2014/main" id="{893BEA68-11A5-47A9-AD25-96154D23CD21}"/>
+                <a16:creationId xmlns:a16="http://schemas.microsoft.com/office/drawing/2014/main" id="{B0FE7094-7928-4922-B24C-E00C1E6FB1BA}"/>
               </a:ext>
             </a:extLst>
           </p:cNvPr>
@@ -9521,7 +9521,7 @@
           <p:cNvPr id="75" name="">
             <a:extLst xmlns:a="http://schemas.openxmlformats.org/drawingml/2006/main">
               <a:ext uri="{FF2B5EF4-FFF2-40B4-BE49-F238E27FC236}">
-                <a16:creationId xmlns:a16="http://schemas.microsoft.com/office/drawing/2014/main" id="{9240E24D-FD50-403B-BBD1-B809AF1A9A06}"/>
+                <a16:creationId xmlns:a16="http://schemas.microsoft.com/office/drawing/2014/main" id="{1DC9F007-EFCF-48FE-A812-50F89A2EE19B}"/>
               </a:ext>
             </a:extLst>
           </p:cNvPr>
@@ -9554,7 +9554,7 @@
           <p:cNvPr id="76" name="">
             <a:extLst xmlns:a="http://schemas.openxmlformats.org/drawingml/2006/main">
               <a:ext uri="{FF2B5EF4-FFF2-40B4-BE49-F238E27FC236}">
-                <a16:creationId xmlns:a16="http://schemas.microsoft.com/office/drawing/2014/main" id="{CB83AB70-B78F-4DF0-B2B3-E0F6C0FDA768}"/>
+                <a16:creationId xmlns:a16="http://schemas.microsoft.com/office/drawing/2014/main" id="{997F8786-DBB7-4A94-BDF0-1DCE497DE10B}"/>
               </a:ext>
             </a:extLst>
           </p:cNvPr>
@@ -9604,7 +9604,7 @@
           <p:cNvPr id="77" name="">
             <a:extLst xmlns:a="http://schemas.openxmlformats.org/drawingml/2006/main">
               <a:ext uri="{FF2B5EF4-FFF2-40B4-BE49-F238E27FC236}">
-                <a16:creationId xmlns:a16="http://schemas.microsoft.com/office/drawing/2014/main" id="{B8895B07-7ED1-4F74-97BF-592E3FC4C115}"/>
+                <a16:creationId xmlns:a16="http://schemas.microsoft.com/office/drawing/2014/main" id="{2B450F78-ABAB-4B86-A197-026F7BF0E819}"/>
               </a:ext>
             </a:extLst>
           </p:cNvPr>
@@ -9637,7 +9637,7 @@
           <p:cNvPr id="78" name="">
             <a:extLst xmlns:a="http://schemas.openxmlformats.org/drawingml/2006/main">
               <a:ext uri="{FF2B5EF4-FFF2-40B4-BE49-F238E27FC236}">
-                <a16:creationId xmlns:a16="http://schemas.microsoft.com/office/drawing/2014/main" id="{FC8EFD1F-B7A7-4929-A223-7FE963F61598}"/>
+                <a16:creationId xmlns:a16="http://schemas.microsoft.com/office/drawing/2014/main" id="{A1827C08-6371-43ED-B9B9-B600E72A8F65}"/>
               </a:ext>
             </a:extLst>
           </p:cNvPr>
@@ -9687,7 +9687,7 @@
           <p:cNvPr id="79" name="">
             <a:extLst xmlns:a="http://schemas.openxmlformats.org/drawingml/2006/main">
               <a:ext uri="{FF2B5EF4-FFF2-40B4-BE49-F238E27FC236}">
-                <a16:creationId xmlns:a16="http://schemas.microsoft.com/office/drawing/2014/main" id="{40AECEBD-33F7-43E2-AEF2-E60CFD2F4016}"/>
+                <a16:creationId xmlns:a16="http://schemas.microsoft.com/office/drawing/2014/main" id="{D46FC3C3-8E1F-4543-AC3A-A85294E61286}"/>
               </a:ext>
             </a:extLst>
           </p:cNvPr>
@@ -9720,7 +9720,7 @@
           <p:cNvPr id="80" name="">
             <a:extLst xmlns:a="http://schemas.openxmlformats.org/drawingml/2006/main">
               <a:ext uri="{FF2B5EF4-FFF2-40B4-BE49-F238E27FC236}">
-                <a16:creationId xmlns:a16="http://schemas.microsoft.com/office/drawing/2014/main" id="{DFB0E543-98C7-4E89-B121-5D3CF3E11575}"/>
+                <a16:creationId xmlns:a16="http://schemas.microsoft.com/office/drawing/2014/main" id="{D6EC206A-C71D-4040-ABD5-406ECD818D1E}"/>
               </a:ext>
             </a:extLst>
           </p:cNvPr>
@@ -9770,7 +9770,7 @@
           <p:cNvPr id="81" name="">
             <a:extLst xmlns:a="http://schemas.openxmlformats.org/drawingml/2006/main">
               <a:ext uri="{FF2B5EF4-FFF2-40B4-BE49-F238E27FC236}">
-                <a16:creationId xmlns:a16="http://schemas.microsoft.com/office/drawing/2014/main" id="{ADD0D8AE-453E-444B-853C-EB97905B14B9}"/>
+                <a16:creationId xmlns:a16="http://schemas.microsoft.com/office/drawing/2014/main" id="{3D1E5758-24DA-4D82-A9B8-20CAB07296EC}"/>
               </a:ext>
             </a:extLst>
           </p:cNvPr>
@@ -9803,7 +9803,7 @@
           <p:cNvPr id="82" name="">
             <a:extLst xmlns:a="http://schemas.openxmlformats.org/drawingml/2006/main">
               <a:ext uri="{FF2B5EF4-FFF2-40B4-BE49-F238E27FC236}">
-                <a16:creationId xmlns:a16="http://schemas.microsoft.com/office/drawing/2014/main" id="{222A1EF1-A5CA-4C54-B28E-7785634E6A49}"/>
+                <a16:creationId xmlns:a16="http://schemas.microsoft.com/office/drawing/2014/main" id="{C75EFEF4-41A9-43AF-9FBA-1E47AE133D5E}"/>
               </a:ext>
             </a:extLst>
           </p:cNvPr>
@@ -9853,7 +9853,7 @@
           <p:cNvPr id="83" name="">
             <a:extLst xmlns:a="http://schemas.openxmlformats.org/drawingml/2006/main">
               <a:ext uri="{FF2B5EF4-FFF2-40B4-BE49-F238E27FC236}">
-                <a16:creationId xmlns:a16="http://schemas.microsoft.com/office/drawing/2014/main" id="{E866F5F9-515B-4121-B01B-8CCC27F78D8C}"/>
+                <a16:creationId xmlns:a16="http://schemas.microsoft.com/office/drawing/2014/main" id="{4822015D-8442-48D1-8214-4780768CE9CE}"/>
               </a:ext>
             </a:extLst>
           </p:cNvPr>
@@ -9886,7 +9886,7 @@
           <p:cNvPr id="84" name="">
             <a:extLst xmlns:a="http://schemas.openxmlformats.org/drawingml/2006/main">
               <a:ext uri="{FF2B5EF4-FFF2-40B4-BE49-F238E27FC236}">
-                <a16:creationId xmlns:a16="http://schemas.microsoft.com/office/drawing/2014/main" id="{092D8467-98FA-481A-9192-C79828D7DFDF}"/>
+                <a16:creationId xmlns:a16="http://schemas.microsoft.com/office/drawing/2014/main" id="{1B6386F8-7F32-4545-9D6F-D088397732C9}"/>
               </a:ext>
             </a:extLst>
           </p:cNvPr>
@@ -9936,7 +9936,7 @@
           <p:cNvPr id="85" name="">
             <a:extLst xmlns:a="http://schemas.openxmlformats.org/drawingml/2006/main">
               <a:ext uri="{FF2B5EF4-FFF2-40B4-BE49-F238E27FC236}">
-                <a16:creationId xmlns:a16="http://schemas.microsoft.com/office/drawing/2014/main" id="{AFC90647-B716-4F18-953F-7DAF1C8F48AD}"/>
+                <a16:creationId xmlns:a16="http://schemas.microsoft.com/office/drawing/2014/main" id="{DD9B9DCD-E948-4FB5-9837-D6F22898D312}"/>
               </a:ext>
             </a:extLst>
           </p:cNvPr>
@@ -9969,7 +9969,7 @@
           <p:cNvPr id="86" name="">
             <a:extLst xmlns:a="http://schemas.openxmlformats.org/drawingml/2006/main">
               <a:ext uri="{FF2B5EF4-FFF2-40B4-BE49-F238E27FC236}">
-                <a16:creationId xmlns:a16="http://schemas.microsoft.com/office/drawing/2014/main" id="{86F7B337-B4B6-4792-A07A-66B512047B8F}"/>
+                <a16:creationId xmlns:a16="http://schemas.microsoft.com/office/drawing/2014/main" id="{22C607B6-6861-4CF0-9A23-83FCF80AC1AD}"/>
               </a:ext>
             </a:extLst>
           </p:cNvPr>
@@ -10019,7 +10019,7 @@
           <p:cNvPr id="87" name="">
             <a:extLst xmlns:a="http://schemas.openxmlformats.org/drawingml/2006/main">
               <a:ext uri="{FF2B5EF4-FFF2-40B4-BE49-F238E27FC236}">
-                <a16:creationId xmlns:a16="http://schemas.microsoft.com/office/drawing/2014/main" id="{B97ADAAB-6536-4F10-9FA4-7F862B16F6DD}"/>
+                <a16:creationId xmlns:a16="http://schemas.microsoft.com/office/drawing/2014/main" id="{EE57FC11-EC5B-44F0-BD35-424E6A11CC9F}"/>
               </a:ext>
             </a:extLst>
           </p:cNvPr>
@@ -10052,7 +10052,7 @@
           <p:cNvPr id="88" name="">
             <a:extLst xmlns:a="http://schemas.openxmlformats.org/drawingml/2006/main">
               <a:ext uri="{FF2B5EF4-FFF2-40B4-BE49-F238E27FC236}">
-                <a16:creationId xmlns:a16="http://schemas.microsoft.com/office/drawing/2014/main" id="{35E42A60-8887-4BA6-975F-C09C631261A8}"/>
+                <a16:creationId xmlns:a16="http://schemas.microsoft.com/office/drawing/2014/main" id="{042AB607-DC90-4177-A51E-EF165E2A78CA}"/>
               </a:ext>
             </a:extLst>
           </p:cNvPr>
@@ -10102,7 +10102,7 @@
           <p:cNvPr id="89" name="">
             <a:extLst xmlns:a="http://schemas.openxmlformats.org/drawingml/2006/main">
               <a:ext uri="{FF2B5EF4-FFF2-40B4-BE49-F238E27FC236}">
-                <a16:creationId xmlns:a16="http://schemas.microsoft.com/office/drawing/2014/main" id="{41D06D7D-CE6D-4991-A0A6-77BD8757A3DB}"/>
+                <a16:creationId xmlns:a16="http://schemas.microsoft.com/office/drawing/2014/main" id="{C58AC522-B44E-4D16-9B1F-7FDD6A38DDB1}"/>
               </a:ext>
             </a:extLst>
           </p:cNvPr>
@@ -10135,7 +10135,7 @@
           <p:cNvPr id="90" name="">
             <a:extLst xmlns:a="http://schemas.openxmlformats.org/drawingml/2006/main">
               <a:ext uri="{FF2B5EF4-FFF2-40B4-BE49-F238E27FC236}">
-                <a16:creationId xmlns:a16="http://schemas.microsoft.com/office/drawing/2014/main" id="{2E9D9410-FE47-4228-AA1D-1385D737D04B}"/>
+                <a16:creationId xmlns:a16="http://schemas.microsoft.com/office/drawing/2014/main" id="{FCD86AFC-525C-4977-A8EB-F9B789F0D1BC}"/>
               </a:ext>
             </a:extLst>
           </p:cNvPr>
@@ -10185,7 +10185,7 @@
           <p:cNvPr id="91" name="">
             <a:extLst xmlns:a="http://schemas.openxmlformats.org/drawingml/2006/main">
               <a:ext uri="{FF2B5EF4-FFF2-40B4-BE49-F238E27FC236}">
-                <a16:creationId xmlns:a16="http://schemas.microsoft.com/office/drawing/2014/main" id="{8A7640CF-EFFA-4BD2-9CE1-38238E2AC218}"/>
+                <a16:creationId xmlns:a16="http://schemas.microsoft.com/office/drawing/2014/main" id="{B2C0CD7C-F163-45C4-BBAE-B35A51FF9433}"/>
               </a:ext>
             </a:extLst>
           </p:cNvPr>
@@ -10218,7 +10218,7 @@
           <p:cNvPr id="92" name="">
             <a:extLst xmlns:a="http://schemas.openxmlformats.org/drawingml/2006/main">
               <a:ext uri="{FF2B5EF4-FFF2-40B4-BE49-F238E27FC236}">
-                <a16:creationId xmlns:a16="http://schemas.microsoft.com/office/drawing/2014/main" id="{869D0BD5-CF34-4FAA-B689-B8C43AEEA0B4}"/>
+                <a16:creationId xmlns:a16="http://schemas.microsoft.com/office/drawing/2014/main" id="{D70B72EA-A0F7-49D3-A442-64B0240E1C6A}"/>
               </a:ext>
             </a:extLst>
           </p:cNvPr>
@@ -10268,7 +10268,7 @@
           <p:cNvPr id="93" name="">
             <a:extLst xmlns:a="http://schemas.openxmlformats.org/drawingml/2006/main">
               <a:ext uri="{FF2B5EF4-FFF2-40B4-BE49-F238E27FC236}">
-                <a16:creationId xmlns:a16="http://schemas.microsoft.com/office/drawing/2014/main" id="{3ECE0BD4-2430-4A91-A745-42B33A0F66A7}"/>
+                <a16:creationId xmlns:a16="http://schemas.microsoft.com/office/drawing/2014/main" id="{468FA893-0792-48DE-ACDF-B19274B72533}"/>
               </a:ext>
             </a:extLst>
           </p:cNvPr>
@@ -10301,7 +10301,7 @@
           <p:cNvPr id="94" name="">
             <a:extLst xmlns:a="http://schemas.openxmlformats.org/drawingml/2006/main">
               <a:ext uri="{FF2B5EF4-FFF2-40B4-BE49-F238E27FC236}">
-                <a16:creationId xmlns:a16="http://schemas.microsoft.com/office/drawing/2014/main" id="{E436B674-DAC7-4660-8FA7-36BD4CEF5E86}"/>
+                <a16:creationId xmlns:a16="http://schemas.microsoft.com/office/drawing/2014/main" id="{09BA5EB1-EFDE-4245-95AE-116CD6482237}"/>
               </a:ext>
             </a:extLst>
           </p:cNvPr>
@@ -10351,7 +10351,7 @@
           <p:cNvPr id="95" name="">
             <a:extLst xmlns:a="http://schemas.openxmlformats.org/drawingml/2006/main">
               <a:ext uri="{FF2B5EF4-FFF2-40B4-BE49-F238E27FC236}">
-                <a16:creationId xmlns:a16="http://schemas.microsoft.com/office/drawing/2014/main" id="{5AE95DF6-3C49-4781-B8EF-23FF4912278F}"/>
+                <a16:creationId xmlns:a16="http://schemas.microsoft.com/office/drawing/2014/main" id="{6F19FB25-9E53-439C-B7AE-203A760E4D46}"/>
               </a:ext>
             </a:extLst>
           </p:cNvPr>
@@ -10384,7 +10384,7 @@
           <p:cNvPr id="96" name="">
             <a:extLst xmlns:a="http://schemas.openxmlformats.org/drawingml/2006/main">
               <a:ext uri="{FF2B5EF4-FFF2-40B4-BE49-F238E27FC236}">
-                <a16:creationId xmlns:a16="http://schemas.microsoft.com/office/drawing/2014/main" id="{C7812975-CC62-4B80-B884-51BC7B081DCD}"/>
+                <a16:creationId xmlns:a16="http://schemas.microsoft.com/office/drawing/2014/main" id="{7DD0DE2F-8902-4740-902B-67FBE68D1010}"/>
               </a:ext>
             </a:extLst>
           </p:cNvPr>
@@ -10434,7 +10434,7 @@
           <p:cNvPr id="97" name="">
             <a:extLst xmlns:a="http://schemas.openxmlformats.org/drawingml/2006/main">
               <a:ext uri="{FF2B5EF4-FFF2-40B4-BE49-F238E27FC236}">
-                <a16:creationId xmlns:a16="http://schemas.microsoft.com/office/drawing/2014/main" id="{40D78ED4-5C49-4E79-84F1-CAE6C9562F77}"/>
+                <a16:creationId xmlns:a16="http://schemas.microsoft.com/office/drawing/2014/main" id="{C658D435-7E7A-47EF-99BB-F7F1597A3FFF}"/>
               </a:ext>
             </a:extLst>
           </p:cNvPr>
@@ -10484,7 +10484,7 @@
           <p:cNvPr id="98" name="">
             <a:extLst xmlns:a="http://schemas.openxmlformats.org/drawingml/2006/main">
               <a:ext uri="{FF2B5EF4-FFF2-40B4-BE49-F238E27FC236}">
-                <a16:creationId xmlns:a16="http://schemas.microsoft.com/office/drawing/2014/main" id="{70B0B2B9-6A32-4A55-8981-81C1F8E310FA}"/>
+                <a16:creationId xmlns:a16="http://schemas.microsoft.com/office/drawing/2014/main" id="{F4463B12-5B56-4717-8C00-97FB5140FC0D}"/>
               </a:ext>
             </a:extLst>
           </p:cNvPr>
@@ -10519,7 +10519,7 @@
           <p:cNvPr id="99" name="">
             <a:extLst xmlns:a="http://schemas.openxmlformats.org/drawingml/2006/main">
               <a:ext uri="{FF2B5EF4-FFF2-40B4-BE49-F238E27FC236}">
-                <a16:creationId xmlns:a16="http://schemas.microsoft.com/office/drawing/2014/main" id="{F43BC10E-73D0-4F82-9843-E4CB20DDA3D7}"/>
+                <a16:creationId xmlns:a16="http://schemas.microsoft.com/office/drawing/2014/main" id="{288B81BE-7521-4F64-9240-E06C09E64C58}"/>
               </a:ext>
             </a:extLst>
           </p:cNvPr>
@@ -10552,7 +10552,7 @@
           <p:cNvPr id="100" name="">
             <a:extLst xmlns:a="http://schemas.openxmlformats.org/drawingml/2006/main">
               <a:ext uri="{FF2B5EF4-FFF2-40B4-BE49-F238E27FC236}">
-                <a16:creationId xmlns:a16="http://schemas.microsoft.com/office/drawing/2014/main" id="{35D30FF6-E6C8-48A5-AC74-AB2B84914D1F}"/>
+                <a16:creationId xmlns:a16="http://schemas.microsoft.com/office/drawing/2014/main" id="{14193C3F-0756-443D-AF92-D8E51842EE7C}"/>
               </a:ext>
             </a:extLst>
           </p:cNvPr>
@@ -10606,10 +10606,10 @@
           <p:nvPr/>
         </p:nvPicPr>
         <p:blipFill>
-          <a:blip xmlns:r="http://schemas.openxmlformats.org/officeDocument/2006/relationships" xmlns:a="http://schemas.openxmlformats.org/drawingml/2006/main" r:embed="R1534e92a4f4e403c">
+          <a:blip xmlns:r="http://schemas.openxmlformats.org/officeDocument/2006/relationships" xmlns:a="http://schemas.openxmlformats.org/drawingml/2006/main" r:embed="R5b9ecca27f024090">
             <a:extLst>
               <a:ext uri="{96DAC541-7B7A-43D3-8B79-37D633B846F1}">
-                <asvg:svgBlip xmlns:asvg="http://schemas.microsoft.com/office/drawing/2016/SVG/main" r:embed="R181e076163ab4906"/>
+                <asvg:svgBlip xmlns:asvg="http://schemas.microsoft.com/office/drawing/2016/SVG/main" r:embed="R925587c25b07427c"/>
               </a:ext>
             </a:extLst>
           </a:blip>
@@ -10628,7 +10628,7 @@
     </p:spTree>
     <p:extLst>
       <p:ext uri="{BB962C8B-B14F-4D97-AF65-F5344CB8AC3E}">
-        <p14:creationId xmlns:p14="http://schemas.microsoft.com/office/powerpoint/2010/main" val="28276457"/>
+        <p14:creationId xmlns:p14="http://schemas.microsoft.com/office/powerpoint/2010/main" val="282583386"/>
       </p:ext>
     </p:extLst>
   </p:cSld>
@@ -10659,7 +10659,7 @@
           <p:cNvPr id="27" name="">
             <a:extLst xmlns:a="http://schemas.openxmlformats.org/drawingml/2006/main">
               <a:ext uri="{FF2B5EF4-FFF2-40B4-BE49-F238E27FC236}">
-                <a16:creationId xmlns:a16="http://schemas.microsoft.com/office/drawing/2014/main" id="{CCD7FC39-DDB2-49CF-9ADC-482DDCA9DC88}"/>
+                <a16:creationId xmlns:a16="http://schemas.microsoft.com/office/drawing/2014/main" id="{E26E77BD-95EE-4051-BFA7-EB2B4BB02173}"/>
               </a:ext>
             </a:extLst>
           </p:cNvPr>
@@ -10692,7 +10692,7 @@
           <p:cNvPr id="2" name="">
             <a:extLst xmlns:a="http://schemas.openxmlformats.org/drawingml/2006/main">
               <a:ext uri="{FF2B5EF4-FFF2-40B4-BE49-F238E27FC236}">
-                <a16:creationId xmlns:a16="http://schemas.microsoft.com/office/drawing/2014/main" id="{C540FF95-2B26-42BC-84B9-34C8CC7F1034}"/>
+                <a16:creationId xmlns:a16="http://schemas.microsoft.com/office/drawing/2014/main" id="{CA8A7046-7C2B-4CFA-B364-DE0C53572B62}"/>
               </a:ext>
             </a:extLst>
           </p:cNvPr>
@@ -10725,7 +10725,7 @@
           <p:cNvPr id="3" name="">
             <a:extLst xmlns:a="http://schemas.openxmlformats.org/drawingml/2006/main">
               <a:ext uri="{FF2B5EF4-FFF2-40B4-BE49-F238E27FC236}">
-                <a16:creationId xmlns:a16="http://schemas.microsoft.com/office/drawing/2014/main" id="{A3771BA6-F54C-4DEA-B5B0-209EA297BBA7}"/>
+                <a16:creationId xmlns:a16="http://schemas.microsoft.com/office/drawing/2014/main" id="{C22BAB45-6D9F-440D-8327-DAE47A7FE0B1}"/>
               </a:ext>
             </a:extLst>
           </p:cNvPr>
@@ -10775,7 +10775,7 @@
           <p:cNvPr id="4" name="">
             <a:extLst xmlns:a="http://schemas.openxmlformats.org/drawingml/2006/main">
               <a:ext uri="{FF2B5EF4-FFF2-40B4-BE49-F238E27FC236}">
-                <a16:creationId xmlns:a16="http://schemas.microsoft.com/office/drawing/2014/main" id="{24F6FBF9-3A4F-408F-9A3C-430DBE026B03}"/>
+                <a16:creationId xmlns:a16="http://schemas.microsoft.com/office/drawing/2014/main" id="{D0D41193-0CDF-488A-A31C-9638DE9CAA14}"/>
               </a:ext>
             </a:extLst>
           </p:cNvPr>
@@ -10825,7 +10825,7 @@
           <p:cNvPr id="5" name="">
             <a:extLst xmlns:a="http://schemas.openxmlformats.org/drawingml/2006/main">
               <a:ext uri="{FF2B5EF4-FFF2-40B4-BE49-F238E27FC236}">
-                <a16:creationId xmlns:a16="http://schemas.microsoft.com/office/drawing/2014/main" id="{0520463C-9764-4168-B859-D0C00D08FEB0}"/>
+                <a16:creationId xmlns:a16="http://schemas.microsoft.com/office/drawing/2014/main" id="{08CF1C3F-F064-49C0-BEB9-C11FADE1CC6A}"/>
               </a:ext>
             </a:extLst>
           </p:cNvPr>
@@ -10879,7 +10879,7 @@
           <p:nvPr/>
         </p:nvPicPr>
         <p:blipFill>
-          <a:blip xmlns:r="http://schemas.openxmlformats.org/officeDocument/2006/relationships" xmlns:a="http://schemas.openxmlformats.org/drawingml/2006/main" r:embed="R81845b9d81934f62"/>
+          <a:blip xmlns:r="http://schemas.openxmlformats.org/officeDocument/2006/relationships" xmlns:a="http://schemas.openxmlformats.org/drawingml/2006/main" r:embed="R25911fa0b2cd444f"/>
           <a:stretch xmlns:a="http://schemas.openxmlformats.org/drawingml/2006/main"/>
         </p:blipFill>
         <p:spPr>
@@ -10897,7 +10897,7 @@
           <p:cNvPr id="7" name="">
             <a:extLst xmlns:a="http://schemas.openxmlformats.org/drawingml/2006/main">
               <a:ext uri="{FF2B5EF4-FFF2-40B4-BE49-F238E27FC236}">
-                <a16:creationId xmlns:a16="http://schemas.microsoft.com/office/drawing/2014/main" id="{38F3F94C-6325-408D-8545-D336E110EFA5}"/>
+                <a16:creationId xmlns:a16="http://schemas.microsoft.com/office/drawing/2014/main" id="{E9B20894-383E-4326-9CD4-93A790DF0618}"/>
               </a:ext>
             </a:extLst>
           </p:cNvPr>
@@ -10930,7 +10930,7 @@
           <p:cNvPr id="8" name="">
             <a:extLst xmlns:a="http://schemas.openxmlformats.org/drawingml/2006/main">
               <a:ext uri="{FF2B5EF4-FFF2-40B4-BE49-F238E27FC236}">
-                <a16:creationId xmlns:a16="http://schemas.microsoft.com/office/drawing/2014/main" id="{8CB24CA8-D7F6-46E7-AFBB-738A6C073218}"/>
+                <a16:creationId xmlns:a16="http://schemas.microsoft.com/office/drawing/2014/main" id="{3E3EA35E-EA5B-4E76-98AE-7184F1EE60BA}"/>
               </a:ext>
             </a:extLst>
           </p:cNvPr>
@@ -10980,7 +10980,7 @@
           <p:cNvPr id="9" name="">
             <a:extLst xmlns:a="http://schemas.openxmlformats.org/drawingml/2006/main">
               <a:ext uri="{FF2B5EF4-FFF2-40B4-BE49-F238E27FC236}">
-                <a16:creationId xmlns:a16="http://schemas.microsoft.com/office/drawing/2014/main" id="{F13B132F-0E20-4843-B319-9AE1DC69BF1C}"/>
+                <a16:creationId xmlns:a16="http://schemas.microsoft.com/office/drawing/2014/main" id="{D50C7057-F4F0-41DD-A5C1-9B7B5DB73757}"/>
               </a:ext>
             </a:extLst>
           </p:cNvPr>
@@ -11030,7 +11030,7 @@
           <p:cNvPr id="10" name="">
             <a:extLst xmlns:a="http://schemas.openxmlformats.org/drawingml/2006/main">
               <a:ext uri="{FF2B5EF4-FFF2-40B4-BE49-F238E27FC236}">
-                <a16:creationId xmlns:a16="http://schemas.microsoft.com/office/drawing/2014/main" id="{5BF1A4A4-FCDE-4AA9-BBFE-FA87F3E6DED2}"/>
+                <a16:creationId xmlns:a16="http://schemas.microsoft.com/office/drawing/2014/main" id="{72848C0D-74CB-42ED-9C0C-03073AB0BABA}"/>
               </a:ext>
             </a:extLst>
           </p:cNvPr>
@@ -11065,7 +11065,7 @@
           <p:cNvPr id="11" name="">
             <a:extLst xmlns:a="http://schemas.openxmlformats.org/drawingml/2006/main">
               <a:ext uri="{FF2B5EF4-FFF2-40B4-BE49-F238E27FC236}">
-                <a16:creationId xmlns:a16="http://schemas.microsoft.com/office/drawing/2014/main" id="{15241C6D-E88F-438B-A3E0-65B5E56F7D99}"/>
+                <a16:creationId xmlns:a16="http://schemas.microsoft.com/office/drawing/2014/main" id="{273CDB48-A032-47BE-9F47-385B2846CFED}"/>
               </a:ext>
             </a:extLst>
           </p:cNvPr>
@@ -11098,7 +11098,7 @@
           <p:cNvPr id="12" name="">
             <a:extLst xmlns:a="http://schemas.openxmlformats.org/drawingml/2006/main">
               <a:ext uri="{FF2B5EF4-FFF2-40B4-BE49-F238E27FC236}">
-                <a16:creationId xmlns:a16="http://schemas.microsoft.com/office/drawing/2014/main" id="{3C4859CA-D6DB-4C60-BB49-0859A2B937B1}"/>
+                <a16:creationId xmlns:a16="http://schemas.microsoft.com/office/drawing/2014/main" id="{B863FCF1-4F92-435D-BDA4-A5A123339C54}"/>
               </a:ext>
             </a:extLst>
           </p:cNvPr>
@@ -11152,10 +11152,10 @@
           <p:nvPr/>
         </p:nvPicPr>
         <p:blipFill>
-          <a:blip xmlns:r="http://schemas.openxmlformats.org/officeDocument/2006/relationships" xmlns:a="http://schemas.openxmlformats.org/drawingml/2006/main" r:embed="R67794b595e8a4761">
+          <a:blip xmlns:r="http://schemas.openxmlformats.org/officeDocument/2006/relationships" xmlns:a="http://schemas.openxmlformats.org/drawingml/2006/main" r:embed="R134d2a4e8a134f39">
             <a:extLst>
               <a:ext uri="{96DAC541-7B7A-43D3-8B79-37D633B846F1}">
-                <asvg:svgBlip xmlns:asvg="http://schemas.microsoft.com/office/drawing/2016/SVG/main" r:embed="Rbd1235201f5944c7"/>
+                <asvg:svgBlip xmlns:asvg="http://schemas.microsoft.com/office/drawing/2016/SVG/main" r:embed="R59ad0b553c6744e4"/>
               </a:ext>
             </a:extLst>
           </a:blip>
@@ -11176,7 +11176,7 @@
           <p:cNvPr id="14" name="">
             <a:extLst xmlns:a="http://schemas.openxmlformats.org/drawingml/2006/main">
               <a:ext uri="{FF2B5EF4-FFF2-40B4-BE49-F238E27FC236}">
-                <a16:creationId xmlns:a16="http://schemas.microsoft.com/office/drawing/2014/main" id="{8B067FE4-6419-40E7-BE5D-54309E2D3073}"/>
+                <a16:creationId xmlns:a16="http://schemas.microsoft.com/office/drawing/2014/main" id="{E4CBABF7-19E7-4554-A283-CAD3D4BFAEA4}"/>
               </a:ext>
             </a:extLst>
           </p:cNvPr>
@@ -11211,7 +11211,7 @@
           <p:cNvPr id="15" name="">
             <a:extLst xmlns:a="http://schemas.openxmlformats.org/drawingml/2006/main">
               <a:ext uri="{FF2B5EF4-FFF2-40B4-BE49-F238E27FC236}">
-                <a16:creationId xmlns:a16="http://schemas.microsoft.com/office/drawing/2014/main" id="{0AC47472-F06C-48E1-94FB-40BD2B0ED6DB}"/>
+                <a16:creationId xmlns:a16="http://schemas.microsoft.com/office/drawing/2014/main" id="{29BCDCBA-D24F-4CFC-8185-7D6CF8EB9840}"/>
               </a:ext>
             </a:extLst>
           </p:cNvPr>
@@ -11244,7 +11244,7 @@
           <p:cNvPr id="16" name="">
             <a:extLst xmlns:a="http://schemas.openxmlformats.org/drawingml/2006/main">
               <a:ext uri="{FF2B5EF4-FFF2-40B4-BE49-F238E27FC236}">
-                <a16:creationId xmlns:a16="http://schemas.microsoft.com/office/drawing/2014/main" id="{0DCA0D87-A70A-47C7-836F-1AC39E173F84}"/>
+                <a16:creationId xmlns:a16="http://schemas.microsoft.com/office/drawing/2014/main" id="{640D578D-4908-42D9-8655-630568353E0A}"/>
               </a:ext>
             </a:extLst>
           </p:cNvPr>
@@ -11298,10 +11298,10 @@
           <p:nvPr/>
         </p:nvPicPr>
         <p:blipFill>
-          <a:blip xmlns:r="http://schemas.openxmlformats.org/officeDocument/2006/relationships" xmlns:a="http://schemas.openxmlformats.org/drawingml/2006/main" r:embed="R67665aca8afd414d">
+          <a:blip xmlns:r="http://schemas.openxmlformats.org/officeDocument/2006/relationships" xmlns:a="http://schemas.openxmlformats.org/drawingml/2006/main" r:embed="R6a5b6360b47e4164">
             <a:extLst>
               <a:ext uri="{96DAC541-7B7A-43D3-8B79-37D633B846F1}">
-                <asvg:svgBlip xmlns:asvg="http://schemas.microsoft.com/office/drawing/2016/SVG/main" r:embed="R005cddf20e5a4f19"/>
+                <asvg:svgBlip xmlns:asvg="http://schemas.microsoft.com/office/drawing/2016/SVG/main" r:embed="Rbb6703445f79476c"/>
               </a:ext>
             </a:extLst>
           </a:blip>
@@ -11322,7 +11322,7 @@
           <p:cNvPr id="18" name="">
             <a:extLst xmlns:a="http://schemas.openxmlformats.org/drawingml/2006/main">
               <a:ext uri="{FF2B5EF4-FFF2-40B4-BE49-F238E27FC236}">
-                <a16:creationId xmlns:a16="http://schemas.microsoft.com/office/drawing/2014/main" id="{AF8DE54C-9A00-43AA-ACA9-ABE7C944AC61}"/>
+                <a16:creationId xmlns:a16="http://schemas.microsoft.com/office/drawing/2014/main" id="{DA858C73-DD56-4746-8BD0-BE518FB7BC82}"/>
               </a:ext>
             </a:extLst>
           </p:cNvPr>
@@ -11357,7 +11357,7 @@
           <p:cNvPr id="19" name="">
             <a:extLst xmlns:a="http://schemas.openxmlformats.org/drawingml/2006/main">
               <a:ext uri="{FF2B5EF4-FFF2-40B4-BE49-F238E27FC236}">
-                <a16:creationId xmlns:a16="http://schemas.microsoft.com/office/drawing/2014/main" id="{562F8C8B-72A0-429B-9FDD-551F37D5CFE6}"/>
+                <a16:creationId xmlns:a16="http://schemas.microsoft.com/office/drawing/2014/main" id="{F2CB892A-6613-4855-A65D-6945717C5F08}"/>
               </a:ext>
             </a:extLst>
           </p:cNvPr>
@@ -11390,7 +11390,7 @@
           <p:cNvPr id="20" name="">
             <a:extLst xmlns:a="http://schemas.openxmlformats.org/drawingml/2006/main">
               <a:ext uri="{FF2B5EF4-FFF2-40B4-BE49-F238E27FC236}">
-                <a16:creationId xmlns:a16="http://schemas.microsoft.com/office/drawing/2014/main" id="{4018AC92-BCCE-48A4-9A72-F6C83D767303}"/>
+                <a16:creationId xmlns:a16="http://schemas.microsoft.com/office/drawing/2014/main" id="{CA869BAB-50FB-49DC-8F26-36186E5B2233}"/>
               </a:ext>
             </a:extLst>
           </p:cNvPr>
@@ -11444,10 +11444,10 @@
           <p:nvPr/>
         </p:nvPicPr>
         <p:blipFill>
-          <a:blip xmlns:r="http://schemas.openxmlformats.org/officeDocument/2006/relationships" xmlns:a="http://schemas.openxmlformats.org/drawingml/2006/main" r:embed="Rcd8618a6debd423a">
+          <a:blip xmlns:r="http://schemas.openxmlformats.org/officeDocument/2006/relationships" xmlns:a="http://schemas.openxmlformats.org/drawingml/2006/main" r:embed="Rd46c52892eec4590">
             <a:extLst>
               <a:ext uri="{96DAC541-7B7A-43D3-8B79-37D633B846F1}">
-                <asvg:svgBlip xmlns:asvg="http://schemas.microsoft.com/office/drawing/2016/SVG/main" r:embed="R777f4d7227e744b8"/>
+                <asvg:svgBlip xmlns:asvg="http://schemas.microsoft.com/office/drawing/2016/SVG/main" r:embed="R1fb785fde2ff4213"/>
               </a:ext>
             </a:extLst>
           </a:blip>
@@ -11468,7 +11468,7 @@
           <p:cNvPr id="22" name="">
             <a:extLst xmlns:a="http://schemas.openxmlformats.org/drawingml/2006/main">
               <a:ext uri="{FF2B5EF4-FFF2-40B4-BE49-F238E27FC236}">
-                <a16:creationId xmlns:a16="http://schemas.microsoft.com/office/drawing/2014/main" id="{4B133D37-CB47-4DFB-A584-BFC0DAF570D5}"/>
+                <a16:creationId xmlns:a16="http://schemas.microsoft.com/office/drawing/2014/main" id="{085917A8-9185-4779-B744-3357EE5C2A47}"/>
               </a:ext>
             </a:extLst>
           </p:cNvPr>
@@ -11503,7 +11503,7 @@
           <p:cNvPr id="23" name="">
             <a:extLst xmlns:a="http://schemas.openxmlformats.org/drawingml/2006/main">
               <a:ext uri="{FF2B5EF4-FFF2-40B4-BE49-F238E27FC236}">
-                <a16:creationId xmlns:a16="http://schemas.microsoft.com/office/drawing/2014/main" id="{908530E2-B4D2-4393-978C-A87F54440EDA}"/>
+                <a16:creationId xmlns:a16="http://schemas.microsoft.com/office/drawing/2014/main" id="{2C641EED-7893-4B8B-9C76-6BCE2B68F7D3}"/>
               </a:ext>
             </a:extLst>
           </p:cNvPr>
@@ -11536,7 +11536,7 @@
           <p:cNvPr id="24" name="">
             <a:extLst xmlns:a="http://schemas.openxmlformats.org/drawingml/2006/main">
               <a:ext uri="{FF2B5EF4-FFF2-40B4-BE49-F238E27FC236}">
-                <a16:creationId xmlns:a16="http://schemas.microsoft.com/office/drawing/2014/main" id="{1DCECEA6-88EC-477A-B263-FE815BA8FD6D}"/>
+                <a16:creationId xmlns:a16="http://schemas.microsoft.com/office/drawing/2014/main" id="{DFBC8033-4863-450C-B5BE-F8EFCE369900}"/>
               </a:ext>
             </a:extLst>
           </p:cNvPr>
@@ -11590,10 +11590,10 @@
           <p:nvPr/>
         </p:nvPicPr>
         <p:blipFill>
-          <a:blip xmlns:r="http://schemas.openxmlformats.org/officeDocument/2006/relationships" xmlns:a="http://schemas.openxmlformats.org/drawingml/2006/main" r:embed="R442d97436172422c">
+          <a:blip xmlns:r="http://schemas.openxmlformats.org/officeDocument/2006/relationships" xmlns:a="http://schemas.openxmlformats.org/drawingml/2006/main" r:embed="Reb50f539c7914066">
             <a:extLst>
               <a:ext uri="{96DAC541-7B7A-43D3-8B79-37D633B846F1}">
-                <asvg:svgBlip xmlns:asvg="http://schemas.microsoft.com/office/drawing/2016/SVG/main" r:embed="R890177dcdc3f4d6c"/>
+                <asvg:svgBlip xmlns:asvg="http://schemas.microsoft.com/office/drawing/2016/SVG/main" r:embed="R1c048d7ed4a54c03"/>
               </a:ext>
             </a:extLst>
           </a:blip>
@@ -11614,7 +11614,7 @@
           <p:cNvPr id="26" name="">
             <a:extLst xmlns:a="http://schemas.openxmlformats.org/drawingml/2006/main">
               <a:ext uri="{FF2B5EF4-FFF2-40B4-BE49-F238E27FC236}">
-                <a16:creationId xmlns:a16="http://schemas.microsoft.com/office/drawing/2014/main" id="{EB2F6A59-A21A-45E0-B326-477CF2C58A6B}"/>
+                <a16:creationId xmlns:a16="http://schemas.microsoft.com/office/drawing/2014/main" id="{B9EE814D-6833-4A58-AB04-6AD9F4A0E463}"/>
               </a:ext>
             </a:extLst>
           </p:cNvPr>
@@ -11662,7 +11662,7 @@
     </p:spTree>
     <p:extLst>
       <p:ext uri="{BB962C8B-B14F-4D97-AF65-F5344CB8AC3E}">
-        <p14:creationId xmlns:p14="http://schemas.microsoft.com/office/powerpoint/2010/main" val="1920820926"/>
+        <p14:creationId xmlns:p14="http://schemas.microsoft.com/office/powerpoint/2010/main" val="1332677690"/>
       </p:ext>
     </p:extLst>
   </p:cSld>
@@ -11693,7 +11693,7 @@
           <p:cNvPr id="61" name="">
             <a:extLst xmlns:a="http://schemas.openxmlformats.org/drawingml/2006/main">
               <a:ext uri="{FF2B5EF4-FFF2-40B4-BE49-F238E27FC236}">
-                <a16:creationId xmlns:a16="http://schemas.microsoft.com/office/drawing/2014/main" id="{C881A907-65AE-4E98-8B2F-F6EB5D76396F}"/>
+                <a16:creationId xmlns:a16="http://schemas.microsoft.com/office/drawing/2014/main" id="{7C104182-2D61-40B8-917C-D10F7A6F8BF1}"/>
               </a:ext>
             </a:extLst>
           </p:cNvPr>
@@ -11726,7 +11726,7 @@
           <p:cNvPr id="2" name="">
             <a:extLst xmlns:a="http://schemas.openxmlformats.org/drawingml/2006/main">
               <a:ext uri="{FF2B5EF4-FFF2-40B4-BE49-F238E27FC236}">
-                <a16:creationId xmlns:a16="http://schemas.microsoft.com/office/drawing/2014/main" id="{18BEEC19-B3D3-4966-A1A8-302B24F2512F}"/>
+                <a16:creationId xmlns:a16="http://schemas.microsoft.com/office/drawing/2014/main" id="{F42E8F68-4AB5-4A44-9C50-E38F87F05565}"/>
               </a:ext>
             </a:extLst>
           </p:cNvPr>
@@ -11759,7 +11759,7 @@
           <p:cNvPr id="3" name="">
             <a:extLst xmlns:a="http://schemas.openxmlformats.org/drawingml/2006/main">
               <a:ext uri="{FF2B5EF4-FFF2-40B4-BE49-F238E27FC236}">
-                <a16:creationId xmlns:a16="http://schemas.microsoft.com/office/drawing/2014/main" id="{BB76B8A8-0F06-4E07-ADC7-5D2EAC8F337D}"/>
+                <a16:creationId xmlns:a16="http://schemas.microsoft.com/office/drawing/2014/main" id="{0742A802-B942-4104-BEB4-4283704A2CAA}"/>
               </a:ext>
             </a:extLst>
           </p:cNvPr>
@@ -11809,7 +11809,7 @@
           <p:cNvPr id="4" name="">
             <a:extLst xmlns:a="http://schemas.openxmlformats.org/drawingml/2006/main">
               <a:ext uri="{FF2B5EF4-FFF2-40B4-BE49-F238E27FC236}">
-                <a16:creationId xmlns:a16="http://schemas.microsoft.com/office/drawing/2014/main" id="{E79D1BAF-A04E-4F05-866D-1E23F3A36DA6}"/>
+                <a16:creationId xmlns:a16="http://schemas.microsoft.com/office/drawing/2014/main" id="{27758183-B60A-43D4-979E-6BDD8BB0888F}"/>
               </a:ext>
             </a:extLst>
           </p:cNvPr>
@@ -11859,7 +11859,7 @@
           <p:cNvPr id="5" name="">
             <a:extLst xmlns:a="http://schemas.openxmlformats.org/drawingml/2006/main">
               <a:ext uri="{FF2B5EF4-FFF2-40B4-BE49-F238E27FC236}">
-                <a16:creationId xmlns:a16="http://schemas.microsoft.com/office/drawing/2014/main" id="{61C87525-D785-44C6-8002-7F7425B384CF}"/>
+                <a16:creationId xmlns:a16="http://schemas.microsoft.com/office/drawing/2014/main" id="{57443848-4FFF-42E1-80E9-FA84D7EEECF7}"/>
               </a:ext>
             </a:extLst>
           </p:cNvPr>
@@ -11913,7 +11913,7 @@
           <p:nvPr/>
         </p:nvPicPr>
         <p:blipFill>
-          <a:blip xmlns:r="http://schemas.openxmlformats.org/officeDocument/2006/relationships" xmlns:a="http://schemas.openxmlformats.org/drawingml/2006/main" r:embed="Rb0c127a32a4c4b79"/>
+          <a:blip xmlns:r="http://schemas.openxmlformats.org/officeDocument/2006/relationships" xmlns:a="http://schemas.openxmlformats.org/drawingml/2006/main" r:embed="R1912f06556f74345"/>
           <a:stretch xmlns:a="http://schemas.openxmlformats.org/drawingml/2006/main"/>
         </p:blipFill>
         <p:spPr>
@@ -11931,7 +11931,7 @@
           <p:cNvPr id="7" name="">
             <a:extLst xmlns:a="http://schemas.openxmlformats.org/drawingml/2006/main">
               <a:ext uri="{FF2B5EF4-FFF2-40B4-BE49-F238E27FC236}">
-                <a16:creationId xmlns:a16="http://schemas.microsoft.com/office/drawing/2014/main" id="{8DF79B3C-F9BA-45F8-A5CF-3FBE870D4CB8}"/>
+                <a16:creationId xmlns:a16="http://schemas.microsoft.com/office/drawing/2014/main" id="{C3F47348-E604-421F-96D5-65393BD7C66A}"/>
               </a:ext>
             </a:extLst>
           </p:cNvPr>
@@ -11964,7 +11964,7 @@
           <p:cNvPr id="8" name="">
             <a:extLst xmlns:a="http://schemas.openxmlformats.org/drawingml/2006/main">
               <a:ext uri="{FF2B5EF4-FFF2-40B4-BE49-F238E27FC236}">
-                <a16:creationId xmlns:a16="http://schemas.microsoft.com/office/drawing/2014/main" id="{3CB611FC-31BA-4D0E-88B1-79F447381937}"/>
+                <a16:creationId xmlns:a16="http://schemas.microsoft.com/office/drawing/2014/main" id="{D84A5C1E-E099-48E0-B71E-487AFFCF9D9D}"/>
               </a:ext>
             </a:extLst>
           </p:cNvPr>
@@ -12014,7 +12014,7 @@
           <p:cNvPr id="9" name="">
             <a:extLst xmlns:a="http://schemas.openxmlformats.org/drawingml/2006/main">
               <a:ext uri="{FF2B5EF4-FFF2-40B4-BE49-F238E27FC236}">
-                <a16:creationId xmlns:a16="http://schemas.microsoft.com/office/drawing/2014/main" id="{A6D7D177-B447-4AEC-8B39-41E252BE221A}"/>
+                <a16:creationId xmlns:a16="http://schemas.microsoft.com/office/drawing/2014/main" id="{CBCAA1C9-65BA-419D-8619-9E94AFA6680C}"/>
               </a:ext>
             </a:extLst>
           </p:cNvPr>
@@ -12064,7 +12064,7 @@
           <p:cNvPr id="10" name="">
             <a:extLst xmlns:a="http://schemas.openxmlformats.org/drawingml/2006/main">
               <a:ext uri="{FF2B5EF4-FFF2-40B4-BE49-F238E27FC236}">
-                <a16:creationId xmlns:a16="http://schemas.microsoft.com/office/drawing/2014/main" id="{182365D8-2609-4A00-9213-83B4931062E3}"/>
+                <a16:creationId xmlns:a16="http://schemas.microsoft.com/office/drawing/2014/main" id="{42D3FC72-0752-4871-B606-A600C2E012C8}"/>
               </a:ext>
             </a:extLst>
           </p:cNvPr>
@@ -12099,7 +12099,7 @@
           <p:cNvPr id="11" name="">
             <a:extLst xmlns:a="http://schemas.openxmlformats.org/drawingml/2006/main">
               <a:ext uri="{FF2B5EF4-FFF2-40B4-BE49-F238E27FC236}">
-                <a16:creationId xmlns:a16="http://schemas.microsoft.com/office/drawing/2014/main" id="{F17D1E03-5742-4A47-8F27-354AE3C36F07}"/>
+                <a16:creationId xmlns:a16="http://schemas.microsoft.com/office/drawing/2014/main" id="{DD094897-BAFA-4FA0-9114-79D9AD9785B3}"/>
               </a:ext>
             </a:extLst>
           </p:cNvPr>
@@ -12132,7 +12132,7 @@
           <p:cNvPr id="12" name="">
             <a:extLst xmlns:a="http://schemas.openxmlformats.org/drawingml/2006/main">
               <a:ext uri="{FF2B5EF4-FFF2-40B4-BE49-F238E27FC236}">
-                <a16:creationId xmlns:a16="http://schemas.microsoft.com/office/drawing/2014/main" id="{032FFFB6-C03D-4851-BE64-82465A66C3CB}"/>
+                <a16:creationId xmlns:a16="http://schemas.microsoft.com/office/drawing/2014/main" id="{C939470D-B261-4EDF-BE9C-8A05BA4754AA}"/>
               </a:ext>
             </a:extLst>
           </p:cNvPr>
@@ -12165,7 +12165,7 @@
           <p:cNvPr id="13" name="">
             <a:extLst xmlns:a="http://schemas.openxmlformats.org/drawingml/2006/main">
               <a:ext uri="{FF2B5EF4-FFF2-40B4-BE49-F238E27FC236}">
-                <a16:creationId xmlns:a16="http://schemas.microsoft.com/office/drawing/2014/main" id="{8101CD90-0BCE-4F51-BB24-3B9EC3DC95DB}"/>
+                <a16:creationId xmlns:a16="http://schemas.microsoft.com/office/drawing/2014/main" id="{3FB20FD8-8C30-4F6C-AE1E-B32EAEDDF3FE}"/>
               </a:ext>
             </a:extLst>
           </p:cNvPr>
@@ -12198,7 +12198,7 @@
           <p:cNvPr id="14" name="">
             <a:extLst xmlns:a="http://schemas.openxmlformats.org/drawingml/2006/main">
               <a:ext uri="{FF2B5EF4-FFF2-40B4-BE49-F238E27FC236}">
-                <a16:creationId xmlns:a16="http://schemas.microsoft.com/office/drawing/2014/main" id="{2B1776FA-EECB-4FA9-8C82-5EE4C383CF57}"/>
+                <a16:creationId xmlns:a16="http://schemas.microsoft.com/office/drawing/2014/main" id="{9643730B-51FF-4507-B243-32B2236CC4FC}"/>
               </a:ext>
             </a:extLst>
           </p:cNvPr>
@@ -12231,7 +12231,7 @@
           <p:cNvPr id="15" name="">
             <a:extLst xmlns:a="http://schemas.openxmlformats.org/drawingml/2006/main">
               <a:ext uri="{FF2B5EF4-FFF2-40B4-BE49-F238E27FC236}">
-                <a16:creationId xmlns:a16="http://schemas.microsoft.com/office/drawing/2014/main" id="{BC600E8F-7A26-4410-9212-E1288B9E930D}"/>
+                <a16:creationId xmlns:a16="http://schemas.microsoft.com/office/drawing/2014/main" id="{D035DD4A-364D-4D12-8650-49A2EA19C389}"/>
               </a:ext>
             </a:extLst>
           </p:cNvPr>
@@ -12281,7 +12281,7 @@
           <p:cNvPr id="16" name="">
             <a:extLst xmlns:a="http://schemas.openxmlformats.org/drawingml/2006/main">
               <a:ext uri="{FF2B5EF4-FFF2-40B4-BE49-F238E27FC236}">
-                <a16:creationId xmlns:a16="http://schemas.microsoft.com/office/drawing/2014/main" id="{8047BDE5-B3B9-4C69-8EDE-BC1F965E6B63}"/>
+                <a16:creationId xmlns:a16="http://schemas.microsoft.com/office/drawing/2014/main" id="{CDEB2D10-DCA8-4D09-B863-89405F52068C}"/>
               </a:ext>
             </a:extLst>
           </p:cNvPr>
@@ -12884,7 +12884,7 @@
           <p:cNvPr id="17" name="">
             <a:extLst xmlns:a="http://schemas.openxmlformats.org/drawingml/2006/main">
               <a:ext uri="{FF2B5EF4-FFF2-40B4-BE49-F238E27FC236}">
-                <a16:creationId xmlns:a16="http://schemas.microsoft.com/office/drawing/2014/main" id="{9CC8DCE4-6C1E-4D66-9A9E-B94579CE9F19}"/>
+                <a16:creationId xmlns:a16="http://schemas.microsoft.com/office/drawing/2014/main" id="{4EED49F3-6389-479B-A9CB-65B0203A34DD}"/>
               </a:ext>
             </a:extLst>
           </p:cNvPr>
@@ -12919,7 +12919,7 @@
           <p:cNvPr id="18" name="">
             <a:extLst xmlns:a="http://schemas.openxmlformats.org/drawingml/2006/main">
               <a:ext uri="{FF2B5EF4-FFF2-40B4-BE49-F238E27FC236}">
-                <a16:creationId xmlns:a16="http://schemas.microsoft.com/office/drawing/2014/main" id="{40D3A666-9218-433C-86FD-87B814E6B122}"/>
+                <a16:creationId xmlns:a16="http://schemas.microsoft.com/office/drawing/2014/main" id="{F01EC9D1-9A2F-4382-A0DF-6C8C3FC5F18F}"/>
               </a:ext>
             </a:extLst>
           </p:cNvPr>
@@ -12952,7 +12952,7 @@
           <p:cNvPr id="19" name="">
             <a:extLst xmlns:a="http://schemas.openxmlformats.org/drawingml/2006/main">
               <a:ext uri="{FF2B5EF4-FFF2-40B4-BE49-F238E27FC236}">
-                <a16:creationId xmlns:a16="http://schemas.microsoft.com/office/drawing/2014/main" id="{916DD6B4-00C1-488C-B27F-6BDB0CF74C0C}"/>
+                <a16:creationId xmlns:a16="http://schemas.microsoft.com/office/drawing/2014/main" id="{544023B6-DB61-4D98-AF66-BB18C33013B8}"/>
               </a:ext>
             </a:extLst>
           </p:cNvPr>
@@ -13002,7 +13002,7 @@
           <p:cNvPr id="20" name="">
             <a:extLst xmlns:a="http://schemas.openxmlformats.org/drawingml/2006/main">
               <a:ext uri="{FF2B5EF4-FFF2-40B4-BE49-F238E27FC236}">
-                <a16:creationId xmlns:a16="http://schemas.microsoft.com/office/drawing/2014/main" id="{DC76E533-E849-47F1-841C-F954A189BC7C}"/>
+                <a16:creationId xmlns:a16="http://schemas.microsoft.com/office/drawing/2014/main" id="{1571D459-F3C5-4261-BF38-B7E7E21CFBAD}"/>
               </a:ext>
             </a:extLst>
           </p:cNvPr>
@@ -13192,7 +13192,7 @@
           <p:cNvPr id="21" name="">
             <a:extLst xmlns:a="http://schemas.openxmlformats.org/drawingml/2006/main">
               <a:ext uri="{FF2B5EF4-FFF2-40B4-BE49-F238E27FC236}">
-                <a16:creationId xmlns:a16="http://schemas.microsoft.com/office/drawing/2014/main" id="{3A77716C-2E64-43D6-9F55-0749DC4376E4}"/>
+                <a16:creationId xmlns:a16="http://schemas.microsoft.com/office/drawing/2014/main" id="{93B4D737-7A07-4809-B75A-42D78C02E075}"/>
               </a:ext>
             </a:extLst>
           </p:cNvPr>
@@ -13293,7 +13293,7 @@
           <p:cNvPr id="22" name="">
             <a:extLst xmlns:a="http://schemas.openxmlformats.org/drawingml/2006/main">
               <a:ext uri="{FF2B5EF4-FFF2-40B4-BE49-F238E27FC236}">
-                <a16:creationId xmlns:a16="http://schemas.microsoft.com/office/drawing/2014/main" id="{10FB3C54-1BE0-4BDB-9A3B-3178E76E9CCF}"/>
+                <a16:creationId xmlns:a16="http://schemas.microsoft.com/office/drawing/2014/main" id="{255B2DEB-BFF0-4F42-9905-3570362B68F3}"/>
               </a:ext>
             </a:extLst>
           </p:cNvPr>
@@ -13328,7 +13328,7 @@
           <p:cNvPr id="23" name="">
             <a:extLst xmlns:a="http://schemas.openxmlformats.org/drawingml/2006/main">
               <a:ext uri="{FF2B5EF4-FFF2-40B4-BE49-F238E27FC236}">
-                <a16:creationId xmlns:a16="http://schemas.microsoft.com/office/drawing/2014/main" id="{923D2B6D-00B9-4A54-817E-F06AB29491C2}"/>
+                <a16:creationId xmlns:a16="http://schemas.microsoft.com/office/drawing/2014/main" id="{CA81279F-2711-40A7-9EF3-A36E8BDC8BA1}"/>
               </a:ext>
             </a:extLst>
           </p:cNvPr>
@@ -13378,7 +13378,7 @@
           <p:cNvPr id="24" name="">
             <a:extLst xmlns:a="http://schemas.openxmlformats.org/drawingml/2006/main">
               <a:ext uri="{FF2B5EF4-FFF2-40B4-BE49-F238E27FC236}">
-                <a16:creationId xmlns:a16="http://schemas.microsoft.com/office/drawing/2014/main" id="{0AAD2D30-9C9E-43A5-BFB9-4AE2E13851A3}"/>
+                <a16:creationId xmlns:a16="http://schemas.microsoft.com/office/drawing/2014/main" id="{80454705-0419-4B7C-89C0-E7747A83A2DF}"/>
               </a:ext>
             </a:extLst>
           </p:cNvPr>
@@ -13428,7 +13428,7 @@
           <p:cNvPr id="25" name="">
             <a:extLst xmlns:a="http://schemas.openxmlformats.org/drawingml/2006/main">
               <a:ext uri="{FF2B5EF4-FFF2-40B4-BE49-F238E27FC236}">
-                <a16:creationId xmlns:a16="http://schemas.microsoft.com/office/drawing/2014/main" id="{21F67FA4-3EF9-4499-B96D-25729FE641FF}"/>
+                <a16:creationId xmlns:a16="http://schemas.microsoft.com/office/drawing/2014/main" id="{CB21CB06-BCA8-4899-9AC6-8FCC5837AA75}"/>
               </a:ext>
             </a:extLst>
           </p:cNvPr>
@@ -13463,7 +13463,7 @@
           <p:cNvPr id="26" name="">
             <a:extLst xmlns:a="http://schemas.openxmlformats.org/drawingml/2006/main">
               <a:ext uri="{FF2B5EF4-FFF2-40B4-BE49-F238E27FC236}">
-                <a16:creationId xmlns:a16="http://schemas.microsoft.com/office/drawing/2014/main" id="{66DCB1C9-5878-4CD8-B4BA-E969D2E2A4E8}"/>
+                <a16:creationId xmlns:a16="http://schemas.microsoft.com/office/drawing/2014/main" id="{BEECE26C-4E29-44E0-BD57-7BD90BA85633}"/>
               </a:ext>
             </a:extLst>
           </p:cNvPr>
@@ -13513,7 +13513,7 @@
           <p:cNvPr id="27" name="">
             <a:extLst xmlns:a="http://schemas.openxmlformats.org/drawingml/2006/main">
               <a:ext uri="{FF2B5EF4-FFF2-40B4-BE49-F238E27FC236}">
-                <a16:creationId xmlns:a16="http://schemas.microsoft.com/office/drawing/2014/main" id="{0A74C2F0-9F89-46D8-9B42-C1CE5ECC62D8}"/>
+                <a16:creationId xmlns:a16="http://schemas.microsoft.com/office/drawing/2014/main" id="{02C1E61F-F133-4333-94E4-65C91F807C28}"/>
               </a:ext>
             </a:extLst>
           </p:cNvPr>
@@ -13563,7 +13563,7 @@
           <p:cNvPr id="28" name="">
             <a:extLst xmlns:a="http://schemas.openxmlformats.org/drawingml/2006/main">
               <a:ext uri="{FF2B5EF4-FFF2-40B4-BE49-F238E27FC236}">
-                <a16:creationId xmlns:a16="http://schemas.microsoft.com/office/drawing/2014/main" id="{79741667-8840-4DAB-BDFF-C91EE985605A}"/>
+                <a16:creationId xmlns:a16="http://schemas.microsoft.com/office/drawing/2014/main" id="{40EA2B7C-24C6-479A-93AA-89417A5A5F63}"/>
               </a:ext>
             </a:extLst>
           </p:cNvPr>
@@ -13590,7 +13590,7 @@
           <p:cNvPr id="29" name="">
             <a:extLst xmlns:a="http://schemas.openxmlformats.org/drawingml/2006/main">
               <a:ext uri="{FF2B5EF4-FFF2-40B4-BE49-F238E27FC236}">
-                <a16:creationId xmlns:a16="http://schemas.microsoft.com/office/drawing/2014/main" id="{F7E50B99-0084-4DA1-A89A-AE36E26555F8}"/>
+                <a16:creationId xmlns:a16="http://schemas.microsoft.com/office/drawing/2014/main" id="{7FD3B97C-C158-4F18-A23F-51C50B4B3D39}"/>
               </a:ext>
             </a:extLst>
           </p:cNvPr>
@@ -13643,7 +13643,7 @@
           <p:cNvPr id="31" name="">
             <a:extLst xmlns:a="http://schemas.openxmlformats.org/drawingml/2006/main">
               <a:ext uri="{FF2B5EF4-FFF2-40B4-BE49-F238E27FC236}">
-                <a16:creationId xmlns:a16="http://schemas.microsoft.com/office/drawing/2014/main" id="{DCF2EAA8-E773-488F-87A7-E4519C9B90AF}"/>
+                <a16:creationId xmlns:a16="http://schemas.microsoft.com/office/drawing/2014/main" id="{189A7C1D-1472-4D08-8ACF-379E038D64E8}"/>
               </a:ext>
             </a:extLst>
           </p:cNvPr>
@@ -13678,7 +13678,7 @@
           <p:cNvPr id="32" name="">
             <a:extLst xmlns:a="http://schemas.openxmlformats.org/drawingml/2006/main">
               <a:ext uri="{FF2B5EF4-FFF2-40B4-BE49-F238E27FC236}">
-                <a16:creationId xmlns:a16="http://schemas.microsoft.com/office/drawing/2014/main" id="{FBFDAAD8-C076-4705-ABFB-64E66CC8D1E8}"/>
+                <a16:creationId xmlns:a16="http://schemas.microsoft.com/office/drawing/2014/main" id="{5EBCE5F5-D27F-4AF2-B818-F63ABD781046}"/>
               </a:ext>
             </a:extLst>
           </p:cNvPr>
@@ -13728,7 +13728,7 @@
           <p:cNvPr id="33" name="">
             <a:extLst xmlns:a="http://schemas.openxmlformats.org/drawingml/2006/main">
               <a:ext uri="{FF2B5EF4-FFF2-40B4-BE49-F238E27FC236}">
-                <a16:creationId xmlns:a16="http://schemas.microsoft.com/office/drawing/2014/main" id="{83FA21F2-2402-46A8-A9B7-84720E364402}"/>
+                <a16:creationId xmlns:a16="http://schemas.microsoft.com/office/drawing/2014/main" id="{033F6E1B-B023-441E-9B47-6AA2ACD417CD}"/>
               </a:ext>
             </a:extLst>
           </p:cNvPr>
@@ -13778,7 +13778,7 @@
           <p:cNvPr id="34" name="">
             <a:extLst xmlns:a="http://schemas.openxmlformats.org/drawingml/2006/main">
               <a:ext uri="{FF2B5EF4-FFF2-40B4-BE49-F238E27FC236}">
-                <a16:creationId xmlns:a16="http://schemas.microsoft.com/office/drawing/2014/main" id="{3572B917-8B07-4C84-8A8A-AD6E6CA4388C}"/>
+                <a16:creationId xmlns:a16="http://schemas.microsoft.com/office/drawing/2014/main" id="{0111F307-9FBD-458C-8324-028A2D2DE2A1}"/>
               </a:ext>
             </a:extLst>
           </p:cNvPr>
@@ -13805,7 +13805,7 @@
           <p:cNvPr id="35" name="">
             <a:extLst xmlns:a="http://schemas.openxmlformats.org/drawingml/2006/main">
               <a:ext uri="{FF2B5EF4-FFF2-40B4-BE49-F238E27FC236}">
-                <a16:creationId xmlns:a16="http://schemas.microsoft.com/office/drawing/2014/main" id="{9FF58D0F-F56F-48B0-BB99-8BDA3952147D}"/>
+                <a16:creationId xmlns:a16="http://schemas.microsoft.com/office/drawing/2014/main" id="{2F7647CB-62DC-4E57-8AE6-A1D8991EB297}"/>
               </a:ext>
             </a:extLst>
           </p:cNvPr>
@@ -13858,7 +13858,7 @@
           <p:cNvPr id="37" name="">
             <a:extLst xmlns:a="http://schemas.openxmlformats.org/drawingml/2006/main">
               <a:ext uri="{FF2B5EF4-FFF2-40B4-BE49-F238E27FC236}">
-                <a16:creationId xmlns:a16="http://schemas.microsoft.com/office/drawing/2014/main" id="{E0C75D64-F6D3-46FF-BDED-BC1044BAAC40}"/>
+                <a16:creationId xmlns:a16="http://schemas.microsoft.com/office/drawing/2014/main" id="{ED9DACFC-7F4D-400B-9569-BF3ED869A6E6}"/>
               </a:ext>
             </a:extLst>
           </p:cNvPr>
@@ -13893,7 +13893,7 @@
           <p:cNvPr id="38" name="">
             <a:extLst xmlns:a="http://schemas.openxmlformats.org/drawingml/2006/main">
               <a:ext uri="{FF2B5EF4-FFF2-40B4-BE49-F238E27FC236}">
-                <a16:creationId xmlns:a16="http://schemas.microsoft.com/office/drawing/2014/main" id="{E3412DB5-8238-4E58-B5A9-1BFB900B6124}"/>
+                <a16:creationId xmlns:a16="http://schemas.microsoft.com/office/drawing/2014/main" id="{9FF8D8A7-4B54-4AD5-9291-86F718DBAA62}"/>
               </a:ext>
             </a:extLst>
           </p:cNvPr>
@@ -13943,7 +13943,7 @@
           <p:cNvPr id="39" name="">
             <a:extLst xmlns:a="http://schemas.openxmlformats.org/drawingml/2006/main">
               <a:ext uri="{FF2B5EF4-FFF2-40B4-BE49-F238E27FC236}">
-                <a16:creationId xmlns:a16="http://schemas.microsoft.com/office/drawing/2014/main" id="{4FB09223-D036-4A3A-88ED-EA4B500F15F1}"/>
+                <a16:creationId xmlns:a16="http://schemas.microsoft.com/office/drawing/2014/main" id="{4EF09CE6-0680-458A-948D-D3E38288E18F}"/>
               </a:ext>
             </a:extLst>
           </p:cNvPr>
@@ -13993,7 +13993,7 @@
           <p:cNvPr id="40" name="">
             <a:extLst xmlns:a="http://schemas.openxmlformats.org/drawingml/2006/main">
               <a:ext uri="{FF2B5EF4-FFF2-40B4-BE49-F238E27FC236}">
-                <a16:creationId xmlns:a16="http://schemas.microsoft.com/office/drawing/2014/main" id="{D2ED3775-02E7-4495-80A1-43DE961FED54}"/>
+                <a16:creationId xmlns:a16="http://schemas.microsoft.com/office/drawing/2014/main" id="{B4E2FF59-E960-43C2-8500-A2D4EB135F52}"/>
               </a:ext>
             </a:extLst>
           </p:cNvPr>
@@ -14020,7 +14020,7 @@
           <p:cNvPr id="41" name="">
             <a:extLst xmlns:a="http://schemas.openxmlformats.org/drawingml/2006/main">
               <a:ext uri="{FF2B5EF4-FFF2-40B4-BE49-F238E27FC236}">
-                <a16:creationId xmlns:a16="http://schemas.microsoft.com/office/drawing/2014/main" id="{975D0987-EDEE-44DB-8FF3-4F9A64D69A52}"/>
+                <a16:creationId xmlns:a16="http://schemas.microsoft.com/office/drawing/2014/main" id="{7940086C-5D3E-4540-A733-82639BDF96EE}"/>
               </a:ext>
             </a:extLst>
           </p:cNvPr>
@@ -14073,7 +14073,7 @@
           <p:cNvPr id="43" name="">
             <a:extLst xmlns:a="http://schemas.openxmlformats.org/drawingml/2006/main">
               <a:ext uri="{FF2B5EF4-FFF2-40B4-BE49-F238E27FC236}">
-                <a16:creationId xmlns:a16="http://schemas.microsoft.com/office/drawing/2014/main" id="{F1CA5AD0-8854-4AB1-9D5C-68B1024DDC37}"/>
+                <a16:creationId xmlns:a16="http://schemas.microsoft.com/office/drawing/2014/main" id="{93CEE762-7AF5-47DE-92FA-EB070ABD826B}"/>
               </a:ext>
             </a:extLst>
           </p:cNvPr>
@@ -14108,7 +14108,7 @@
           <p:cNvPr id="44" name="">
             <a:extLst xmlns:a="http://schemas.openxmlformats.org/drawingml/2006/main">
               <a:ext uri="{FF2B5EF4-FFF2-40B4-BE49-F238E27FC236}">
-                <a16:creationId xmlns:a16="http://schemas.microsoft.com/office/drawing/2014/main" id="{070A4549-B413-40F6-BE91-93A4D346EF68}"/>
+                <a16:creationId xmlns:a16="http://schemas.microsoft.com/office/drawing/2014/main" id="{463D0F37-A19C-4528-9054-516D85356D2B}"/>
               </a:ext>
             </a:extLst>
           </p:cNvPr>
@@ -14158,7 +14158,7 @@
           <p:cNvPr id="45" name="">
             <a:extLst xmlns:a="http://schemas.openxmlformats.org/drawingml/2006/main">
               <a:ext uri="{FF2B5EF4-FFF2-40B4-BE49-F238E27FC236}">
-                <a16:creationId xmlns:a16="http://schemas.microsoft.com/office/drawing/2014/main" id="{CA4177AF-AD7D-475D-8ABE-54F4EFB3520D}"/>
+                <a16:creationId xmlns:a16="http://schemas.microsoft.com/office/drawing/2014/main" id="{79477CDE-C968-4520-B416-5510A1A65E18}"/>
               </a:ext>
             </a:extLst>
           </p:cNvPr>
@@ -14208,7 +14208,7 @@
           <p:cNvPr id="46" name="">
             <a:extLst xmlns:a="http://schemas.openxmlformats.org/drawingml/2006/main">
               <a:ext uri="{FF2B5EF4-FFF2-40B4-BE49-F238E27FC236}">
-                <a16:creationId xmlns:a16="http://schemas.microsoft.com/office/drawing/2014/main" id="{7796B9AD-A38E-4167-A4BC-D7F56F6F33D9}"/>
+                <a16:creationId xmlns:a16="http://schemas.microsoft.com/office/drawing/2014/main" id="{E03BD174-4BAD-41A4-BB12-1178A81C9DAA}"/>
               </a:ext>
             </a:extLst>
           </p:cNvPr>
@@ -14235,7 +14235,7 @@
           <p:cNvPr id="47" name="">
             <a:extLst xmlns:a="http://schemas.openxmlformats.org/drawingml/2006/main">
               <a:ext uri="{FF2B5EF4-FFF2-40B4-BE49-F238E27FC236}">
-                <a16:creationId xmlns:a16="http://schemas.microsoft.com/office/drawing/2014/main" id="{707CA400-6E7E-41B2-A56E-9A786B0365E5}"/>
+                <a16:creationId xmlns:a16="http://schemas.microsoft.com/office/drawing/2014/main" id="{102E8561-5CB3-4885-9467-FCBB5BF83499}"/>
               </a:ext>
             </a:extLst>
           </p:cNvPr>
@@ -14288,7 +14288,7 @@
           <p:cNvPr id="49" name="">
             <a:extLst xmlns:a="http://schemas.openxmlformats.org/drawingml/2006/main">
               <a:ext uri="{FF2B5EF4-FFF2-40B4-BE49-F238E27FC236}">
-                <a16:creationId xmlns:a16="http://schemas.microsoft.com/office/drawing/2014/main" id="{2CCFA547-F394-4E9D-9759-E35648920261}"/>
+                <a16:creationId xmlns:a16="http://schemas.microsoft.com/office/drawing/2014/main" id="{8722C23F-6BF2-4A4B-8A9E-D076DA25378A}"/>
               </a:ext>
             </a:extLst>
           </p:cNvPr>
@@ -14315,7 +14315,7 @@
           <p:cNvPr id="50" name="">
             <a:extLst xmlns:a="http://schemas.openxmlformats.org/drawingml/2006/main">
               <a:ext uri="{FF2B5EF4-FFF2-40B4-BE49-F238E27FC236}">
-                <a16:creationId xmlns:a16="http://schemas.microsoft.com/office/drawing/2014/main" id="{67B84A08-BBDC-4D63-B7F6-41A37E5E3D8A}"/>
+                <a16:creationId xmlns:a16="http://schemas.microsoft.com/office/drawing/2014/main" id="{C78466A3-04F8-474F-A547-0992FAB10AF5}"/>
               </a:ext>
             </a:extLst>
           </p:cNvPr>
@@ -14368,7 +14368,7 @@
           <p:cNvPr id="52" name="">
             <a:extLst xmlns:a="http://schemas.openxmlformats.org/drawingml/2006/main">
               <a:ext uri="{FF2B5EF4-FFF2-40B4-BE49-F238E27FC236}">
-                <a16:creationId xmlns:a16="http://schemas.microsoft.com/office/drawing/2014/main" id="{46CA2C38-0757-457A-B54F-04CA88429719}"/>
+                <a16:creationId xmlns:a16="http://schemas.microsoft.com/office/drawing/2014/main" id="{2D16E304-C087-412F-B4BD-DD815AEBF211}"/>
               </a:ext>
             </a:extLst>
           </p:cNvPr>
@@ -14395,7 +14395,7 @@
           <p:cNvPr id="53" name="">
             <a:extLst xmlns:a="http://schemas.openxmlformats.org/drawingml/2006/main">
               <a:ext uri="{FF2B5EF4-FFF2-40B4-BE49-F238E27FC236}">
-                <a16:creationId xmlns:a16="http://schemas.microsoft.com/office/drawing/2014/main" id="{A0DACE1A-D355-4AD6-A978-D89D31D930A0}"/>
+                <a16:creationId xmlns:a16="http://schemas.microsoft.com/office/drawing/2014/main" id="{2C02B4BE-1E26-482A-A220-70A3955AEEF5}"/>
               </a:ext>
             </a:extLst>
           </p:cNvPr>
@@ -14448,7 +14448,7 @@
           <p:cNvPr id="55" name="">
             <a:extLst xmlns:a="http://schemas.openxmlformats.org/drawingml/2006/main">
               <a:ext uri="{FF2B5EF4-FFF2-40B4-BE49-F238E27FC236}">
-                <a16:creationId xmlns:a16="http://schemas.microsoft.com/office/drawing/2014/main" id="{1BA7DD99-CB22-45CA-B43B-7041CBC3907A}"/>
+                <a16:creationId xmlns:a16="http://schemas.microsoft.com/office/drawing/2014/main" id="{EEBCBC7A-CA0E-470C-BE5A-214ACC416AAC}"/>
               </a:ext>
             </a:extLst>
           </p:cNvPr>
@@ -14475,7 +14475,7 @@
           <p:cNvPr id="56" name="">
             <a:extLst xmlns:a="http://schemas.openxmlformats.org/drawingml/2006/main">
               <a:ext uri="{FF2B5EF4-FFF2-40B4-BE49-F238E27FC236}">
-                <a16:creationId xmlns:a16="http://schemas.microsoft.com/office/drawing/2014/main" id="{AEB5E42C-4C99-4840-B4C6-34FF27200704}"/>
+                <a16:creationId xmlns:a16="http://schemas.microsoft.com/office/drawing/2014/main" id="{DA844391-2327-47CD-88FF-F91155E459A0}"/>
               </a:ext>
             </a:extLst>
           </p:cNvPr>
@@ -14528,7 +14528,7 @@
           <p:cNvPr id="58" name="">
             <a:extLst xmlns:a="http://schemas.openxmlformats.org/drawingml/2006/main">
               <a:ext uri="{FF2B5EF4-FFF2-40B4-BE49-F238E27FC236}">
-                <a16:creationId xmlns:a16="http://schemas.microsoft.com/office/drawing/2014/main" id="{52114310-2168-4815-A7C1-90AED2028C7A}"/>
+                <a16:creationId xmlns:a16="http://schemas.microsoft.com/office/drawing/2014/main" id="{ADA5C449-04FB-4DD5-9482-ACF97716EEC3}"/>
               </a:ext>
             </a:extLst>
           </p:cNvPr>
@@ -14563,7 +14563,7 @@
           <p:cNvPr id="59" name="">
             <a:extLst xmlns:a="http://schemas.openxmlformats.org/drawingml/2006/main">
               <a:ext uri="{FF2B5EF4-FFF2-40B4-BE49-F238E27FC236}">
-                <a16:creationId xmlns:a16="http://schemas.microsoft.com/office/drawing/2014/main" id="{8121E070-4045-4798-A938-B20F8DC750EF}"/>
+                <a16:creationId xmlns:a16="http://schemas.microsoft.com/office/drawing/2014/main" id="{AE05F59E-1BA6-49BE-92D5-4284AFACD056}"/>
               </a:ext>
             </a:extLst>
           </p:cNvPr>
@@ -14613,7 +14613,7 @@
           <p:cNvPr id="60" name="">
             <a:extLst xmlns:a="http://schemas.openxmlformats.org/drawingml/2006/main">
               <a:ext uri="{FF2B5EF4-FFF2-40B4-BE49-F238E27FC236}">
-                <a16:creationId xmlns:a16="http://schemas.microsoft.com/office/drawing/2014/main" id="{D7117EB9-2D42-45E2-90CA-17049DEF8BE6}"/>
+                <a16:creationId xmlns:a16="http://schemas.microsoft.com/office/drawing/2014/main" id="{11B0089E-DCE5-4703-966A-E131714D921D}"/>
               </a:ext>
             </a:extLst>
           </p:cNvPr>
@@ -14661,7 +14661,7 @@
     </p:spTree>
     <p:extLst>
       <p:ext uri="{BB962C8B-B14F-4D97-AF65-F5344CB8AC3E}">
-        <p14:creationId xmlns:p14="http://schemas.microsoft.com/office/powerpoint/2010/main" val="599148704"/>
+        <p14:creationId xmlns:p14="http://schemas.microsoft.com/office/powerpoint/2010/main" val="745810663"/>
       </p:ext>
     </p:extLst>
   </p:cSld>
@@ -14692,7 +14692,7 @@
           <p:cNvPr id="29" name="">
             <a:extLst xmlns:a="http://schemas.openxmlformats.org/drawingml/2006/main">
               <a:ext uri="{FF2B5EF4-FFF2-40B4-BE49-F238E27FC236}">
-                <a16:creationId xmlns:a16="http://schemas.microsoft.com/office/drawing/2014/main" id="{C7289858-1D77-4180-86E2-1F2E9A1E61AA}"/>
+                <a16:creationId xmlns:a16="http://schemas.microsoft.com/office/drawing/2014/main" id="{A4EB82F0-0938-45FA-BE01-63762CC3A1FC}"/>
               </a:ext>
             </a:extLst>
           </p:cNvPr>
@@ -14725,7 +14725,7 @@
           <p:cNvPr id="2" name="">
             <a:extLst xmlns:a="http://schemas.openxmlformats.org/drawingml/2006/main">
               <a:ext uri="{FF2B5EF4-FFF2-40B4-BE49-F238E27FC236}">
-                <a16:creationId xmlns:a16="http://schemas.microsoft.com/office/drawing/2014/main" id="{3E7C8C93-B9B3-4DEA-B020-FE1D07FCDA7E}"/>
+                <a16:creationId xmlns:a16="http://schemas.microsoft.com/office/drawing/2014/main" id="{713300C8-7B38-4159-B375-A55A216B58CE}"/>
               </a:ext>
             </a:extLst>
           </p:cNvPr>
@@ -14758,7 +14758,7 @@
           <p:cNvPr id="3" name="">
             <a:extLst xmlns:a="http://schemas.openxmlformats.org/drawingml/2006/main">
               <a:ext uri="{FF2B5EF4-FFF2-40B4-BE49-F238E27FC236}">
-                <a16:creationId xmlns:a16="http://schemas.microsoft.com/office/drawing/2014/main" id="{CD37D1A3-EE5E-44F7-B236-40C0F2C286FC}"/>
+                <a16:creationId xmlns:a16="http://schemas.microsoft.com/office/drawing/2014/main" id="{85697F43-3085-4C37-BF84-B3072CD48F5B}"/>
               </a:ext>
             </a:extLst>
           </p:cNvPr>
@@ -14808,7 +14808,7 @@
           <p:cNvPr id="4" name="">
             <a:extLst xmlns:a="http://schemas.openxmlformats.org/drawingml/2006/main">
               <a:ext uri="{FF2B5EF4-FFF2-40B4-BE49-F238E27FC236}">
-                <a16:creationId xmlns:a16="http://schemas.microsoft.com/office/drawing/2014/main" id="{A01286C7-23FE-4103-AE6B-4BFFB9C96C07}"/>
+                <a16:creationId xmlns:a16="http://schemas.microsoft.com/office/drawing/2014/main" id="{3C15CB12-BA2E-46D9-B1D0-BBD7295347A3}"/>
               </a:ext>
             </a:extLst>
           </p:cNvPr>
@@ -14858,7 +14858,7 @@
           <p:cNvPr id="5" name="">
             <a:extLst xmlns:a="http://schemas.openxmlformats.org/drawingml/2006/main">
               <a:ext uri="{FF2B5EF4-FFF2-40B4-BE49-F238E27FC236}">
-                <a16:creationId xmlns:a16="http://schemas.microsoft.com/office/drawing/2014/main" id="{85906F33-1967-4161-BEFD-395330464344}"/>
+                <a16:creationId xmlns:a16="http://schemas.microsoft.com/office/drawing/2014/main" id="{57D095E0-1906-4688-9F62-F6E4BB85FD0D}"/>
               </a:ext>
             </a:extLst>
           </p:cNvPr>
@@ -14912,7 +14912,7 @@
           <p:nvPr/>
         </p:nvPicPr>
         <p:blipFill>
-          <a:blip xmlns:r="http://schemas.openxmlformats.org/officeDocument/2006/relationships" xmlns:a="http://schemas.openxmlformats.org/drawingml/2006/main" r:embed="R184fc130c60d4e26"/>
+          <a:blip xmlns:r="http://schemas.openxmlformats.org/officeDocument/2006/relationships" xmlns:a="http://schemas.openxmlformats.org/drawingml/2006/main" r:embed="R86aae6e9b5a14982"/>
           <a:stretch xmlns:a="http://schemas.openxmlformats.org/drawingml/2006/main"/>
         </p:blipFill>
         <p:spPr>
@@ -14930,7 +14930,7 @@
           <p:cNvPr id="7" name="">
             <a:extLst xmlns:a="http://schemas.openxmlformats.org/drawingml/2006/main">
               <a:ext uri="{FF2B5EF4-FFF2-40B4-BE49-F238E27FC236}">
-                <a16:creationId xmlns:a16="http://schemas.microsoft.com/office/drawing/2014/main" id="{0279AE0B-3691-4085-98B1-0D2B41819097}"/>
+                <a16:creationId xmlns:a16="http://schemas.microsoft.com/office/drawing/2014/main" id="{1403ED48-2298-4460-A17A-4EAC0B525F58}"/>
               </a:ext>
             </a:extLst>
           </p:cNvPr>
@@ -14963,7 +14963,7 @@
           <p:cNvPr id="8" name="">
             <a:extLst xmlns:a="http://schemas.openxmlformats.org/drawingml/2006/main">
               <a:ext uri="{FF2B5EF4-FFF2-40B4-BE49-F238E27FC236}">
-                <a16:creationId xmlns:a16="http://schemas.microsoft.com/office/drawing/2014/main" id="{380E3A24-3AA0-4564-96CF-C4FB612EF969}"/>
+                <a16:creationId xmlns:a16="http://schemas.microsoft.com/office/drawing/2014/main" id="{F44B5EE0-55E7-4CBD-BB96-79D1AAF2CFF0}"/>
               </a:ext>
             </a:extLst>
           </p:cNvPr>
@@ -15013,7 +15013,7 @@
           <p:cNvPr id="9" name="">
             <a:extLst xmlns:a="http://schemas.openxmlformats.org/drawingml/2006/main">
               <a:ext uri="{FF2B5EF4-FFF2-40B4-BE49-F238E27FC236}">
-                <a16:creationId xmlns:a16="http://schemas.microsoft.com/office/drawing/2014/main" id="{C819EEB7-44E2-4039-B785-E2D43856D025}"/>
+                <a16:creationId xmlns:a16="http://schemas.microsoft.com/office/drawing/2014/main" id="{7C2E4799-5521-48C6-AB95-D89107FAEC2B}"/>
               </a:ext>
             </a:extLst>
           </p:cNvPr>
@@ -15063,7 +15063,7 @@
           <p:cNvPr id="10" name="">
             <a:extLst xmlns:a="http://schemas.openxmlformats.org/drawingml/2006/main">
               <a:ext uri="{FF2B5EF4-FFF2-40B4-BE49-F238E27FC236}">
-                <a16:creationId xmlns:a16="http://schemas.microsoft.com/office/drawing/2014/main" id="{CB675258-FD3A-4994-A909-E4CE6733D776}"/>
+                <a16:creationId xmlns:a16="http://schemas.microsoft.com/office/drawing/2014/main" id="{8DA4BF84-F04B-4B61-8741-A517EC308E8A}"/>
               </a:ext>
             </a:extLst>
           </p:cNvPr>
@@ -15098,7 +15098,7 @@
           <p:cNvPr id="11" name="">
             <a:extLst xmlns:a="http://schemas.openxmlformats.org/drawingml/2006/main">
               <a:ext uri="{FF2B5EF4-FFF2-40B4-BE49-F238E27FC236}">
-                <a16:creationId xmlns:a16="http://schemas.microsoft.com/office/drawing/2014/main" id="{0D7A201B-BC3B-447D-A8DE-D572C9355048}"/>
+                <a16:creationId xmlns:a16="http://schemas.microsoft.com/office/drawing/2014/main" id="{564ACE7A-CEC6-4C66-A342-50FCD95E841E}"/>
               </a:ext>
             </a:extLst>
           </p:cNvPr>
@@ -15131,7 +15131,7 @@
           <p:cNvPr id="12" name="">
             <a:extLst xmlns:a="http://schemas.openxmlformats.org/drawingml/2006/main">
               <a:ext uri="{FF2B5EF4-FFF2-40B4-BE49-F238E27FC236}">
-                <a16:creationId xmlns:a16="http://schemas.microsoft.com/office/drawing/2014/main" id="{43F3C727-CE5E-49CE-9689-64CBCFB39C65}"/>
+                <a16:creationId xmlns:a16="http://schemas.microsoft.com/office/drawing/2014/main" id="{89B7709D-8123-4CC0-831F-F70C576DEA7C}"/>
               </a:ext>
             </a:extLst>
           </p:cNvPr>
@@ -15181,7 +15181,7 @@
           <p:cNvPr id="13" name="">
             <a:extLst xmlns:a="http://schemas.openxmlformats.org/drawingml/2006/main">
               <a:ext uri="{FF2B5EF4-FFF2-40B4-BE49-F238E27FC236}">
-                <a16:creationId xmlns:a16="http://schemas.microsoft.com/office/drawing/2014/main" id="{574407A3-6E2E-4A44-9EB3-5F6E9A7D571C}"/>
+                <a16:creationId xmlns:a16="http://schemas.microsoft.com/office/drawing/2014/main" id="{665A3C3E-7E09-46F3-B1D2-337417B6459A}"/>
               </a:ext>
             </a:extLst>
           </p:cNvPr>
@@ -15282,7 +15282,7 @@
           <p:cNvPr id="14" name="">
             <a:extLst xmlns:a="http://schemas.openxmlformats.org/drawingml/2006/main">
               <a:ext uri="{FF2B5EF4-FFF2-40B4-BE49-F238E27FC236}">
-                <a16:creationId xmlns:a16="http://schemas.microsoft.com/office/drawing/2014/main" id="{716D836F-F471-41B7-8333-162A65145901}"/>
+                <a16:creationId xmlns:a16="http://schemas.microsoft.com/office/drawing/2014/main" id="{16BBA13F-96B8-4509-89F2-E691C570A84E}"/>
               </a:ext>
             </a:extLst>
           </p:cNvPr>
@@ -15317,7 +15317,7 @@
           <p:cNvPr id="15" name="">
             <a:extLst xmlns:a="http://schemas.openxmlformats.org/drawingml/2006/main">
               <a:ext uri="{FF2B5EF4-FFF2-40B4-BE49-F238E27FC236}">
-                <a16:creationId xmlns:a16="http://schemas.microsoft.com/office/drawing/2014/main" id="{BF24B103-BBBD-449C-B4AE-ED8D154D7521}"/>
+                <a16:creationId xmlns:a16="http://schemas.microsoft.com/office/drawing/2014/main" id="{4164A672-D810-451E-B0B6-8AB9AD7E1BB0}"/>
               </a:ext>
             </a:extLst>
           </p:cNvPr>
@@ -15350,7 +15350,7 @@
           <p:cNvPr id="16" name="">
             <a:extLst xmlns:a="http://schemas.openxmlformats.org/drawingml/2006/main">
               <a:ext uri="{FF2B5EF4-FFF2-40B4-BE49-F238E27FC236}">
-                <a16:creationId xmlns:a16="http://schemas.microsoft.com/office/drawing/2014/main" id="{1EFDB91E-8216-4555-A9BF-CD9D7D9263CD}"/>
+                <a16:creationId xmlns:a16="http://schemas.microsoft.com/office/drawing/2014/main" id="{A8E3EBE6-89CA-49A6-86C9-31D1AD4ECB19}"/>
               </a:ext>
             </a:extLst>
           </p:cNvPr>
@@ -15400,7 +15400,7 @@
           <p:cNvPr id="17" name="">
             <a:extLst xmlns:a="http://schemas.openxmlformats.org/drawingml/2006/main">
               <a:ext uri="{FF2B5EF4-FFF2-40B4-BE49-F238E27FC236}">
-                <a16:creationId xmlns:a16="http://schemas.microsoft.com/office/drawing/2014/main" id="{45D6797E-3458-4D87-AE12-5E1264BF87F5}"/>
+                <a16:creationId xmlns:a16="http://schemas.microsoft.com/office/drawing/2014/main" id="{CF6F0A8B-5319-4B31-A88F-EB4B4E10DE11}"/>
               </a:ext>
             </a:extLst>
           </p:cNvPr>
@@ -15501,7 +15501,7 @@
           <p:cNvPr id="18" name="">
             <a:extLst xmlns:a="http://schemas.openxmlformats.org/drawingml/2006/main">
               <a:ext uri="{FF2B5EF4-FFF2-40B4-BE49-F238E27FC236}">
-                <a16:creationId xmlns:a16="http://schemas.microsoft.com/office/drawing/2014/main" id="{FEB0DCDD-665A-4B92-B19B-405D66F2A991}"/>
+                <a16:creationId xmlns:a16="http://schemas.microsoft.com/office/drawing/2014/main" id="{89E72596-FC3E-4E09-A277-CB87266BCF58}"/>
               </a:ext>
             </a:extLst>
           </p:cNvPr>
@@ -15536,7 +15536,7 @@
           <p:cNvPr id="19" name="">
             <a:extLst xmlns:a="http://schemas.openxmlformats.org/drawingml/2006/main">
               <a:ext uri="{FF2B5EF4-FFF2-40B4-BE49-F238E27FC236}">
-                <a16:creationId xmlns:a16="http://schemas.microsoft.com/office/drawing/2014/main" id="{5C79EE3D-FE70-4382-9685-8594D930A0F5}"/>
+                <a16:creationId xmlns:a16="http://schemas.microsoft.com/office/drawing/2014/main" id="{54D4F722-A259-4F6E-B85D-CD2A7BB392A5}"/>
               </a:ext>
             </a:extLst>
           </p:cNvPr>
@@ -15569,7 +15569,7 @@
           <p:cNvPr id="20" name="">
             <a:extLst xmlns:a="http://schemas.openxmlformats.org/drawingml/2006/main">
               <a:ext uri="{FF2B5EF4-FFF2-40B4-BE49-F238E27FC236}">
-                <a16:creationId xmlns:a16="http://schemas.microsoft.com/office/drawing/2014/main" id="{F3E86B87-EAC8-4D40-81A4-30D6DCB70C22}"/>
+                <a16:creationId xmlns:a16="http://schemas.microsoft.com/office/drawing/2014/main" id="{94FBB462-90B1-4A6C-B165-E6F38B139A7A}"/>
               </a:ext>
             </a:extLst>
           </p:cNvPr>
@@ -15623,10 +15623,10 @@
           <p:nvPr/>
         </p:nvPicPr>
         <p:blipFill>
-          <a:blip xmlns:r="http://schemas.openxmlformats.org/officeDocument/2006/relationships" xmlns:a="http://schemas.openxmlformats.org/drawingml/2006/main" r:embed="R0a35070b8bc94e15">
+          <a:blip xmlns:r="http://schemas.openxmlformats.org/officeDocument/2006/relationships" xmlns:a="http://schemas.openxmlformats.org/drawingml/2006/main" r:embed="R12d351cab94f4dc6">
             <a:extLst>
               <a:ext uri="{96DAC541-7B7A-43D3-8B79-37D633B846F1}">
-                <asvg:svgBlip xmlns:asvg="http://schemas.microsoft.com/office/drawing/2016/SVG/main" r:embed="R615975a779ce4152"/>
+                <asvg:svgBlip xmlns:asvg="http://schemas.microsoft.com/office/drawing/2016/SVG/main" r:embed="R0c37820f54a54c15"/>
               </a:ext>
             </a:extLst>
           </a:blip>
@@ -15647,7 +15647,7 @@
           <p:cNvPr id="22" name="">
             <a:extLst xmlns:a="http://schemas.openxmlformats.org/drawingml/2006/main">
               <a:ext uri="{FF2B5EF4-FFF2-40B4-BE49-F238E27FC236}">
-                <a16:creationId xmlns:a16="http://schemas.microsoft.com/office/drawing/2014/main" id="{32705564-2B46-4428-A7FC-B3A6A71EA92F}"/>
+                <a16:creationId xmlns:a16="http://schemas.microsoft.com/office/drawing/2014/main" id="{F59F8DC6-E548-418C-ADFD-9DB60B04773D}"/>
               </a:ext>
             </a:extLst>
           </p:cNvPr>
@@ -15682,7 +15682,7 @@
           <p:cNvPr id="23" name="">
             <a:extLst xmlns:a="http://schemas.openxmlformats.org/drawingml/2006/main">
               <a:ext uri="{FF2B5EF4-FFF2-40B4-BE49-F238E27FC236}">
-                <a16:creationId xmlns:a16="http://schemas.microsoft.com/office/drawing/2014/main" id="{1C386BE2-E4E3-4403-A40F-F13978FE6DA3}"/>
+                <a16:creationId xmlns:a16="http://schemas.microsoft.com/office/drawing/2014/main" id="{01E5A377-CE82-44C1-BC93-74BA2F29B8B8}"/>
               </a:ext>
             </a:extLst>
           </p:cNvPr>
@@ -15732,7 +15732,7 @@
           <p:cNvPr id="24" name="">
             <a:extLst xmlns:a="http://schemas.openxmlformats.org/drawingml/2006/main">
               <a:ext uri="{FF2B5EF4-FFF2-40B4-BE49-F238E27FC236}">
-                <a16:creationId xmlns:a16="http://schemas.microsoft.com/office/drawing/2014/main" id="{E0116CCA-C503-4ED7-AD5D-F307B3AB4131}"/>
+                <a16:creationId xmlns:a16="http://schemas.microsoft.com/office/drawing/2014/main" id="{34B5F169-F8FB-4B04-85DF-C9D8DC40E99D}"/>
               </a:ext>
             </a:extLst>
           </p:cNvPr>
@@ -15782,7 +15782,7 @@
           <p:cNvPr id="25" name="">
             <a:extLst xmlns:a="http://schemas.openxmlformats.org/drawingml/2006/main">
               <a:ext uri="{FF2B5EF4-FFF2-40B4-BE49-F238E27FC236}">
-                <a16:creationId xmlns:a16="http://schemas.microsoft.com/office/drawing/2014/main" id="{0A9F12AA-7076-4393-9CEE-8E182C6852E4}"/>
+                <a16:creationId xmlns:a16="http://schemas.microsoft.com/office/drawing/2014/main" id="{1A7791BA-DD61-4D0E-87F8-6A552FCEDA6F}"/>
               </a:ext>
             </a:extLst>
           </p:cNvPr>
@@ -15817,7 +15817,7 @@
           <p:cNvPr id="26" name="">
             <a:extLst xmlns:a="http://schemas.openxmlformats.org/drawingml/2006/main">
               <a:ext uri="{FF2B5EF4-FFF2-40B4-BE49-F238E27FC236}">
-                <a16:creationId xmlns:a16="http://schemas.microsoft.com/office/drawing/2014/main" id="{CF1FF621-9B2A-446B-9A69-8A623B665177}"/>
+                <a16:creationId xmlns:a16="http://schemas.microsoft.com/office/drawing/2014/main" id="{F18D773E-BE16-4561-8CB5-8114C881A22C}"/>
               </a:ext>
             </a:extLst>
           </p:cNvPr>
@@ -15867,7 +15867,7 @@
           <p:cNvPr id="27" name="">
             <a:extLst xmlns:a="http://schemas.openxmlformats.org/drawingml/2006/main">
               <a:ext uri="{FF2B5EF4-FFF2-40B4-BE49-F238E27FC236}">
-                <a16:creationId xmlns:a16="http://schemas.microsoft.com/office/drawing/2014/main" id="{58EEE1E4-D44E-4A32-8CF2-649C7979E656}"/>
+                <a16:creationId xmlns:a16="http://schemas.microsoft.com/office/drawing/2014/main" id="{C3AFD1AF-EE87-475C-A967-9C00F23339FE}"/>
               </a:ext>
             </a:extLst>
           </p:cNvPr>
@@ -15917,7 +15917,7 @@
           <p:cNvPr id="28" name="">
             <a:extLst xmlns:a="http://schemas.openxmlformats.org/drawingml/2006/main">
               <a:ext uri="{FF2B5EF4-FFF2-40B4-BE49-F238E27FC236}">
-                <a16:creationId xmlns:a16="http://schemas.microsoft.com/office/drawing/2014/main" id="{DBE092C8-BD9F-4026-A503-55884045703D}"/>
+                <a16:creationId xmlns:a16="http://schemas.microsoft.com/office/drawing/2014/main" id="{F0361A0B-E020-4AB8-BD5B-1651584A5DDF}"/>
               </a:ext>
             </a:extLst>
           </p:cNvPr>
@@ -15965,7 +15965,7 @@
     </p:spTree>
     <p:extLst>
       <p:ext uri="{BB962C8B-B14F-4D97-AF65-F5344CB8AC3E}">
-        <p14:creationId xmlns:p14="http://schemas.microsoft.com/office/powerpoint/2010/main" val="589513957"/>
+        <p14:creationId xmlns:p14="http://schemas.microsoft.com/office/powerpoint/2010/main" val="1809045520"/>
       </p:ext>
     </p:extLst>
   </p:cSld>

</xml_diff>